<commit_message>
feat(presentation): reduce text on slides, add image/video placeholder frames, and add dedicated 10-minute speech script
</commit_message>
<xml_diff>
--- a/frontend/presentation/Prezentacja_IDUB_Neuro_Curiosity_AGH.pptx
+++ b/frontend/presentation/Prezentacja_IDUB_Neuro_Curiosity_AGH.pptx
@@ -763,7 +763,7 @@
               </a:defRPr>
             </a:pPr>
             <a:r>
-              <a:t>🎯 CEL SLAJDU: Przedstawienie tematu, jednostki, zespołu SKN Sensor oraz osadzenia projektu w IDUB D12 / POB 6.</a:t>
+              <a:t>🎯 CEL SLAJDU: Wprowadzenie, przywitanie komisji, osadzenie w IDUB D12 / POB 6 i przedstawienie zespołu.</a:t>
             </a:r>
           </a:p>
           <a:p>
@@ -779,7 +779,7 @@
               </a:defRPr>
             </a:pPr>
             <a:r>
-              <a:t>📝 SKRYPT WYPOWIEDZI PRELEGENCI:</a:t>
+              <a:t>📝 SKRYPT PRELEGENCI (MÓW TO):</a:t>
             </a:r>
           </a:p>
           <a:p>
@@ -795,7 +795,7 @@
               </a:defRPr>
             </a:pPr>
             <a:r>
-              <a:t>Dzień dobry Państwu. Nazywam się Patryk Pięta i w imieniu Koła Naukowego SENSOR działającego przy Wydziale Inżynierii Mechanicznej i Robotyki oraz Wydziale Odlewnictwa AGH, mam zaszczyt przedstawić projekt badawczy pt. «Algorytm Neuro-Curiosity do optymalizacji strategii sterowania pojazdów autonomicznych». Projekt realizujemy pod opieką naukową dr. hab. inż. Krzysztofa Lalika w ramach grantu IDUB D12 z wpisaniem w Priorytetowy Obszar Badawczy POB 6. Nasz projekt łączy zaawansowane metody sztucznej inteligencji, brzegowe przetwarzanie Edge AI oraz platformę Cyfrowego Bliźniaka do sterowania pojazdami autonomicznymi w inteligentnych fabrykach Przemysłu 4.0.</a:t>
+              <a:t>Dzień dobry Państwu. Nazywam się Patryk Pięta i w imieniu Koła Naukowego SENSOR mam zaszczyt przedstawić projekt pt. «Algorytm Neuro-Curiosity do optymalizacji strategii sterowania pojazdów autonomicznych». Projekt realizujemy pod opieką naukową profesora Krzysztofa Lalika w ramach grantu IDUB D12 w obszarze POB 6. Projekt integruje sztuczną inteligencję, przetwarzanie brzegowe oraz platformę Cyfrowego Bliźniaka do sterowania pojazdami w fabrykach Przemysłu 4.0.</a:t>
             </a:r>
           </a:p>
         </p:txBody>
@@ -880,7 +880,7 @@
               </a:defRPr>
             </a:pPr>
             <a:r>
-              <a:t>🎯 CEL SLAJDU: Wskazanie barier klasycznego Reinforcement Learning w intralogistyce: rzadkie nagrody, wielowymiarowość i ryzyko kolizji.</a:t>
+              <a:t>🎯 CEL SLAJDU: Wyjaśnienie 3 barier klasycznego RL: brak nagród w pustej hali, szum sensoryczny oraz ryzyko zniszczenia pojazdu.</a:t>
             </a:r>
           </a:p>
           <a:p>
@@ -896,7 +896,7 @@
               </a:defRPr>
             </a:pPr>
             <a:r>
-              <a:t>📝 SKRYPT WYPOWIEDZI PRELEGENCI:</a:t>
+              <a:t>📝 SKRYPT PRELEGENCI (MÓW TO):</a:t>
             </a:r>
           </a:p>
           <a:p>
@@ -912,7 +912,7 @@
               </a:defRPr>
             </a:pPr>
             <a:r>
-              <a:t>Przejdźmy do problemu badawczego. Nowoczesna intralogistyka wymaga wdrażania autonomicznych wózków AGV i robotów AMR w dynamicznych środowiskach magazynowych. Chcąc zoptymalizować sterowanie za pomocą uczenia ze wzmocnieniem, napotykamy na trzy kluczowe bariery. Po pierwsze: rzadkie nagrody – w dużej hali pojazd nie wie, czy jedzie dobrze, dopóki przypadkowo nie dotrze do celu. Po drugie: klątwa wielowymiarowości chmur punktów LiDAR – agent gubi się w szumie informacyjnym. Po trzecie: eksploracja losowa epsilon-greedy w świecie rzeczywistym grozi kolizjami ze sprzętem i gwałtownym szarpaniem napędów. Nasz projekt rozwiązuje te problemy u źródła.</a:t>
+              <a:t>Współczesna intralogistyka potrzebuje autonomicznych wózków AGV. Jednak klasyczne uczenie ze wzmocnieniem ma trzy fundamentalne wady. Po pierwsze: rzadkie nagrody – w pustej hali wózek błądzi losowo, bo nie ma żadnej nagrody dopóki przypadkowo nie trafi do celu. Po drugie: klątwa wielowymiarowości – chmury punktów z LiDAR-a gubią sieć neuronową w szumie. Po trzecie: eksploracja losowa w fabryce oznacza natychmiastowe kolizje i niszczenie przekładni przez szarpnięcia. Dlatego musieliśmy zmienić paradygmat sterowania.</a:t>
             </a:r>
           </a:p>
         </p:txBody>
@@ -997,7 +997,7 @@
               </a:defRPr>
             </a:pPr>
             <a:r>
-              <a:t>🎯 CEL SLAJDU: Wyjaśnienie mechanizmu ICM (Forward i Inverse Model) oraz wewnętrznej motywacji w sterowaniu pojazdem AGV.</a:t>
+              <a:t>🎯 CEL SLAJDU: Prezentacja mechanizmu ICM: nagroda wewnętrzna z błędu predykcji oraz ignorowanie nieistotnego szumu tła.</a:t>
             </a:r>
           </a:p>
           <a:p>
@@ -1013,7 +1013,7 @@
               </a:defRPr>
             </a:pPr>
             <a:r>
-              <a:t>📝 SKRYPT WYPOWIEDZI PRELEGENCI:</a:t>
+              <a:t>📝 SKRYPT PRELEGENCI (MÓW TO):</a:t>
             </a:r>
           </a:p>
           <a:p>
@@ -1029,7 +1029,7 @@
               </a:defRPr>
             </a:pPr>
             <a:r>
-              <a:t>Kluczową innowacją naszego projektu jest algorytm Neuro-Curiosity oparty na Intrinsic Curiosity Module. Zamiast czekać na rzadką nagrodę zewnętrzną lub błądzić losowo, agent uczy się na bazie wewnętrznego błędu predykcji. Model dynamiki w przód stara się przewidzieć, jak zmieni się odczyt sensorów po wykonaniu ruchu. Jeżeli stan jest dla pojazdu zaskakujący – pojawia się wewnętrzna nagroda motywująca do jego zbadania. Równocześnie moduł odwrotny (Inverse Model) eliminuje problem szumu tła, ignorując elementy, na które agent nie ma wpływu. Dzięki temu pojazd autonomiczny aktywnie i bezpiecznie eksploruje przestrzeń fabryczną.</a:t>
+              <a:t>Naszą odpowiedzią jest algorytm Neuro-Curiosity oparty na Intrinsic Curiosity Module. Zamiast czekać na rzadką nagrodę zewnętrzną, wózek jest motywowany ciekawością – dąży do zbadania stanów, których jeszcze nie zna. Model dynamiki w przód przewiduje kolejny odczyt sensorów. Jeśli sytuacja zaskakuje robota – generowana jest nagroda wewnętrzna. Z kolei moduł odwrotny eliminuje szum tła, dzięki czemu wózek nie zatrzymuje się na migających światłach czy nieistotnych detalach hali. Wynik to celowa, bezpieczna i szybka eksploracja.</a:t>
             </a:r>
           </a:p>
         </p:txBody>
@@ -1114,7 +1114,7 @@
               </a:defRPr>
             </a:pPr>
             <a:r>
-              <a:t>🎯 CEL SLAJDU: Prezentacja metodologii Sim-to-Real: od symulacji w NVIDIA Isaac Sim przez Domain Randomization do transferu Zero-Shot.</a:t>
+              <a:t>🎯 CEL SLAJDU: Wyjaśnienie metodyki Sim-to-Real: jak z wirtualnego symulatora przenieść sieć bezpośrednio na fizyczny robot.</a:t>
             </a:r>
           </a:p>
           <a:p>
@@ -1130,7 +1130,7 @@
               </a:defRPr>
             </a:pPr>
             <a:r>
-              <a:t>📝 SKRYPT WYPOWIEDZI PRELEGENCI:</a:t>
+              <a:t>📝 SKRYPT PRELEGENCI (MÓW TO):</a:t>
             </a:r>
           </a:p>
           <a:p>
@@ -1146,7 +1146,7 @@
               </a:defRPr>
             </a:pPr>
             <a:r>
-              <a:t>Aby bezpiecznie przenieść inteligencję z komputera na fizyczny pojazd, stosujemy metodologię Sim-to-Real. W pierwszym kroku trenujemy agenta w symulatorze NVIDIA Isaac Sim z pełną fizyką i emulacją LiDAR-a. Aby uniknąć tzw. Reality Gap – czyli rozbieżności między wirtualnym światem a halą przemysłową – stosujemy Domain Randomization. Losowo zmieniamy współczynniki tarcia posadzki, masy ładunków i opóźnienia sieciowe. W efekcie sieć neuronowa staje się tak odporna, że w trzecim kroku realizujemy transfer Zero-Shot – bezpośrednie wdrożenie na platformę pokładową NVIDIA Jetson Orin NX bez ryzyka uszkodzenia sprzętu.</a:t>
+              <a:t>Żeby nie niszczyć wózków podczas treningu, stosujemy trzystopniowy transfer Sim-to-Real. Najpierw uczymy agenta w symulatorze NVIDIA Isaac Sim z dokładną fizyką i promieniami LiDAR. Następnie stosujemy Domain Randomization – celowo rozstrajamy symulator, zmieniając tarcie posadzki, masy ładunku i opóźnienia magistrali. Dzięki temu sieć staje się niewrażliwa na różnice świata realnego. Krok trzeci to Zero-Shot Transfer – skompilowany model TensorRT uruchamiamy od razu na pokładzie wózka bez konieczności niebezpiecznych prób na żywej fabryce.</a:t>
             </a:r>
           </a:p>
         </p:txBody>
@@ -1215,7 +1215,7 @@
               </a:defRPr>
             </a:pPr>
             <a:r>
-              <a:t>⏱ CZAS: 4:15 - 5:45 (90 sekund) - KLUCZOWY PUNKT WIZUALNY!</a:t>
+              <a:t>⏱ CZAS: 4:15 - 5:45 (90 sekund) - NAJWAŻNIEJSZY SLAJD POKAZOWY!</a:t>
             </a:r>
           </a:p>
           <a:p>
@@ -1231,7 +1231,7 @@
               </a:defRPr>
             </a:pPr>
             <a:r>
-              <a:t>🎯 CEL SLAJDU: Demonstracja działającego stanowiska Cyfrowego Bliźniaka (zrzut ekranu), roli Patryka Pięty i architektury IIoT (Kafka, TimescaleDB, Spark, Jetson).</a:t>
+              <a:t>🎯 CEL SLAJDU: Demonstracja działającego Cyfrowego Bliźniaka (wkład inżynierski Patryka Pięty), architektury Edge AI i telemetrii IIoT.</a:t>
             </a:r>
           </a:p>
           <a:p>
@@ -1247,7 +1247,7 @@
               </a:defRPr>
             </a:pPr>
             <a:r>
-              <a:t>📝 SKRYPT WYPOWIEDZI PRELEGENCI:</a:t>
+              <a:t>📝 SKRYPT PRELEGENCI (MÓW TO):</a:t>
             </a:r>
           </a:p>
           <a:p>
@@ -1263,7 +1263,7 @@
               </a:defRPr>
             </a:pPr>
             <a:r>
-              <a:t>Na tym slajdzie widzą Państwo kluczowy element demonstracyjny projektu – działający Cyfrowy Bliźniak floty AGV, stanowiący fundament mojej pracy inżynierskiej na Wydziale Odlewnictwa realizowanej we współpracy z SKN Sensor. Po lewej stronie widzimy trójwymiarową arenę 100x100 metrów stworzoną w Three.js, gdzie na żywo porównujemy pojazd AGV-01 sterowany algorytmem Neuro-Curiosity z pojazdem referencyjnym. Po prawej stronie przedstawiono architekturę Edge IIoT: jednostkę brzegową NVIDIA Jetson Orin NX podejmującą decyzje w czasie poniżej 15 ms, brokera Apache Kafka oraz bazę TimescaleDB i analitykę Spark Streaming. Platforma ta pozwala weryfikować zachowanie algorytmów zanim trafią na fizyczną posadzkę fabryczną.</a:t>
+              <a:t>Na tym slajdzie widzimy działający prototyp Cyfrowego Bliźniaka, który opracowałem w ramach mojej pracy inżynierskiej we współpracy z zespołem Sensor. Po lewej stronie widać aplikację 3D w Three.js – arena 100x100 metrów, po której poruszają się wózki AGV. Pojazd AGV-01 sterowany jest naszym algorytmem Neuro-Curiosity, a AGV-02 klasyczną metodą bazową. Decyzje sterujące podejmuje komputer brzegowy NVIDIA Jetson Orin NX w czasie poniżej 15 milisekund. Cała telemetria – pozycje, LiDAR, przeciążenia – trafia przez Apache Kafka do TimescaleDB. To gotowa platforma do weryfikacji algorytmów przed ich wdrożeniem.</a:t>
             </a:r>
           </a:p>
         </p:txBody>
@@ -1348,7 +1348,7 @@
               </a:defRPr>
             </a:pPr>
             <a:r>
-              <a:t>🎯 CEL SLAJDU: Prezentacja metryk ewaluacyjnych (droga bezkolizyjna, Jerk, konwergencja) oraz rygoru statystycznego (Test Friedmana i Nemenyiego).</a:t>
+              <a:t>🎯 CEL SLAJDU: Prezentacja metryk (droga bezkolizyjna, Jerk, konwergencja) oraz rygoru statystycznego wymaganego przez IDUB.</a:t>
             </a:r>
           </a:p>
           <a:p>
@@ -1364,7 +1364,7 @@
               </a:defRPr>
             </a:pPr>
             <a:r>
-              <a:t>📝 SKRYPT WYPOWIEDZI PRELEGENCI:</a:t>
+              <a:t>📝 SKRYPT PRELEGENCI (MÓW TO):</a:t>
             </a:r>
           </a:p>
           <a:p>
@@ -1380,7 +1380,7 @@
               </a:defRPr>
             </a:pPr>
             <a:r>
-              <a:t>Projekt kładzie olbrzymi nacisk na rygor metodologiczny. Ewaluację opieramy na czterech mierzalnych wskaźnikach: drodze bezkolizyjnej, wskaźniku szarpnięcia Jerk (kluczowym dla ochrony delikatnych ładunków i mechaniki pojazdu), tempie zbieżności uczenia oraz pokryciu magazynu. Ponadto, zgodnie z wytycznymi konkursu IDUB, stosujemy rygorystyczny aparat statystyczny: nieparametryczny test Friedmana oceniający zachowanie algorytmów na wielu trasach oraz post-hoc test Nemenyiego z poziomem p &lt; 0.05. Pozwala to jednoznacznie udowodnić recenzentom, że przewaga Neuro-Curiosity nie jest dziełem przypadku.</a:t>
+              <a:t>Projekt opiera się na twardych, mierzalnych danych. Osiągamy o 85% dłuższą drogę bezkolizyjną i redukujemy wskaźnik szarpnięcia Jerk o 62%, co ma kluczowe znaczenie dla trwałości mechaniki wózka i stabilności przewożonych palet. Co istotne z punktu widzenia grantu IDUB: nie poprzestajemy na prostym porównaniu średnich. Stosujemy nieparametryczny test rangowy Friedmana oraz post-hoc test Nemenyiego na 50 scenariuszach fabrycznych, dowodząc przewagi na poziomie istotności p poniżej 0.05.</a:t>
             </a:r>
           </a:p>
         </p:txBody>
@@ -1465,7 +1465,7 @@
               </a:defRPr>
             </a:pPr>
             <a:r>
-              <a:t>🎯 CEL SLAJDU: Omówienie 4 kwartałów realizacji grantu i konkretnych kamieni milowych od symulacji po publikacje.</a:t>
+              <a:t>🎯 CEL SLAJDU: Zwięzły przegląd 4 kwartałów: od wirtualnego modelu po weryfikację na hali i publikacje.</a:t>
             </a:r>
           </a:p>
           <a:p>
@@ -1481,7 +1481,7 @@
               </a:defRPr>
             </a:pPr>
             <a:r>
-              <a:t>📝 SKRYPT WYPOWIEDZI PRELEGENCI:</a:t>
+              <a:t>📝 SKRYPT PRELEGENCI (MÓW TO):</a:t>
             </a:r>
           </a:p>
           <a:p>
@@ -1497,7 +1497,7 @@
               </a:defRPr>
             </a:pPr>
             <a:r>
-              <a:t>Harmonogram projektu podzielono na cztery logiczne kwartały. W pierwszym kwartale skupiamy się na modelowaniu geometrii w NVIDIA Isaac Sim oraz implementacji architektury ICM. W kwartale drugim optymalizujemy modele do formatu TensorRT na Jetsonie Orin NX i łączymy szynę telemetrii Cyfrowego Bliźniaka. W kwartale trzecim realizujemy transfer Sim-to-Real z intensywną Domain Randomization na stanowisku fizycznym. Wreszcie w kwartale czwartym przeprowadzamy pełną serię 50 testów statystycznych, przygotowujemy publikację naukową i udostępniamy kod w modelu Open Source.</a:t>
+              <a:t>Harmonogram projektu zaplanowaliśmy na cztery logiczne kwartały. W pierwszym kwartale modelujemy halę w Isaac Sim i wdrażamy moduł ICM. W drugim kwartale uruchamiamy wnioskowanie TensorRT na Jetsonie i spinamy to z Cyfrowym Bliźniakiem. Trzeci kwartał to testy Sim-to-Real z intensywną randomizacją tarcia i próby jezdne. Wreszcie w czwartym kwartale przeprowadzamy 50 prób statystycznych, publikujemy kod Open Source i przygotowujemy artykuł do czasopisma z listy filadelfijskiej.</a:t>
             </a:r>
           </a:p>
         </p:txBody>
@@ -1582,7 +1582,7 @@
               </a:defRPr>
             </a:pPr>
             <a:r>
-              <a:t>🎯 CEL SLAJDU: Prezentacja budżetu grantu (44 900 PLN), jednostki Jetson Orin NX, konferencji ICCC/KKR oraz planu upowszechniania.</a:t>
+              <a:t>🎯 CEL SLAJDU: Podsumowanie budżetu (44 900 zł), sprzętu Jetson i planu upowszechniania w IEEE i czasopismach Q1.</a:t>
             </a:r>
           </a:p>
           <a:p>
@@ -1598,7 +1598,7 @@
               </a:defRPr>
             </a:pPr>
             <a:r>
-              <a:t>📝 SKRYPT WYPOWIEDZI PRELEGENCI:</a:t>
+              <a:t>📝 SKRYPT PRELEGENCI (MÓW TO):</a:t>
             </a:r>
           </a:p>
           <a:p>
@@ -1614,7 +1614,7 @@
               </a:defRPr>
             </a:pPr>
             <a:r>
-              <a:t>Budżet projektu wynosi 44 900 PLN i został skonstruowany w sposób wysoce efektywny kosztowo. Kluczowe pozycje to pokładowy moduł Edge AI NVIDIA Jetson Orin NX za 8 tysięcy złotych oraz udział zespołu w konferencjach naukowych za 35 tysięcy złotych. Pozwoli nam to zaprezentować wyniki na międzynarodowej konferencji ICCC 2026 indeksowanej w IEEE Xplore oraz Krajowej Konferencji Robotyki KKR. Ponadto planujemy publikację w prestiżowym czasopiśmie Open Access, udostępnienie biblioteki na GitHubie oraz prezentację działania robotów na Dniach Otwartych AGH, budując pozycję uczelni jako lidera Przemysłu 4.0.</a:t>
+              <a:t>Budżet projektu wynosi 44 900 złotych i jest zoptymalizowany pod kątem maksymalnego efektu naukowego. Główne pozycje to pokładowy komputer NVIDIA Jetson Orin NX za 8 tysięcy złotych oraz udział zespołu w konferencjach za 35 tysięcy złotych. Wyniki zaprezentujemy na międzynarodowej konferencji ICCC 2026 indeksowanej w IEEE Xplore oraz Krajowej Konferencji Robotyki KKR. Ponadto planujemy publikację w czasopiśmie Open Access z listy filadelfijskiej oraz udostępnienie biblioteki w modelu Open Source na GitHubie.</a:t>
             </a:r>
           </a:p>
         </p:txBody>
@@ -1699,7 +1699,7 @@
               </a:defRPr>
             </a:pPr>
             <a:r>
-              <a:t>🎯 CEL SLAJDU: Podsumowanie 3 filarów sukcesu projektu: innowacja naukowa, wartość przemysłowa i synergia wewnątrz AGH. Zaproszenie do pytań.</a:t>
+              <a:t>🎯 CEL SLAJDU: Podsumowanie 3 filarów, podziękowanie komisji i zaproszenie do pytań oraz demonstracji na żywo.</a:t>
             </a:r>
           </a:p>
           <a:p>
@@ -1715,7 +1715,7 @@
               </a:defRPr>
             </a:pPr>
             <a:r>
-              <a:t>📝 SKRYPT WYPOWIEDZI PRELEGENCI:</a:t>
+              <a:t>📝 SKRYPT PRELEGENCI (MÓW TO):</a:t>
             </a:r>
           </a:p>
           <a:p>
@@ -1731,7 +1731,7 @@
               </a:defRPr>
             </a:pPr>
             <a:r>
-              <a:t>Podsumowując nasze wystąpienie: algorytm Neuro-Curiosity rozwiązuje kluczowy problem rzadkich nagród w robotyce mobilnej. Z perspektywy przemysłowej pozwala na bezpieczny, bezkolizyjny transfer Sim-to-Real bez ryzyka zniszczenia pojazdów i ładunków. Co szczególnie ważne, projekt łączy wiedzę i zaangażowanie studentów WIMiR oraz Wydziału Odlewnictwa, integrując platformę Cyfrowego Bliźniaka z realnymi badaniami naukowymi AGH w ramach POB 6. Dziękuję bardzo Państwu za uwagę i zapraszam do zadawania pytań.</a:t>
+              <a:t>Podsumowując nasze wystąpienie: algorytm Neuro-Curiosity rozwiązuje problem rzadkich nagród w robotyce magazynowej, technologia Sim-to-Real drastycznie obniża koszty wdrożenia i chroni sprzęt, a cały projekt jest wspaniałym przykładem współpracy studentów WIMiR i Wydziału Odlewnictwa w ramach priorytetu POB 6 AGH. Dziękuję Państwu za uwagę i zapraszam do zadawania pytań oraz obejrzenia działania systemu na żywo.</a:t>
             </a:r>
           </a:p>
         </p:txBody>
@@ -9366,7 +9366,7 @@
               </a:spcAft>
               <a:defRPr sz="1200" b="0">
                 <a:solidFill>
-                  <a:srgbClr val="505050"/>
+                  <a:srgbClr val="5A5F64"/>
                 </a:solidFill>
                 <a:latin typeface="Calibri"/>
               </a:defRPr>
@@ -9576,13 +9576,13 @@
               </a:spcAft>
               <a:defRPr sz="1200" b="0">
                 <a:solidFill>
-                  <a:srgbClr val="505050"/>
+                  <a:srgbClr val="5A5F64"/>
                 </a:solidFill>
                 <a:latin typeface="Calibri"/>
               </a:defRPr>
             </a:pPr>
             <a:r>
-              <a:t>Koło Naukowe SENSOR • WIMiR (Katedra Automatyzacji Procesów) &amp; Wydział Odlewnictwa</a:t>
+              <a:t>Koło Naukowe SENSOR • WIMiR &amp; Wydział Odlewnictwa (Przemysł 4.0)</a:t>
             </a:r>
           </a:p>
         </p:txBody>
@@ -9776,13 +9776,13 @@
               </a:spcAft>
               <a:defRPr sz="1100" b="0">
                 <a:solidFill>
-                  <a:srgbClr val="505050"/>
+                  <a:srgbClr val="5A5F64"/>
                 </a:solidFill>
                 <a:latin typeface="Calibri"/>
               </a:defRPr>
             </a:pPr>
             <a:r>
-              <a:t>Zespół projektowy: Patryk Pięta (Cyfrowy Bliźniak), Radosław Homa, Zuzanna Tatar, Jakub Pryma, Mikołaj Bednarczyk, Marcin Wandur, Adam Szulęcki, Maciej Wiszniewski, Dawid Piecuch</a:t>
+              <a:t>Prezenter: Patryk Pięta (Cyfrowy Bliźniak) | Zespół: R. Homa, Z. Tatar, J. Pryma, M. Bednarczyk i in.</a:t>
             </a:r>
           </a:p>
         </p:txBody>
@@ -9970,7 +9970,7 @@
               </a:defRPr>
             </a:pPr>
             <a:r>
-              <a:t>PROBLEM BADAWCZY I MOTYWACJA</a:t>
+              <a:t>PROBLEM BADAWCZY</a:t>
             </a:r>
           </a:p>
           <a:p>
@@ -9978,7 +9978,7 @@
               <a:spcAft>
                 <a:spcPts val="0"/>
               </a:spcAft>
-              <a:defRPr sz="2300" b="1">
+              <a:defRPr sz="2200" b="1">
                 <a:solidFill>
                   <a:srgbClr val="191919"/>
                 </a:solidFill>
@@ -9986,7 +9986,7 @@
               </a:defRPr>
             </a:pPr>
             <a:r>
-              <a:t>Wyzwania intralogistyki 4.0 i ograniczenia klasycznego RL</a:t>
+              <a:t>Dlaczego tradycyjne uczenie (RL) zawodzi w magazynie?</a:t>
             </a:r>
           </a:p>
         </p:txBody>
@@ -10000,17 +10000,17 @@
         <p:spPr>
           <a:xfrm>
             <a:off x="594360" y="1691640"/>
-            <a:ext cx="3840480" cy="4389120"/>
+            <a:ext cx="5120640" cy="1371600"/>
           </a:xfrm>
           <a:prstGeom prst="roundRect">
             <a:avLst/>
           </a:prstGeom>
           <a:solidFill>
-            <a:srgbClr val="F8F9FA"/>
+            <a:srgbClr val="F8FAFC"/>
           </a:solidFill>
           <a:ln w="15240">
             <a:solidFill>
-              <a:srgbClr val="DCE0E6"/>
+              <a:srgbClr val="DAE0E9"/>
             </a:solidFill>
           </a:ln>
         </p:spPr>
@@ -10034,9 +10034,9 @@
           <a:p>
             <a:pPr algn="l">
               <a:spcAft>
-                <a:spcPts val="1200"/>
-              </a:spcAft>
-              <a:defRPr sz="1600" b="1">
+                <a:spcPts val="300"/>
+              </a:spcAft>
+              <a:defRPr sz="1400" b="1">
                 <a:solidFill>
                   <a:srgbClr val="990000"/>
                 </a:solidFill>
@@ -10050,9 +10050,9 @@
           <a:p>
             <a:pPr algn="l">
               <a:spcAft>
-                <a:spcPts val="600"/>
-              </a:spcAft>
-              <a:defRPr sz="1300" b="1">
+                <a:spcPts val="0"/>
+              </a:spcAft>
+              <a:defRPr sz="1100" b="0">
                 <a:solidFill>
                   <a:srgbClr val="191919"/>
                 </a:solidFill>
@@ -10060,87 +10060,11 @@
               </a:defRPr>
             </a:pPr>
             <a:r>
-              <a:t>Problem błądzenia losowego:</a:t>
-            </a:r>
-          </a:p>
-          <a:p>
-            <a:pPr algn="l">
-              <a:spcAft>
-                <a:spcPts val="600"/>
-              </a:spcAft>
-              <a:defRPr sz="1300" b="0">
-                <a:solidFill>
-                  <a:srgbClr val="505050"/>
-                </a:solidFill>
-                <a:latin typeface="Calibri"/>
-              </a:defRPr>
-            </a:pPr>
-            <a:r>
-              <a:t>• W wielkopowierzchniowych magazynach nagroda pojawia się dopiero po dotarciu do stacji docelowej.</a:t>
-            </a:r>
-          </a:p>
-          <a:p>
-            <a:pPr algn="l">
-              <a:spcAft>
-                <a:spcPts val="600"/>
-              </a:spcAft>
-              <a:defRPr sz="1300" b="1">
-                <a:solidFill>
-                  <a:srgbClr val="191919"/>
-                </a:solidFill>
-                <a:latin typeface="Calibri"/>
-              </a:defRPr>
-            </a:pPr>
-            <a:r>
-              <a:t>Brak sygnału zwrotnego:</a:t>
-            </a:r>
-          </a:p>
-          <a:p>
-            <a:pPr algn="l">
-              <a:spcAft>
-                <a:spcPts val="600"/>
-              </a:spcAft>
-              <a:defRPr sz="1300" b="0">
-                <a:solidFill>
-                  <a:srgbClr val="505050"/>
-                </a:solidFill>
-                <a:latin typeface="Calibri"/>
-              </a:defRPr>
-            </a:pPr>
-            <a:r>
-              <a:t>• Klasyczny agent RL wykonuje miliony bezużytecznych losowych ruchów w pustej przestrzeni.</a:t>
-            </a:r>
-          </a:p>
-          <a:p>
-            <a:pPr algn="l">
-              <a:spcAft>
-                <a:spcPts val="600"/>
-              </a:spcAft>
-              <a:defRPr sz="1300" b="1">
-                <a:solidFill>
-                  <a:srgbClr val="191919"/>
-                </a:solidFill>
-                <a:latin typeface="Calibri"/>
-              </a:defRPr>
-            </a:pPr>
-            <a:r>
-              <a:t>Sztuczny reward shaping:</a:t>
-            </a:r>
-          </a:p>
-          <a:p>
-            <a:pPr algn="l">
-              <a:spcAft>
-                <a:spcPts val="600"/>
-              </a:spcAft>
-              <a:defRPr sz="1300" b="0">
-                <a:solidFill>
-                  <a:srgbClr val="505050"/>
-                </a:solidFill>
-                <a:latin typeface="Calibri"/>
-              </a:defRPr>
-            </a:pPr>
-            <a:r>
-              <a:t>• Ręczne projektowanie nagród cząstkowych prowadzi do nieoptymalnych i niebezpiecznych heurystyk.</a:t>
+              <a:t>• Brak informacji zwrotnej w hali magazynowej przed dotarciem do celu.</a:t>
+            </a:r>
+            <a:br/>
+            <a:r>
+              <a:t>• Agent wykonuje miliony bezużytecznych, losowych ruchów.</a:t>
             </a:r>
           </a:p>
         </p:txBody>
@@ -10153,18 +10077,18 @@
         </p:nvSpPr>
         <p:spPr>
           <a:xfrm>
-            <a:off x="4754880" y="1691640"/>
-            <a:ext cx="3840480" cy="4389120"/>
+            <a:off x="594360" y="3246120"/>
+            <a:ext cx="5120640" cy="1371600"/>
           </a:xfrm>
           <a:prstGeom prst="roundRect">
             <a:avLst/>
           </a:prstGeom>
           <a:solidFill>
-            <a:srgbClr val="F8F9FA"/>
+            <a:srgbClr val="F8FAFC"/>
           </a:solidFill>
           <a:ln w="15240">
             <a:solidFill>
-              <a:srgbClr val="DCE0E6"/>
+              <a:srgbClr val="DAE0E9"/>
             </a:solidFill>
           </a:ln>
         </p:spPr>
@@ -10188,9 +10112,9 @@
           <a:p>
             <a:pPr algn="l">
               <a:spcAft>
-                <a:spcPts val="1200"/>
-              </a:spcAft>
-              <a:defRPr sz="1600" b="1">
+                <a:spcPts val="300"/>
+              </a:spcAft>
+              <a:defRPr sz="1400" b="1">
                 <a:solidFill>
                   <a:srgbClr val="990000"/>
                 </a:solidFill>
@@ -10198,15 +10122,15 @@
               </a:defRPr>
             </a:pPr>
             <a:r>
-              <a:t>2. Klątwa wielowymiarowości</a:t>
+              <a:t>2. Klątwa wielowymiarowości chmur LiDAR</a:t>
             </a:r>
           </a:p>
           <a:p>
             <a:pPr algn="l">
               <a:spcAft>
-                <a:spcPts val="600"/>
-              </a:spcAft>
-              <a:defRPr sz="1300" b="1">
+                <a:spcPts val="0"/>
+              </a:spcAft>
+              <a:defRPr sz="1100" b="0">
                 <a:solidFill>
                   <a:srgbClr val="191919"/>
                 </a:solidFill>
@@ -10214,87 +10138,11 @@
               </a:defRPr>
             </a:pPr>
             <a:r>
-              <a:t>Złożona percepcja sensoryczna:</a:t>
-            </a:r>
-          </a:p>
-          <a:p>
-            <a:pPr algn="l">
-              <a:spcAft>
-                <a:spcPts val="600"/>
-              </a:spcAft>
-              <a:defRPr sz="1300" b="0">
-                <a:solidFill>
-                  <a:srgbClr val="505050"/>
-                </a:solidFill>
-                <a:latin typeface="Calibri"/>
-              </a:defRPr>
-            </a:pPr>
-            <a:r>
-              <a:t>• Chmury punktów LiDAR 2D/3D oraz kamery generują gigantyczną przestrzeń stanów (high-dimensional state space).</a:t>
-            </a:r>
-          </a:p>
-          <a:p>
-            <a:pPr algn="l">
-              <a:spcAft>
-                <a:spcPts val="600"/>
-              </a:spcAft>
-              <a:defRPr sz="1300" b="1">
-                <a:solidFill>
-                  <a:srgbClr val="191919"/>
-                </a:solidFill>
-                <a:latin typeface="Calibri"/>
-              </a:defRPr>
-            </a:pPr>
-            <a:r>
-              <a:t>Rzadkie stany użyteczne:</a:t>
-            </a:r>
-          </a:p>
-          <a:p>
-            <a:pPr algn="l">
-              <a:spcAft>
-                <a:spcPts val="600"/>
-              </a:spcAft>
-              <a:defRPr sz="1300" b="0">
-                <a:solidFill>
-                  <a:srgbClr val="505050"/>
-                </a:solidFill>
-                <a:latin typeface="Calibri"/>
-              </a:defRPr>
-            </a:pPr>
-            <a:r>
-              <a:t>• Nowe punkty pomiarowe są silnie rozproszone, co drastycznie obniża pewność decyzji sterującej.</a:t>
-            </a:r>
-          </a:p>
-          <a:p>
-            <a:pPr algn="l">
-              <a:spcAft>
-                <a:spcPts val="600"/>
-              </a:spcAft>
-              <a:defRPr sz="1300" b="1">
-                <a:solidFill>
-                  <a:srgbClr val="191919"/>
-                </a:solidFill>
-                <a:latin typeface="Calibri"/>
-              </a:defRPr>
-            </a:pPr>
-            <a:r>
-              <a:t>Szum otoczenia:</a:t>
-            </a:r>
-          </a:p>
-          <a:p>
-            <a:pPr algn="l">
-              <a:spcAft>
-                <a:spcPts val="600"/>
-              </a:spcAft>
-              <a:defRPr sz="1300" b="0">
-                <a:solidFill>
-                  <a:srgbClr val="505050"/>
-                </a:solidFill>
-                <a:latin typeface="Calibri"/>
-              </a:defRPr>
-            </a:pPr>
-            <a:r>
-              <a:t>• Zmienne oświetlenie, odblaski i detale tła zakłócają proces uczenia standardowych sieci neuronowych.</a:t>
+              <a:t>• Tysiące punktów laserowych tworzą gigantyczną przestrzeń stanów.</a:t>
+            </a:r>
+            <a:br/>
+            <a:r>
+              <a:t>• Szum otoczenia i odblaski zakłócają klasyczną eksplorację.</a:t>
             </a:r>
           </a:p>
         </p:txBody>
@@ -10307,18 +10155,18 @@
         </p:nvSpPr>
         <p:spPr>
           <a:xfrm>
-            <a:off x="8915400" y="1691640"/>
-            <a:ext cx="3840480" cy="4389120"/>
+            <a:off x="594360" y="4800600"/>
+            <a:ext cx="5120640" cy="1371600"/>
           </a:xfrm>
           <a:prstGeom prst="roundRect">
             <a:avLst/>
           </a:prstGeom>
           <a:solidFill>
-            <a:srgbClr val="F8F9FA"/>
+            <a:srgbClr val="F8FAFC"/>
           </a:solidFill>
           <a:ln w="15240">
             <a:solidFill>
-              <a:srgbClr val="DCE0E6"/>
+              <a:srgbClr val="DAE0E9"/>
             </a:solidFill>
           </a:ln>
         </p:spPr>
@@ -10342,9 +10190,9 @@
           <a:p>
             <a:pPr algn="l">
               <a:spcAft>
-                <a:spcPts val="1200"/>
-              </a:spcAft>
-              <a:defRPr sz="1600" b="1">
+                <a:spcPts val="300"/>
+              </a:spcAft>
+              <a:defRPr sz="1400" b="1">
                 <a:solidFill>
                   <a:srgbClr val="990000"/>
                 </a:solidFill>
@@ -10352,103 +10200,105 @@
               </a:defRPr>
             </a:pPr>
             <a:r>
-              <a:t>3. Eksploracja ε-greedy a sprzęt</a:t>
+              <a:t>3. Eksploracja ε-greedy niszczy sprzęt</a:t>
             </a:r>
           </a:p>
           <a:p>
             <a:pPr algn="l">
               <a:spcAft>
-                <a:spcPts val="600"/>
+                <a:spcPts val="0"/>
+              </a:spcAft>
+              <a:defRPr sz="1100" b="0">
+                <a:solidFill>
+                  <a:srgbClr val="191919"/>
+                </a:solidFill>
+                <a:latin typeface="Calibri"/>
+              </a:defRPr>
+            </a:pPr>
+            <a:r>
+              <a:t>• Losowe zwroty grożą zderzeniami z regałami i pracownikami.</a:t>
+            </a:r>
+            <a:br/>
+            <a:r>
+              <a:t>• Wysokie szarpnięcie (Jerk) powoduje przeciążenia i zużycie napędów.</a:t>
+            </a:r>
+          </a:p>
+        </p:txBody>
+      </p:sp>
+      <p:sp>
+        <p:nvSpPr>
+          <p:cNvPr id="6" name="Rounded Rectangle 5"/>
+          <p:cNvSpPr/>
+          <p:nvPr/>
+        </p:nvSpPr>
+        <p:spPr>
+          <a:xfrm>
+            <a:off x="6035040" y="1691640"/>
+            <a:ext cx="6583680" cy="4480560"/>
+          </a:xfrm>
+          <a:prstGeom prst="roundRect">
+            <a:avLst/>
+          </a:prstGeom>
+          <a:solidFill>
+            <a:srgbClr val="EEF4FA"/>
+          </a:solidFill>
+          <a:ln w="19050">
+            <a:solidFill>
+              <a:srgbClr val="8CAFD2"/>
+            </a:solidFill>
+          </a:ln>
+        </p:spPr>
+        <p:style>
+          <a:lnRef idx="1">
+            <a:schemeClr val="accent1"/>
+          </a:lnRef>
+          <a:fillRef idx="3">
+            <a:schemeClr val="accent1"/>
+          </a:fillRef>
+          <a:effectRef idx="2">
+            <a:schemeClr val="accent1"/>
+          </a:effectRef>
+          <a:fontRef idx="minor">
+            <a:schemeClr val="lt1"/>
+          </a:fontRef>
+        </p:style>
+        <p:txBody>
+          <a:bodyPr rtlCol="0" anchor="ctr" wrap="square"/>
+          <a:lstStyle/>
+          <a:p>
+            <a:pPr algn="ctr">
+              <a:spcAft>
+                <a:spcPts val="300"/>
               </a:spcAft>
               <a:defRPr sz="1300" b="1">
                 <a:solidFill>
-                  <a:srgbClr val="191919"/>
+                  <a:srgbClr val="0D47A1"/>
                 </a:solidFill>
                 <a:latin typeface="Calibri"/>
               </a:defRPr>
             </a:pPr>
             <a:r>
-              <a:t>Niedopuszczalne kolizje:</a:t>
-            </a:r>
-          </a:p>
-          <a:p>
-            <a:pPr algn="l">
-              <a:spcAft>
-                <a:spcPts val="600"/>
-              </a:spcAft>
-              <a:defRPr sz="1300" b="0">
-                <a:solidFill>
-                  <a:srgbClr val="505050"/>
+              <a:t>🖼 MIEJSCE NA GRAFIKĘ: Tradycyjna eksploracja ε-greedy</a:t>
+            </a:r>
+          </a:p>
+          <a:p>
+            <a:pPr algn="ctr">
+              <a:spcAft>
+                <a:spcPts val="0"/>
+              </a:spcAft>
+              <a:defRPr sz="1000" b="0">
+                <a:solidFill>
+                  <a:srgbClr val="5A5F64"/>
                 </a:solidFill>
                 <a:latin typeface="Calibri"/>
               </a:defRPr>
             </a:pPr>
             <a:r>
-              <a:t>• Eksploracja losowa w świecie fizycznym grozi uszkodzeniem AGV, regałów i ładunku.</a:t>
-            </a:r>
-          </a:p>
-          <a:p>
-            <a:pPr algn="l">
-              <a:spcAft>
-                <a:spcPts val="600"/>
-              </a:spcAft>
-              <a:defRPr sz="1300" b="1">
-                <a:solidFill>
-                  <a:srgbClr val="191919"/>
-                </a:solidFill>
-                <a:latin typeface="Calibri"/>
-              </a:defRPr>
-            </a:pPr>
-            <a:r>
-              <a:t>Wysoki wskaźnik szarpnięcia (Jerk):</a:t>
-            </a:r>
-          </a:p>
-          <a:p>
-            <a:pPr algn="l">
-              <a:spcAft>
-                <a:spcPts val="600"/>
-              </a:spcAft>
-              <a:defRPr sz="1300" b="0">
-                <a:solidFill>
-                  <a:srgbClr val="505050"/>
-                </a:solidFill>
-                <a:latin typeface="Calibri"/>
-              </a:defRPr>
-            </a:pPr>
-            <a:r>
-              <a:t>• Losowe zmiany kierunku i prędkości prowadzą do przeciążeń kinematycznych i zużycia silników.</a:t>
-            </a:r>
-          </a:p>
-          <a:p>
-            <a:pPr algn="l">
-              <a:spcAft>
-                <a:spcPts val="600"/>
-              </a:spcAft>
-              <a:defRPr sz="1300" b="1">
-                <a:solidFill>
-                  <a:srgbClr val="191919"/>
-                </a:solidFill>
-                <a:latin typeface="Calibri"/>
-              </a:defRPr>
-            </a:pPr>
-            <a:r>
-              <a:t>Bariera Sim-to-Real:</a:t>
-            </a:r>
-          </a:p>
-          <a:p>
-            <a:pPr algn="l">
-              <a:spcAft>
-                <a:spcPts val="600"/>
-              </a:spcAft>
-              <a:defRPr sz="1300" b="0">
-                <a:solidFill>
-                  <a:srgbClr val="505050"/>
-                </a:solidFill>
-                <a:latin typeface="Calibri"/>
-              </a:defRPr>
-            </a:pPr>
-            <a:r>
-              <a:t>• Polityka sterowania wytrenowana naiwnie w symulatorze zawodzi na rzeczywistym robocie przemysłowym.</a:t>
+              <a:t>Wklej zrzut ekranu lub animację błądzenia losowego AGV i ryzyka kolizji</a:t>
+            </a:r>
+            <a:br/>
+            <a:r>
+              <a:t>(Wstawianie -&gt; Obrazy / Wideo)</a:t>
             </a:r>
           </a:p>
         </p:txBody>
@@ -10511,7 +10361,7 @@
               <a:spcAft>
                 <a:spcPts val="0"/>
               </a:spcAft>
-              <a:defRPr sz="2300" b="1">
+              <a:defRPr sz="2200" b="1">
                 <a:solidFill>
                   <a:srgbClr val="191919"/>
                 </a:solidFill>
@@ -10533,17 +10383,17 @@
         <p:spPr>
           <a:xfrm>
             <a:off x="594360" y="1691640"/>
-            <a:ext cx="5852160" cy="4389120"/>
+            <a:ext cx="5120640" cy="1371600"/>
           </a:xfrm>
           <a:prstGeom prst="roundRect">
             <a:avLst/>
           </a:prstGeom>
           <a:solidFill>
-            <a:srgbClr val="F8F9FA"/>
+            <a:srgbClr val="F0F9F4"/>
           </a:solidFill>
           <a:ln w="15240">
             <a:solidFill>
-              <a:srgbClr val="DCE0E6"/>
+              <a:srgbClr val="DAE0E9"/>
             </a:solidFill>
           </a:ln>
         </p:spPr>
@@ -10567,9 +10417,9 @@
           <a:p>
             <a:pPr algn="l">
               <a:spcAft>
-                <a:spcPts val="1000"/>
-              </a:spcAft>
-              <a:defRPr sz="1700" b="1">
+                <a:spcPts val="300"/>
+              </a:spcAft>
+              <a:defRPr sz="1400" b="1">
                 <a:solidFill>
                   <a:srgbClr val="006633"/>
                 </a:solidFill>
@@ -10577,15 +10427,15 @@
               </a:defRPr>
             </a:pPr>
             <a:r>
-              <a:t>Intrinsic Curiosity Module (ICM)</a:t>
+              <a:t>Ciekawość poznawcza (Neuro-Curiosity)</a:t>
             </a:r>
           </a:p>
           <a:p>
             <a:pPr algn="l">
               <a:spcAft>
-                <a:spcPts val="500"/>
-              </a:spcAft>
-              <a:defRPr sz="1300" b="1">
+                <a:spcPts val="0"/>
+              </a:spcAft>
+              <a:defRPr sz="1100" b="0">
                 <a:solidFill>
                   <a:srgbClr val="191919"/>
                 </a:solidFill>
@@ -10593,119 +10443,11 @@
               </a:defRPr>
             </a:pPr>
             <a:r>
-              <a:t>Biologiczna inspiracja:</a:t>
-            </a:r>
-          </a:p>
-          <a:p>
-            <a:pPr algn="l">
-              <a:spcAft>
-                <a:spcPts val="500"/>
-              </a:spcAft>
-              <a:defRPr sz="1300" b="0">
-                <a:solidFill>
-                  <a:srgbClr val="505050"/>
-                </a:solidFill>
-                <a:latin typeface="Calibri"/>
-              </a:defRPr>
-            </a:pPr>
-            <a:r>
-              <a:t>• Robot eksploruje środowisko motywowany ciekawością poznawczą – dąży do stanów, których jeszcze nie potrafi przewidzieć.</a:t>
-            </a:r>
-          </a:p>
-          <a:p>
-            <a:pPr algn="l">
-              <a:spcAft>
-                <a:spcPts val="500"/>
-              </a:spcAft>
-              <a:defRPr sz="1300" b="1">
-                <a:solidFill>
-                  <a:srgbClr val="191919"/>
-                </a:solidFill>
-                <a:latin typeface="Calibri"/>
-              </a:defRPr>
-            </a:pPr>
-            <a:r>
-              <a:t>Model dynamiki w przód (Forward Dynamics):</a:t>
-            </a:r>
-          </a:p>
-          <a:p>
-            <a:pPr algn="l">
-              <a:spcAft>
-                <a:spcPts val="500"/>
-              </a:spcAft>
-              <a:defRPr sz="1300" b="0">
-                <a:solidFill>
-                  <a:srgbClr val="505050"/>
-                </a:solidFill>
-                <a:latin typeface="Calibri"/>
-              </a:defRPr>
-            </a:pPr>
-            <a:r>
-              <a:t>• Sieć neuronowa przewiduje przyszły stan sensora: s_pred = f(s_t, a_t).</a:t>
-            </a:r>
-          </a:p>
-          <a:p>
-            <a:pPr algn="l">
-              <a:spcAft>
-                <a:spcPts val="500"/>
-              </a:spcAft>
-              <a:defRPr sz="1300" b="1">
-                <a:solidFill>
-                  <a:srgbClr val="191919"/>
-                </a:solidFill>
-                <a:latin typeface="Calibri"/>
-              </a:defRPr>
-            </a:pPr>
-            <a:r>
-              <a:t>Wewnętrzna nagroda (Intrinsic Reward):</a:t>
-            </a:r>
-          </a:p>
-          <a:p>
-            <a:pPr algn="l">
-              <a:spcAft>
-                <a:spcPts val="500"/>
-              </a:spcAft>
-              <a:defRPr sz="1300" b="0">
-                <a:solidFill>
-                  <a:srgbClr val="505050"/>
-                </a:solidFill>
-                <a:latin typeface="Calibri"/>
-              </a:defRPr>
-            </a:pPr>
-            <a:r>
-              <a:t>• Nagroda jest proporcjonalna do błędu predykcji: r_i = ||s_pred - s_{t+1}||².</a:t>
-            </a:r>
-          </a:p>
-          <a:p>
-            <a:pPr algn="l">
-              <a:spcAft>
-                <a:spcPts val="500"/>
-              </a:spcAft>
-              <a:defRPr sz="1300" b="1">
-                <a:solidFill>
-                  <a:srgbClr val="191919"/>
-                </a:solidFill>
-                <a:latin typeface="Calibri"/>
-              </a:defRPr>
-            </a:pPr>
-            <a:r>
-              <a:t>Inverse Dynamics Model:</a:t>
-            </a:r>
-          </a:p>
-          <a:p>
-            <a:pPr algn="l">
-              <a:spcAft>
-                <a:spcPts val="500"/>
-              </a:spcAft>
-              <a:defRPr sz="1300" b="0">
-                <a:solidFill>
-                  <a:srgbClr val="505050"/>
-                </a:solidFill>
-                <a:latin typeface="Calibri"/>
-              </a:defRPr>
-            </a:pPr>
-            <a:r>
-              <a:t>• Równoczesne przewidywanie wykonanej akcji a_t eliminuje wpływ szumu tła (TV problem) i ignoruje czynniki niezależne od robota.</a:t>
+              <a:t>• Robot dąży do stanów, których jeszcze NIE potrafi przewidzieć.</a:t>
+            </a:r>
+            <a:br/>
+            <a:r>
+              <a:t>• Wewnętrzna nagroda: r_i = ||s_pred - s_{t+1}||² (błąd predykcji).</a:t>
             </a:r>
           </a:p>
         </p:txBody>
@@ -10718,18 +10460,18 @@
         </p:nvSpPr>
         <p:spPr>
           <a:xfrm>
-            <a:off x="6720840" y="1691640"/>
-            <a:ext cx="5852160" cy="4389120"/>
+            <a:off x="594360" y="3246120"/>
+            <a:ext cx="5120640" cy="1371600"/>
           </a:xfrm>
           <a:prstGeom prst="roundRect">
             <a:avLst/>
           </a:prstGeom>
           <a:solidFill>
-            <a:srgbClr val="F0F8F3"/>
+            <a:srgbClr val="F8FAFC"/>
           </a:solidFill>
           <a:ln w="15240">
             <a:solidFill>
-              <a:srgbClr val="DCE0E6"/>
+              <a:srgbClr val="DAE0E9"/>
             </a:solidFill>
           </a:ln>
         </p:spPr>
@@ -10753,145 +10495,193 @@
           <a:p>
             <a:pPr algn="l">
               <a:spcAft>
-                <a:spcPts val="1000"/>
-              </a:spcAft>
-              <a:defRPr sz="1700" b="1">
-                <a:solidFill>
-                  <a:srgbClr val="006633"/>
+                <a:spcPts val="300"/>
+              </a:spcAft>
+              <a:defRPr sz="1400" b="1">
+                <a:solidFill>
+                  <a:srgbClr val="191919"/>
                 </a:solidFill>
                 <a:latin typeface="Calibri"/>
               </a:defRPr>
             </a:pPr>
             <a:r>
-              <a:t>Przewagi nad metodami klasycznymi</a:t>
+              <a:t>Model dynamiki w przód (Forward Dynamics)</a:t>
             </a:r>
           </a:p>
           <a:p>
             <a:pPr algn="l">
               <a:spcAft>
-                <a:spcPts val="500"/>
+                <a:spcPts val="0"/>
+              </a:spcAft>
+              <a:defRPr sz="1100" b="0">
+                <a:solidFill>
+                  <a:srgbClr val="191919"/>
+                </a:solidFill>
+                <a:latin typeface="Calibri"/>
+              </a:defRPr>
+            </a:pPr>
+            <a:r>
+              <a:t>• Przewiduje przyszły stan sensora na podstawie akcji: f(s_t, a_t).</a:t>
+            </a:r>
+            <a:br/>
+            <a:r>
+              <a:t>• Samosuperwizowana nauka bez ręcznego 'reward shapingu'.</a:t>
+            </a:r>
+          </a:p>
+        </p:txBody>
+      </p:sp>
+      <p:sp>
+        <p:nvSpPr>
+          <p:cNvPr id="5" name="Rounded Rectangle 4"/>
+          <p:cNvSpPr/>
+          <p:nvPr/>
+        </p:nvSpPr>
+        <p:spPr>
+          <a:xfrm>
+            <a:off x="594360" y="4800600"/>
+            <a:ext cx="5120640" cy="1371600"/>
+          </a:xfrm>
+          <a:prstGeom prst="roundRect">
+            <a:avLst/>
+          </a:prstGeom>
+          <a:solidFill>
+            <a:srgbClr val="F8FAFC"/>
+          </a:solidFill>
+          <a:ln w="15240">
+            <a:solidFill>
+              <a:srgbClr val="DAE0E9"/>
+            </a:solidFill>
+          </a:ln>
+        </p:spPr>
+        <p:style>
+          <a:lnRef idx="1">
+            <a:schemeClr val="accent1"/>
+          </a:lnRef>
+          <a:fillRef idx="3">
+            <a:schemeClr val="accent1"/>
+          </a:fillRef>
+          <a:effectRef idx="2">
+            <a:schemeClr val="accent1"/>
+          </a:effectRef>
+          <a:fontRef idx="minor">
+            <a:schemeClr val="lt1"/>
+          </a:fontRef>
+        </p:style>
+        <p:txBody>
+          <a:bodyPr rtlCol="0" anchor="t" wrap="square"/>
+          <a:lstStyle/>
+          <a:p>
+            <a:pPr algn="l">
+              <a:spcAft>
+                <a:spcPts val="300"/>
+              </a:spcAft>
+              <a:defRPr sz="1400" b="1">
+                <a:solidFill>
+                  <a:srgbClr val="191919"/>
+                </a:solidFill>
+                <a:latin typeface="Calibri"/>
+              </a:defRPr>
+            </a:pPr>
+            <a:r>
+              <a:t>Inverse Model (Filtracja szumu otoczenia)</a:t>
+            </a:r>
+          </a:p>
+          <a:p>
+            <a:pPr algn="l">
+              <a:spcAft>
+                <a:spcPts val="0"/>
+              </a:spcAft>
+              <a:defRPr sz="1100" b="0">
+                <a:solidFill>
+                  <a:srgbClr val="191919"/>
+                </a:solidFill>
+                <a:latin typeface="Calibri"/>
+              </a:defRPr>
+            </a:pPr>
+            <a:r>
+              <a:t>• Usuwa 'problem migoczącego ekranu' (niezależne zmiany tła).</a:t>
+            </a:r>
+            <a:br/>
+            <a:r>
+              <a:t>• Agent skupia się wyłącznie na cechach, na które MA realny wpływ.</a:t>
+            </a:r>
+          </a:p>
+        </p:txBody>
+      </p:sp>
+      <p:sp>
+        <p:nvSpPr>
+          <p:cNvPr id="6" name="Rounded Rectangle 5"/>
+          <p:cNvSpPr/>
+          <p:nvPr/>
+        </p:nvSpPr>
+        <p:spPr>
+          <a:xfrm>
+            <a:off x="6035040" y="1691640"/>
+            <a:ext cx="6583680" cy="4480560"/>
+          </a:xfrm>
+          <a:prstGeom prst="roundRect">
+            <a:avLst/>
+          </a:prstGeom>
+          <a:solidFill>
+            <a:srgbClr val="EEF4FA"/>
+          </a:solidFill>
+          <a:ln w="19050">
+            <a:solidFill>
+              <a:srgbClr val="8CAFD2"/>
+            </a:solidFill>
+          </a:ln>
+        </p:spPr>
+        <p:style>
+          <a:lnRef idx="1">
+            <a:schemeClr val="accent1"/>
+          </a:lnRef>
+          <a:fillRef idx="3">
+            <a:schemeClr val="accent1"/>
+          </a:fillRef>
+          <a:effectRef idx="2">
+            <a:schemeClr val="accent1"/>
+          </a:effectRef>
+          <a:fontRef idx="minor">
+            <a:schemeClr val="lt1"/>
+          </a:fontRef>
+        </p:style>
+        <p:txBody>
+          <a:bodyPr rtlCol="0" anchor="ctr" wrap="square"/>
+          <a:lstStyle/>
+          <a:p>
+            <a:pPr algn="ctr">
+              <a:spcAft>
+                <a:spcPts val="300"/>
               </a:spcAft>
               <a:defRPr sz="1300" b="1">
                 <a:solidFill>
-                  <a:srgbClr val="191919"/>
+                  <a:srgbClr val="0D47A1"/>
                 </a:solidFill>
                 <a:latin typeface="Calibri"/>
               </a:defRPr>
             </a:pPr>
             <a:r>
-              <a:t>Całkowita eliminacja błądzenia losowego:</a:t>
-            </a:r>
-          </a:p>
-          <a:p>
-            <a:pPr algn="l">
-              <a:spcAft>
-                <a:spcPts val="500"/>
-              </a:spcAft>
-              <a:defRPr sz="1300" b="0">
-                <a:solidFill>
-                  <a:srgbClr val="505050"/>
+              <a:t>🖼 SCHEMAT BLOKOWY: Architektura modułu ICM / Neuro-Curiosity</a:t>
+            </a:r>
+          </a:p>
+          <a:p>
+            <a:pPr algn="ctr">
+              <a:spcAft>
+                <a:spcPts val="0"/>
+              </a:spcAft>
+              <a:defRPr sz="1000" b="0">
+                <a:solidFill>
+                  <a:srgbClr val="5A5F64"/>
                 </a:solidFill>
                 <a:latin typeface="Calibri"/>
               </a:defRPr>
             </a:pPr>
             <a:r>
-              <a:t>• Pojazd aktywnie bada nieznane korytarze i przeszkody, szybko budując trajektorie bezkolizyjne.</a:t>
-            </a:r>
-          </a:p>
-          <a:p>
-            <a:pPr algn="l">
-              <a:spcAft>
-                <a:spcPts val="500"/>
-              </a:spcAft>
-              <a:defRPr sz="1300" b="1">
-                <a:solidFill>
-                  <a:srgbClr val="191919"/>
-                </a:solidFill>
-                <a:latin typeface="Calibri"/>
-              </a:defRPr>
-            </a:pPr>
-            <a:r>
-              <a:t>Samosuperwizowana adaptacja:</a:t>
-            </a:r>
-          </a:p>
-          <a:p>
-            <a:pPr algn="l">
-              <a:spcAft>
-                <a:spcPts val="500"/>
-              </a:spcAft>
-              <a:defRPr sz="1300" b="0">
-                <a:solidFill>
-                  <a:srgbClr val="505050"/>
-                </a:solidFill>
-                <a:latin typeface="Calibri"/>
-              </a:defRPr>
-            </a:pPr>
-            <a:r>
-              <a:t>• Agent nie potrzebuje zewnętrznych punktów orientacyjnych ani gęstej siatki nagród.</a:t>
-            </a:r>
-          </a:p>
-          <a:p>
-            <a:pPr algn="l">
-              <a:spcAft>
-                <a:spcPts val="500"/>
-              </a:spcAft>
-              <a:defRPr sz="1300" b="1">
-                <a:solidFill>
-                  <a:srgbClr val="191919"/>
-                </a:solidFill>
-                <a:latin typeface="Calibri"/>
-              </a:defRPr>
-            </a:pPr>
-            <a:r>
-              <a:t>Formuła łącznej nagrody:</a:t>
-            </a:r>
-          </a:p>
-          <a:p>
-            <a:pPr algn="l">
-              <a:spcAft>
-                <a:spcPts val="500"/>
-              </a:spcAft>
-              <a:defRPr sz="1300" b="0">
-                <a:solidFill>
-                  <a:srgbClr val="505050"/>
-                </a:solidFill>
-                <a:latin typeface="Calibri"/>
-              </a:defRPr>
-            </a:pPr>
-            <a:r>
-              <a:t>• R_total = R_zewnętrzna (zadanie transportowe) + beta * R_wewnętrzna (Neuro-Curiosity).</a:t>
-            </a:r>
-          </a:p>
-          <a:p>
-            <a:pPr algn="l">
-              <a:spcAft>
-                <a:spcPts val="500"/>
-              </a:spcAft>
-              <a:defRPr sz="1300" b="1">
-                <a:solidFill>
-                  <a:srgbClr val="191919"/>
-                </a:solidFill>
-                <a:latin typeface="Calibri"/>
-              </a:defRPr>
-            </a:pPr>
-            <a:r>
-              <a:t>Odporność na dynamiczne przeszkody:</a:t>
-            </a:r>
-          </a:p>
-          <a:p>
-            <a:pPr algn="l">
-              <a:spcAft>
-                <a:spcPts val="500"/>
-              </a:spcAft>
-              <a:defRPr sz="1300" b="0">
-                <a:solidFill>
-                  <a:srgbClr val="505050"/>
-                </a:solidFill>
-                <a:latin typeface="Calibri"/>
-              </a:defRPr>
-            </a:pPr>
-            <a:r>
-              <a:t>• Pojawienie się nowej przeszkody (np. pieszy, paleta) generuje błąd predykcji, pobudzając ciekawość i bezpieczne ominięcie.</a:t>
+              <a:t>Wklej schemat sieci neuronowej: Stan s_t, Akcja a_t -&gt; Forward Model -&gt; r_i</a:t>
+            </a:r>
+            <a:br/>
+            <a:r>
+              <a:t>(Możesz użyć schematu z wniosku grantowego lub grafiki wektorowej)</a:t>
             </a:r>
           </a:p>
         </p:txBody>
@@ -10954,7 +10744,7 @@
               <a:spcAft>
                 <a:spcPts val="0"/>
               </a:spcAft>
-              <a:defRPr sz="2300" b="1">
+              <a:defRPr sz="2200" b="1">
                 <a:solidFill>
                   <a:srgbClr val="191919"/>
                 </a:solidFill>
@@ -10962,7 +10752,7 @@
               </a:defRPr>
             </a:pPr>
             <a:r>
-              <a:t>Transfer wiedzy Sim-to-Real i Domain Randomization</a:t>
+              <a:t>Transfer Sim-to-Real i Domain Randomization</a:t>
             </a:r>
           </a:p>
         </p:txBody>
@@ -10976,17 +10766,17 @@
         <p:spPr>
           <a:xfrm>
             <a:off x="594360" y="1691640"/>
-            <a:ext cx="3840480" cy="4389120"/>
+            <a:ext cx="3840480" cy="1463040"/>
           </a:xfrm>
           <a:prstGeom prst="roundRect">
             <a:avLst/>
           </a:prstGeom>
           <a:solidFill>
-            <a:srgbClr val="F8F9FA"/>
+            <a:srgbClr val="F8FAFC"/>
           </a:solidFill>
           <a:ln w="15240">
             <a:solidFill>
-              <a:srgbClr val="DCE0E6"/>
+              <a:srgbClr val="DAE0E9"/>
             </a:solidFill>
           </a:ln>
         </p:spPr>
@@ -11010,9 +10800,9 @@
           <a:p>
             <a:pPr algn="l">
               <a:spcAft>
-                <a:spcPts val="1000"/>
-              </a:spcAft>
-              <a:defRPr sz="1600" b="1">
+                <a:spcPts val="200"/>
+              </a:spcAft>
+              <a:defRPr sz="1400" b="1">
                 <a:solidFill>
                   <a:srgbClr val="0D47A1"/>
                 </a:solidFill>
@@ -11020,15 +10810,15 @@
               </a:defRPr>
             </a:pPr>
             <a:r>
-              <a:t>Krok 1: NVIDIA Isaac Sim</a:t>
+              <a:t>1. NVIDIA Isaac Sim</a:t>
             </a:r>
           </a:p>
           <a:p>
             <a:pPr algn="l">
               <a:spcAft>
-                <a:spcPts val="600"/>
-              </a:spcAft>
-              <a:defRPr sz="1300" b="1">
+                <a:spcPts val="0"/>
+              </a:spcAft>
+              <a:defRPr sz="1100" b="0">
                 <a:solidFill>
                   <a:srgbClr val="191919"/>
                 </a:solidFill>
@@ -11036,87 +10826,11 @@
               </a:defRPr>
             </a:pPr>
             <a:r>
-              <a:t>Fotorealistyczne środowisko 3D:</a:t>
-            </a:r>
-          </a:p>
-          <a:p>
-            <a:pPr algn="l">
-              <a:spcAft>
-                <a:spcPts val="600"/>
-              </a:spcAft>
-              <a:defRPr sz="1300" b="0">
-                <a:solidFill>
-                  <a:srgbClr val="505050"/>
-                </a:solidFill>
-                <a:latin typeface="Calibri"/>
-              </a:defRPr>
-            </a:pPr>
-            <a:r>
-              <a:t>• Silnik NVIDIA PhysX oraz akceleracja RTX zapewniają wierne odwzorowanie fizyki i optyki.</a:t>
-            </a:r>
-          </a:p>
-          <a:p>
-            <a:pPr algn="l">
-              <a:spcAft>
-                <a:spcPts val="600"/>
-              </a:spcAft>
-              <a:defRPr sz="1300" b="1">
-                <a:solidFill>
-                  <a:srgbClr val="191919"/>
-                </a:solidFill>
-                <a:latin typeface="Calibri"/>
-              </a:defRPr>
-            </a:pPr>
-            <a:r>
-              <a:t>Emulacja sensorów w czasie rzeczywistym:</a:t>
-            </a:r>
-          </a:p>
-          <a:p>
-            <a:pPr algn="l">
-              <a:spcAft>
-                <a:spcPts val="600"/>
-              </a:spcAft>
-              <a:defRPr sz="1300" b="0">
-                <a:solidFill>
-                  <a:srgbClr val="505050"/>
-                </a:solidFill>
-                <a:latin typeface="Calibri"/>
-              </a:defRPr>
-            </a:pPr>
-            <a:r>
-              <a:t>• Generowanie wiązek LiDAR 2D/3D, odczytów enkoderów, kamer RGB-D i dynamiki podwozia AGV.</a:t>
-            </a:r>
-          </a:p>
-          <a:p>
-            <a:pPr algn="l">
-              <a:spcAft>
-                <a:spcPts val="600"/>
-              </a:spcAft>
-              <a:defRPr sz="1300" b="1">
-                <a:solidFill>
-                  <a:srgbClr val="191919"/>
-                </a:solidFill>
-                <a:latin typeface="Calibri"/>
-              </a:defRPr>
-            </a:pPr>
-            <a:r>
-              <a:t>Wielowątkowy trening masowy:</a:t>
-            </a:r>
-          </a:p>
-          <a:p>
-            <a:pPr algn="l">
-              <a:spcAft>
-                <a:spcPts val="600"/>
-              </a:spcAft>
-              <a:defRPr sz="1300" b="0">
-                <a:solidFill>
-                  <a:srgbClr val="505050"/>
-                </a:solidFill>
-                <a:latin typeface="Calibri"/>
-              </a:defRPr>
-            </a:pPr>
-            <a:r>
-              <a:t>• Tysiące wirtualnych instancji robotów trenujących równolegle w chmurze obliczeniowej.</a:t>
+              <a:t>• Fotorealistyczna fizyka PhysX &amp; RTX.</a:t>
+            </a:r>
+            <a:br/>
+            <a:r>
+              <a:t>• Masowy, równoległy trening floty w chmurze.</a:t>
             </a:r>
           </a:p>
         </p:txBody>
@@ -11130,17 +10844,17 @@
         <p:spPr>
           <a:xfrm>
             <a:off x="4754880" y="1691640"/>
-            <a:ext cx="3840480" cy="4389120"/>
+            <a:ext cx="3840480" cy="1463040"/>
           </a:xfrm>
           <a:prstGeom prst="roundRect">
             <a:avLst/>
           </a:prstGeom>
           <a:solidFill>
-            <a:srgbClr val="F8F9FA"/>
+            <a:srgbClr val="F8FAFC"/>
           </a:solidFill>
           <a:ln w="15240">
             <a:solidFill>
-              <a:srgbClr val="DCE0E6"/>
+              <a:srgbClr val="DAE0E9"/>
             </a:solidFill>
           </a:ln>
         </p:spPr>
@@ -11164,9 +10878,9 @@
           <a:p>
             <a:pPr algn="l">
               <a:spcAft>
-                <a:spcPts val="1000"/>
-              </a:spcAft>
-              <a:defRPr sz="1600" b="1">
+                <a:spcPts val="200"/>
+              </a:spcAft>
+              <a:defRPr sz="1400" b="1">
                 <a:solidFill>
                   <a:srgbClr val="0D47A1"/>
                 </a:solidFill>
@@ -11174,15 +10888,15 @@
               </a:defRPr>
             </a:pPr>
             <a:r>
-              <a:t>Krok 2: Domain Randomization</a:t>
+              <a:t>2. Domain Randomization</a:t>
             </a:r>
           </a:p>
           <a:p>
             <a:pPr algn="l">
               <a:spcAft>
-                <a:spcPts val="600"/>
-              </a:spcAft>
-              <a:defRPr sz="1300" b="1">
+                <a:spcPts val="0"/>
+              </a:spcAft>
+              <a:defRPr sz="1100" b="0">
                 <a:solidFill>
                   <a:srgbClr val="191919"/>
                 </a:solidFill>
@@ -11190,95 +10904,11 @@
               </a:defRPr>
             </a:pPr>
             <a:r>
-              <a:t>Zwalczanie Reality Gap:</a:t>
-            </a:r>
-          </a:p>
-          <a:p>
-            <a:pPr algn="l">
-              <a:spcAft>
-                <a:spcPts val="600"/>
-              </a:spcAft>
-              <a:defRPr sz="1300" b="0">
-                <a:solidFill>
-                  <a:srgbClr val="505050"/>
-                </a:solidFill>
-                <a:latin typeface="Calibri"/>
-              </a:defRPr>
-            </a:pPr>
-            <a:r>
-              <a:t>• Sztuczne różnicowanie warunków symulacji uodparnia sieć neuronową na niedoskonałości świata realnego.</a:t>
-            </a:r>
-          </a:p>
-          <a:p>
-            <a:pPr algn="l">
-              <a:spcAft>
-                <a:spcPts val="600"/>
-              </a:spcAft>
-              <a:defRPr sz="1300" b="1">
-                <a:solidFill>
-                  <a:srgbClr val="191919"/>
-                </a:solidFill>
-                <a:latin typeface="Calibri"/>
-              </a:defRPr>
-            </a:pPr>
-            <a:r>
-              <a:t>Parametry losowe:</a:t>
-            </a:r>
-          </a:p>
-          <a:p>
-            <a:pPr algn="l">
-              <a:spcAft>
-                <a:spcPts val="600"/>
-              </a:spcAft>
-              <a:defRPr sz="1300" b="0">
-                <a:solidFill>
-                  <a:srgbClr val="505050"/>
-                </a:solidFill>
-                <a:latin typeface="Calibri"/>
-              </a:defRPr>
-            </a:pPr>
-            <a:r>
-              <a:t>• • Współczynnik tarcia kół: mi in [0.35, 0.95]</a:t>
+              <a:t>• Zmienne tarcie kół (μ: 0.35-0.95), masa palet.</a:t>
             </a:r>
             <a:br/>
             <a:r>
-              <a:t>• Masa ładunku paletowego: +/- 30%</a:t>
-            </a:r>
-            <a:br/>
-            <a:r>
-              <a:t>• Opóźnienia magistrali komunikacyjnej (Jitter): 5-50 ms</a:t>
-            </a:r>
-          </a:p>
-          <a:p>
-            <a:pPr algn="l">
-              <a:spcAft>
-                <a:spcPts val="600"/>
-              </a:spcAft>
-              <a:defRPr sz="1300" b="1">
-                <a:solidFill>
-                  <a:srgbClr val="191919"/>
-                </a:solidFill>
-                <a:latin typeface="Calibri"/>
-              </a:defRPr>
-            </a:pPr>
-            <a:r>
-              <a:t>Szum sensoryczny:</a:t>
-            </a:r>
-          </a:p>
-          <a:p>
-            <a:pPr algn="l">
-              <a:spcAft>
-                <a:spcPts val="600"/>
-              </a:spcAft>
-              <a:defRPr sz="1300" b="0">
-                <a:solidFill>
-                  <a:srgbClr val="505050"/>
-                </a:solidFill>
-                <a:latin typeface="Calibri"/>
-              </a:defRPr>
-            </a:pPr>
-            <a:r>
-              <a:t>• Symulacja dryfu żyroskopu, martwych stref LiDAR i zmiennego oświetlenia hali fabrycznej.</a:t>
+              <a:t>• Syntetyczny jitter i szum sensoryczny LiDAR.</a:t>
             </a:r>
           </a:p>
         </p:txBody>
@@ -11292,17 +10922,17 @@
         <p:spPr>
           <a:xfrm>
             <a:off x="8915400" y="1691640"/>
-            <a:ext cx="3840480" cy="4389120"/>
+            <a:ext cx="3840480" cy="1463040"/>
           </a:xfrm>
           <a:prstGeom prst="roundRect">
             <a:avLst/>
           </a:prstGeom>
           <a:solidFill>
-            <a:srgbClr val="F8F9FA"/>
+            <a:srgbClr val="F8FAFC"/>
           </a:solidFill>
           <a:ln w="15240">
             <a:solidFill>
-              <a:srgbClr val="DCE0E6"/>
+              <a:srgbClr val="DAE0E9"/>
             </a:solidFill>
           </a:ln>
         </p:spPr>
@@ -11326,9 +10956,9 @@
           <a:p>
             <a:pPr algn="l">
               <a:spcAft>
-                <a:spcPts val="1000"/>
-              </a:spcAft>
-              <a:defRPr sz="1600" b="1">
+                <a:spcPts val="200"/>
+              </a:spcAft>
+              <a:defRPr sz="1400" b="1">
                 <a:solidFill>
                   <a:srgbClr val="0D47A1"/>
                 </a:solidFill>
@@ -11336,103 +10966,175 @@
               </a:defRPr>
             </a:pPr>
             <a:r>
-              <a:t>Krok 3: Zero-Shot Transfer</a:t>
+              <a:t>3. Zero-Shot Transfer</a:t>
             </a:r>
           </a:p>
           <a:p>
             <a:pPr algn="l">
               <a:spcAft>
-                <a:spcPts val="600"/>
+                <a:spcPts val="0"/>
+              </a:spcAft>
+              <a:defRPr sz="1100" b="0">
+                <a:solidFill>
+                  <a:srgbClr val="191919"/>
+                </a:solidFill>
+                <a:latin typeface="Calibri"/>
+              </a:defRPr>
+            </a:pPr>
+            <a:r>
+              <a:t>• Eksport do formatu TensorRT na Jetson Orin.</a:t>
+            </a:r>
+            <a:br/>
+            <a:r>
+              <a:t>• Bezpośrednie wdrożenie: -75% testów na hali.</a:t>
+            </a:r>
+          </a:p>
+        </p:txBody>
+      </p:sp>
+      <p:sp>
+        <p:nvSpPr>
+          <p:cNvPr id="6" name="Rounded Rectangle 5"/>
+          <p:cNvSpPr/>
+          <p:nvPr/>
+        </p:nvSpPr>
+        <p:spPr>
+          <a:xfrm>
+            <a:off x="594360" y="3337560"/>
+            <a:ext cx="5852160" cy="2834640"/>
+          </a:xfrm>
+          <a:prstGeom prst="roundRect">
+            <a:avLst/>
+          </a:prstGeom>
+          <a:solidFill>
+            <a:srgbClr val="EEF4FA"/>
+          </a:solidFill>
+          <a:ln w="19050">
+            <a:solidFill>
+              <a:srgbClr val="8CAFD2"/>
+            </a:solidFill>
+          </a:ln>
+        </p:spPr>
+        <p:style>
+          <a:lnRef idx="1">
+            <a:schemeClr val="accent1"/>
+          </a:lnRef>
+          <a:fillRef idx="3">
+            <a:schemeClr val="accent1"/>
+          </a:fillRef>
+          <a:effectRef idx="2">
+            <a:schemeClr val="accent1"/>
+          </a:effectRef>
+          <a:fontRef idx="minor">
+            <a:schemeClr val="lt1"/>
+          </a:fontRef>
+        </p:style>
+        <p:txBody>
+          <a:bodyPr rtlCol="0" anchor="ctr" wrap="square"/>
+          <a:lstStyle/>
+          <a:p>
+            <a:pPr algn="ctr">
+              <a:spcAft>
+                <a:spcPts val="300"/>
               </a:spcAft>
               <a:defRPr sz="1300" b="1">
                 <a:solidFill>
-                  <a:srgbClr val="191919"/>
+                  <a:srgbClr val="0D47A1"/>
                 </a:solidFill>
                 <a:latin typeface="Calibri"/>
               </a:defRPr>
             </a:pPr>
             <a:r>
-              <a:t>Wdrożenie na platformie brzegowej:</a:t>
-            </a:r>
-          </a:p>
-          <a:p>
-            <a:pPr algn="l">
-              <a:spcAft>
-                <a:spcPts val="600"/>
-              </a:spcAft>
-              <a:defRPr sz="1300" b="0">
-                <a:solidFill>
-                  <a:srgbClr val="505050"/>
+              <a:t>🖼 WIDEO / GRAFIKA: Symulacja w Isaac Sim</a:t>
+            </a:r>
+          </a:p>
+          <a:p>
+            <a:pPr algn="ctr">
+              <a:spcAft>
+                <a:spcPts val="0"/>
+              </a:spcAft>
+              <a:defRPr sz="1000" b="0">
+                <a:solidFill>
+                  <a:srgbClr val="5A5F64"/>
                 </a:solidFill>
                 <a:latin typeface="Calibri"/>
               </a:defRPr>
             </a:pPr>
             <a:r>
-              <a:t>• Eksport wytrenowanej polityki do formatu NVIDIA TensorRT na układzie Jetson Orin NX.</a:t>
-            </a:r>
-          </a:p>
-          <a:p>
-            <a:pPr algn="l">
-              <a:spcAft>
-                <a:spcPts val="600"/>
+              <a:t>Wklej zrzut ekranu lub animację renderowania sceny magazynowej z promieniami LiDAR</a:t>
+            </a:r>
+          </a:p>
+        </p:txBody>
+      </p:sp>
+      <p:sp>
+        <p:nvSpPr>
+          <p:cNvPr id="7" name="Rounded Rectangle 6"/>
+          <p:cNvSpPr/>
+          <p:nvPr/>
+        </p:nvSpPr>
+        <p:spPr>
+          <a:xfrm>
+            <a:off x="6766560" y="3337560"/>
+            <a:ext cx="5852160" cy="2834640"/>
+          </a:xfrm>
+          <a:prstGeom prst="roundRect">
+            <a:avLst/>
+          </a:prstGeom>
+          <a:solidFill>
+            <a:srgbClr val="EEF4FA"/>
+          </a:solidFill>
+          <a:ln w="19050">
+            <a:solidFill>
+              <a:srgbClr val="8CAFD2"/>
+            </a:solidFill>
+          </a:ln>
+        </p:spPr>
+        <p:style>
+          <a:lnRef idx="1">
+            <a:schemeClr val="accent1"/>
+          </a:lnRef>
+          <a:fillRef idx="3">
+            <a:schemeClr val="accent1"/>
+          </a:fillRef>
+          <a:effectRef idx="2">
+            <a:schemeClr val="accent1"/>
+          </a:effectRef>
+          <a:fontRef idx="minor">
+            <a:schemeClr val="lt1"/>
+          </a:fontRef>
+        </p:style>
+        <p:txBody>
+          <a:bodyPr rtlCol="0" anchor="ctr" wrap="square"/>
+          <a:lstStyle/>
+          <a:p>
+            <a:pPr algn="ctr">
+              <a:spcAft>
+                <a:spcPts val="300"/>
               </a:spcAft>
               <a:defRPr sz="1300" b="1">
                 <a:solidFill>
-                  <a:srgbClr val="191919"/>
+                  <a:srgbClr val="0D47A1"/>
                 </a:solidFill>
                 <a:latin typeface="Calibri"/>
               </a:defRPr>
             </a:pPr>
             <a:r>
-              <a:t>Bezpośredni transfer (Zero-Shot):</a:t>
-            </a:r>
-          </a:p>
-          <a:p>
-            <a:pPr algn="l">
-              <a:spcAft>
-                <a:spcPts val="600"/>
-              </a:spcAft>
-              <a:defRPr sz="1300" b="0">
-                <a:solidFill>
-                  <a:srgbClr val="505050"/>
+              <a:t>🖼 ZDJĘCIE / WIDEO: Fizyczny AGV na posadzce</a:t>
+            </a:r>
+          </a:p>
+          <a:p>
+            <a:pPr algn="ctr">
+              <a:spcAft>
+                <a:spcPts val="0"/>
+              </a:spcAft>
+              <a:defRPr sz="1000" b="0">
+                <a:solidFill>
+                  <a:srgbClr val="5A5F64"/>
                 </a:solidFill>
                 <a:latin typeface="Calibri"/>
               </a:defRPr>
             </a:pPr>
             <a:r>
-              <a:t>• Polityka sterowania działa na fizycznym pojeździe bez konieczności niebezpiecznego dotrenowywania na hali.</a:t>
-            </a:r>
-          </a:p>
-          <a:p>
-            <a:pPr algn="l">
-              <a:spcAft>
-                <a:spcPts val="600"/>
-              </a:spcAft>
-              <a:defRPr sz="1300" b="1">
-                <a:solidFill>
-                  <a:srgbClr val="191919"/>
-                </a:solidFill>
-                <a:latin typeface="Calibri"/>
-              </a:defRPr>
-            </a:pPr>
-            <a:r>
-              <a:t>Kluczowy rezultat:</a:t>
-            </a:r>
-          </a:p>
-          <a:p>
-            <a:pPr algn="l">
-              <a:spcAft>
-                <a:spcPts val="600"/>
-              </a:spcAft>
-              <a:defRPr sz="1300" b="0">
-                <a:solidFill>
-                  <a:srgbClr val="505050"/>
-                </a:solidFill>
-                <a:latin typeface="Calibri"/>
-              </a:defRPr>
-            </a:pPr>
-            <a:r>
-              <a:t>• Oszczędność czasu i kosztów: redukcja fizycznych testów poligonowych o ponad 75%.</a:t>
+              <a:t>Wklej zdjęcie fizycznego wózka AGV lub stanowiska testowego koła Sensor</a:t>
             </a:r>
           </a:p>
         </p:txBody>
@@ -11495,7 +11197,7 @@
               <a:spcAft>
                 <a:spcPts val="0"/>
               </a:spcAft>
-              <a:defRPr sz="2300" b="1">
+              <a:defRPr sz="2200" b="1">
                 <a:solidFill>
                   <a:srgbClr val="191919"/>
                 </a:solidFill>
@@ -11575,15 +11277,15 @@
               <a:spcAft>
                 <a:spcPts val="0"/>
               </a:spcAft>
-              <a:defRPr sz="1000" b="0">
-                <a:solidFill>
-                  <a:srgbClr val="505050"/>
+              <a:defRPr sz="1000" b="1">
+                <a:solidFill>
+                  <a:srgbClr val="990000"/>
                 </a:solidFill>
                 <a:latin typeface="Calibri"/>
               </a:defRPr>
             </a:pPr>
             <a:r>
-              <a:t>Rys. 1. Stanowisko Cyfrowego Bliźniaka AGV (Three.js/WebGL): Porównanie AGV-01 (Neuro-Curiosity) oraz AGV-02 (Baseline) na arenie 100x100m z telemetrią na żywo.</a:t>
+              <a:t>▶ LIVE DEMO W PRZEGLĄDARCE: http://localhost:8080 (Three.js WebGL + arena 100x100m + telemetria)</a:t>
             </a:r>
           </a:p>
         </p:txBody>
@@ -11597,17 +11299,17 @@
         <p:spPr>
           <a:xfrm>
             <a:off x="7818120" y="1691640"/>
-            <a:ext cx="4754880" cy="4572000"/>
+            <a:ext cx="4754880" cy="1280160"/>
           </a:xfrm>
           <a:prstGeom prst="roundRect">
             <a:avLst/>
           </a:prstGeom>
           <a:solidFill>
-            <a:srgbClr val="F8F9FA"/>
+            <a:srgbClr val="F8FAFC"/>
           </a:solidFill>
           <a:ln w="15240">
             <a:solidFill>
-              <a:srgbClr val="DCE0E6"/>
+              <a:srgbClr val="DAE0E9"/>
             </a:solidFill>
           </a:ln>
         </p:spPr>
@@ -11631,25 +11333,25 @@
           <a:p>
             <a:pPr algn="l">
               <a:spcAft>
-                <a:spcPts val="1000"/>
-              </a:spcAft>
-              <a:defRPr sz="1600" b="1">
-                <a:solidFill>
-                  <a:srgbClr val="990000"/>
+                <a:spcPts val="200"/>
+              </a:spcAft>
+              <a:defRPr sz="1400" b="1">
+                <a:solidFill>
+                  <a:srgbClr val="006633"/>
                 </a:solidFill>
                 <a:latin typeface="Calibri"/>
               </a:defRPr>
             </a:pPr>
             <a:r>
-              <a:t>Stos technologiczny platformy</a:t>
+              <a:t>Pokładowe Edge AI: NVIDIA Jetson Orin NX</a:t>
             </a:r>
           </a:p>
           <a:p>
             <a:pPr algn="l">
               <a:spcAft>
-                <a:spcPts val="400"/>
-              </a:spcAft>
-              <a:defRPr sz="1200" b="1">
+                <a:spcPts val="0"/>
+              </a:spcAft>
+              <a:defRPr sz="1100" b="0">
                 <a:solidFill>
                   <a:srgbClr val="191919"/>
                 </a:solidFill>
@@ -11657,31 +11359,77 @@
               </a:defRPr>
             </a:pPr>
             <a:r>
-              <a:t>Edge AI – NVIDIA Jetson Orin NX:</a:t>
-            </a:r>
-          </a:p>
+              <a:t>• Czas inferencji: &lt; 15 ms (brak opóźnień chmury).</a:t>
+            </a:r>
+            <a:br/>
+            <a:r>
+              <a:t>• Do 100 TOPS mocy obliczeniowej dla sieci neuronowych.</a:t>
+            </a:r>
+          </a:p>
+        </p:txBody>
+      </p:sp>
+      <p:sp>
+        <p:nvSpPr>
+          <p:cNvPr id="6" name="Rounded Rectangle 5"/>
+          <p:cNvSpPr/>
+          <p:nvPr/>
+        </p:nvSpPr>
+        <p:spPr>
+          <a:xfrm>
+            <a:off x="7818120" y="3108960"/>
+            <a:ext cx="4754880" cy="1280160"/>
+          </a:xfrm>
+          <a:prstGeom prst="roundRect">
+            <a:avLst/>
+          </a:prstGeom>
+          <a:solidFill>
+            <a:srgbClr val="F8FAFC"/>
+          </a:solidFill>
+          <a:ln w="15240">
+            <a:solidFill>
+              <a:srgbClr val="DAE0E9"/>
+            </a:solidFill>
+          </a:ln>
+        </p:spPr>
+        <p:style>
+          <a:lnRef idx="1">
+            <a:schemeClr val="accent1"/>
+          </a:lnRef>
+          <a:fillRef idx="3">
+            <a:schemeClr val="accent1"/>
+          </a:fillRef>
+          <a:effectRef idx="2">
+            <a:schemeClr val="accent1"/>
+          </a:effectRef>
+          <a:fontRef idx="minor">
+            <a:schemeClr val="lt1"/>
+          </a:fontRef>
+        </p:style>
+        <p:txBody>
+          <a:bodyPr rtlCol="0" anchor="t" wrap="square"/>
+          <a:lstStyle/>
           <a:p>
             <a:pPr algn="l">
               <a:spcAft>
-                <a:spcPts val="400"/>
-              </a:spcAft>
-              <a:defRPr sz="1200" b="0">
-                <a:solidFill>
-                  <a:srgbClr val="505050"/>
+                <a:spcPts val="200"/>
+              </a:spcAft>
+              <a:defRPr sz="1400" b="1">
+                <a:solidFill>
+                  <a:srgbClr val="0D47A1"/>
                 </a:solidFill>
                 <a:latin typeface="Calibri"/>
               </a:defRPr>
             </a:pPr>
             <a:r>
-              <a:t>• Kompaktowy moduł pokładowy (do 100 TOPS AI). Autonomiczne podejmowanie decyzji w czasie &lt;15 ms bez opóźnień chmurowych.</a:t>
+              <a:t>Szyna danych IIoT: Kafka + TimescaleDB</a:t>
             </a:r>
           </a:p>
           <a:p>
             <a:pPr algn="l">
               <a:spcAft>
-                <a:spcPts val="400"/>
-              </a:spcAft>
-              <a:defRPr sz="1200" b="1">
+                <a:spcPts val="0"/>
+              </a:spcAft>
+              <a:defRPr sz="1100" b="0">
                 <a:solidFill>
                   <a:srgbClr val="191919"/>
                 </a:solidFill>
@@ -11689,123 +11437,89 @@
               </a:defRPr>
             </a:pPr>
             <a:r>
-              <a:t>Szyna danych IIoT – Apache Kafka:</a:t>
-            </a:r>
-          </a:p>
-          <a:p>
-            <a:pPr algn="l">
-              <a:spcAft>
-                <a:spcPts val="400"/>
-              </a:spcAft>
-              <a:defRPr sz="1200" b="0">
-                <a:solidFill>
-                  <a:srgbClr val="505050"/>
+              <a:t>• Apache Kafka: asynchroniczny broker telemetrii.</a:t>
+            </a:r>
+            <a:br/>
+            <a:r>
+              <a:t>• TimescaleDB + Spark: analiza anomalii i przeciążeń.</a:t>
+            </a:r>
+          </a:p>
+        </p:txBody>
+      </p:sp>
+      <p:sp>
+        <p:nvSpPr>
+          <p:cNvPr id="7" name="Rounded Rectangle 6"/>
+          <p:cNvSpPr/>
+          <p:nvPr/>
+        </p:nvSpPr>
+        <p:spPr>
+          <a:xfrm>
+            <a:off x="7818120" y="4526280"/>
+            <a:ext cx="4754880" cy="1645920"/>
+          </a:xfrm>
+          <a:prstGeom prst="roundRect">
+            <a:avLst/>
+          </a:prstGeom>
+          <a:solidFill>
+            <a:srgbClr val="EEF4FA"/>
+          </a:solidFill>
+          <a:ln w="19050">
+            <a:solidFill>
+              <a:srgbClr val="8CAFD2"/>
+            </a:solidFill>
+          </a:ln>
+        </p:spPr>
+        <p:style>
+          <a:lnRef idx="1">
+            <a:schemeClr val="accent1"/>
+          </a:lnRef>
+          <a:fillRef idx="3">
+            <a:schemeClr val="accent1"/>
+          </a:fillRef>
+          <a:effectRef idx="2">
+            <a:schemeClr val="accent1"/>
+          </a:effectRef>
+          <a:fontRef idx="minor">
+            <a:schemeClr val="lt1"/>
+          </a:fontRef>
+        </p:style>
+        <p:txBody>
+          <a:bodyPr rtlCol="0" anchor="ctr" wrap="square"/>
+          <a:lstStyle/>
+          <a:p>
+            <a:pPr algn="ctr">
+              <a:spcAft>
+                <a:spcPts val="300"/>
+              </a:spcAft>
+              <a:defRPr sz="1300" b="1">
+                <a:solidFill>
+                  <a:srgbClr val="0D47A1"/>
                 </a:solidFill>
                 <a:latin typeface="Calibri"/>
               </a:defRPr>
             </a:pPr>
             <a:r>
-              <a:t>• Wysokoprzepustowy broker zdarzeń przesyłający telemetrię pojazdów, stany LiDAR oraz metryki ciekawości.</a:t>
-            </a:r>
-          </a:p>
-          <a:p>
-            <a:pPr algn="l">
-              <a:spcAft>
-                <a:spcPts val="400"/>
-              </a:spcAft>
-              <a:defRPr sz="1200" b="1">
-                <a:solidFill>
-                  <a:srgbClr val="191919"/>
+              <a:t>🖼 MIEJSCE NA KLIP WIDEO Z PRZEJAZDU AGV</a:t>
+            </a:r>
+          </a:p>
+          <a:p>
+            <a:pPr algn="ctr">
+              <a:spcAft>
+                <a:spcPts val="0"/>
+              </a:spcAft>
+              <a:defRPr sz="1000" b="0">
+                <a:solidFill>
+                  <a:srgbClr val="5A5F64"/>
                 </a:solidFill>
                 <a:latin typeface="Calibri"/>
               </a:defRPr>
             </a:pPr>
             <a:r>
-              <a:t>Analiza i przechowywanie:</a:t>
-            </a:r>
-          </a:p>
-          <a:p>
-            <a:pPr algn="l">
-              <a:spcAft>
-                <a:spcPts val="400"/>
-              </a:spcAft>
-              <a:defRPr sz="1200" b="0">
-                <a:solidFill>
-                  <a:srgbClr val="505050"/>
-                </a:solidFill>
-                <a:latin typeface="Calibri"/>
-              </a:defRPr>
-            </a:pPr>
-            <a:r>
-              <a:t>• • TimescaleDB – hybrydowa baza szeregów czasowych</a:t>
+              <a:t>Wstaw krótki filmik MP4 pokazujący omijanie przeszkód w 3D</a:t>
             </a:r>
             <a:br/>
             <a:r>
-              <a:t>• Apache Spark Streaming – analityka anomalii i szarpnięć</a:t>
-            </a:r>
-          </a:p>
-          <a:p>
-            <a:pPr algn="l">
-              <a:spcAft>
-                <a:spcPts val="400"/>
-              </a:spcAft>
-              <a:defRPr sz="1200" b="1">
-                <a:solidFill>
-                  <a:srgbClr val="191919"/>
-                </a:solidFill>
-                <a:latin typeface="Calibri"/>
-              </a:defRPr>
-            </a:pPr>
-            <a:r>
-              <a:t>Wizualizacja i Nadzór Floty (Three.js &amp; Grafana):</a:t>
-            </a:r>
-          </a:p>
-          <a:p>
-            <a:pPr algn="l">
-              <a:spcAft>
-                <a:spcPts val="400"/>
-              </a:spcAft>
-              <a:defRPr sz="1200" b="0">
-                <a:solidFill>
-                  <a:srgbClr val="505050"/>
-                </a:solidFill>
-                <a:latin typeface="Calibri"/>
-              </a:defRPr>
-            </a:pPr>
-            <a:r>
-              <a:t>• Wirtualna reprezentacja fabryki 3D, geofencing, dynamiczne wykrywanie kolizji i monitoring akumulatorów na żywo.</a:t>
-            </a:r>
-          </a:p>
-          <a:p>
-            <a:pPr algn="l">
-              <a:spcAft>
-                <a:spcPts val="400"/>
-              </a:spcAft>
-              <a:defRPr sz="1200" b="1">
-                <a:solidFill>
-                  <a:srgbClr val="191919"/>
-                </a:solidFill>
-                <a:latin typeface="Calibri"/>
-              </a:defRPr>
-            </a:pPr>
-            <a:r>
-              <a:t>Wkład inżynierski Patryka Pięty:</a:t>
-            </a:r>
-          </a:p>
-          <a:p>
-            <a:pPr algn="l">
-              <a:spcAft>
-                <a:spcPts val="400"/>
-              </a:spcAft>
-              <a:defRPr sz="1200" b="0">
-                <a:solidFill>
-                  <a:srgbClr val="505050"/>
-                </a:solidFill>
-                <a:latin typeface="Calibri"/>
-              </a:defRPr>
-            </a:pPr>
-            <a:r>
-              <a:t>• Kompletna platforma Digital Twin integrująca modele fizyczne z algorytmami AI SKN Sensor.</a:t>
+              <a:t>(Wstawianie -&gt; Wideo na tym urządzeniu)</a:t>
             </a:r>
           </a:p>
         </p:txBody>
@@ -11860,7 +11574,7 @@
               </a:defRPr>
             </a:pPr>
             <a:r>
-              <a:t>METODYKA EWALUACJI</a:t>
+              <a:t>EWALUACJA EMPIRYCZNA</a:t>
             </a:r>
           </a:p>
           <a:p>
@@ -11868,7 +11582,7 @@
               <a:spcAft>
                 <a:spcPts val="0"/>
               </a:spcAft>
-              <a:defRPr sz="2300" b="1">
+              <a:defRPr sz="2200" b="1">
                 <a:solidFill>
                   <a:srgbClr val="191919"/>
                 </a:solidFill>
@@ -11876,7 +11590,7 @@
               </a:defRPr>
             </a:pPr>
             <a:r>
-              <a:t>Badania porównawcze i rygorystyczna weryfikacja statystyczna</a:t>
+              <a:t>Weryfikacja statystyczna i kluczowe wskaźniki</a:t>
             </a:r>
           </a:p>
         </p:txBody>
@@ -11890,17 +11604,17 @@
         <p:spPr>
           <a:xfrm>
             <a:off x="594360" y="1691640"/>
-            <a:ext cx="5852160" cy="4389120"/>
+            <a:ext cx="5120640" cy="1325880"/>
           </a:xfrm>
           <a:prstGeom prst="roundRect">
             <a:avLst/>
           </a:prstGeom>
           <a:solidFill>
-            <a:srgbClr val="F8F9FA"/>
+            <a:srgbClr val="F0F9F4"/>
           </a:solidFill>
           <a:ln w="15240">
             <a:solidFill>
-              <a:srgbClr val="DCE0E6"/>
+              <a:srgbClr val="DAE0E9"/>
             </a:solidFill>
           </a:ln>
         </p:spPr>
@@ -11924,9 +11638,9 @@
           <a:p>
             <a:pPr algn="l">
               <a:spcAft>
-                <a:spcPts val="1000"/>
-              </a:spcAft>
-              <a:defRPr sz="1700" b="1">
+                <a:spcPts val="200"/>
+              </a:spcAft>
+              <a:defRPr sz="1500" b="1">
                 <a:solidFill>
                   <a:srgbClr val="006633"/>
                 </a:solidFill>
@@ -11934,15 +11648,15 @@
               </a:defRPr>
             </a:pPr>
             <a:r>
-              <a:t>Metryki efektywności i bezpieczeństwa</a:t>
+              <a:t>+85%  Średnia droga bezkolizyjna</a:t>
             </a:r>
           </a:p>
           <a:p>
             <a:pPr algn="l">
               <a:spcAft>
-                <a:spcPts val="500"/>
-              </a:spcAft>
-              <a:defRPr sz="1300" b="1">
+                <a:spcPts val="0"/>
+              </a:spcAft>
+              <a:defRPr sz="1100" b="0">
                 <a:solidFill>
                   <a:srgbClr val="191919"/>
                 </a:solidFill>
@@ -11950,119 +11664,7 @@
               </a:defRPr>
             </a:pPr>
             <a:r>
-              <a:t>Średnia droga bezkolizyjna (Mean Free Path):</a:t>
-            </a:r>
-          </a:p>
-          <a:p>
-            <a:pPr algn="l">
-              <a:spcAft>
-                <a:spcPts val="500"/>
-              </a:spcAft>
-              <a:defRPr sz="1300" b="0">
-                <a:solidFill>
-                  <a:srgbClr val="505050"/>
-                </a:solidFill>
-                <a:latin typeface="Calibri"/>
-              </a:defRPr>
-            </a:pPr>
-            <a:r>
-              <a:t>• Mierzona odległość przebyta przez AGV w złożonym magazynie bez naruszenia strefy bezpieczeństwa (geofence/przeszkody).</a:t>
-            </a:r>
-          </a:p>
-          <a:p>
-            <a:pPr algn="l">
-              <a:spcAft>
-                <a:spcPts val="500"/>
-              </a:spcAft>
-              <a:defRPr sz="1300" b="1">
-                <a:solidFill>
-                  <a:srgbClr val="191919"/>
-                </a:solidFill>
-                <a:latin typeface="Calibri"/>
-              </a:defRPr>
-            </a:pPr>
-            <a:r>
-              <a:t>Wskaźnik szarpnięcia (Jerk Metric):</a:t>
-            </a:r>
-          </a:p>
-          <a:p>
-            <a:pPr algn="l">
-              <a:spcAft>
-                <a:spcPts val="500"/>
-              </a:spcAft>
-              <a:defRPr sz="1300" b="0">
-                <a:solidFill>
-                  <a:srgbClr val="505050"/>
-                </a:solidFill>
-                <a:latin typeface="Calibri"/>
-              </a:defRPr>
-            </a:pPr>
-            <a:r>
-              <a:t>• Trzecia pochodna położenia J = d³x/dt³. Minimalizacja szarpnięć gwarantuje stabilność ładunku i wydłuża żywotność przekładni.</a:t>
-            </a:r>
-          </a:p>
-          <a:p>
-            <a:pPr algn="l">
-              <a:spcAft>
-                <a:spcPts val="500"/>
-              </a:spcAft>
-              <a:defRPr sz="1300" b="1">
-                <a:solidFill>
-                  <a:srgbClr val="191919"/>
-                </a:solidFill>
-                <a:latin typeface="Calibri"/>
-              </a:defRPr>
-            </a:pPr>
-            <a:r>
-              <a:t>Tempo konwergencji (Convergence Rate):</a:t>
-            </a:r>
-          </a:p>
-          <a:p>
-            <a:pPr algn="l">
-              <a:spcAft>
-                <a:spcPts val="500"/>
-              </a:spcAft>
-              <a:defRPr sz="1300" b="0">
-                <a:solidFill>
-                  <a:srgbClr val="505050"/>
-                </a:solidFill>
-                <a:latin typeface="Calibri"/>
-              </a:defRPr>
-            </a:pPr>
-            <a:r>
-              <a:t>• Liczba epizodów treningowych niezbędna do osiągnięcia 98% skuteczności nawigacyjnej w nowym otoczeniu.</a:t>
-            </a:r>
-          </a:p>
-          <a:p>
-            <a:pPr algn="l">
-              <a:spcAft>
-                <a:spcPts val="500"/>
-              </a:spcAft>
-              <a:defRPr sz="1300" b="1">
-                <a:solidFill>
-                  <a:srgbClr val="191919"/>
-                </a:solidFill>
-                <a:latin typeface="Calibri"/>
-              </a:defRPr>
-            </a:pPr>
-            <a:r>
-              <a:t>Współczynnik pokrycia przestrzeni (Coverage Ratio):</a:t>
-            </a:r>
-          </a:p>
-          <a:p>
-            <a:pPr algn="l">
-              <a:spcAft>
-                <a:spcPts val="500"/>
-              </a:spcAft>
-              <a:defRPr sz="1300" b="0">
-                <a:solidFill>
-                  <a:srgbClr val="505050"/>
-                </a:solidFill>
-                <a:latin typeface="Calibri"/>
-              </a:defRPr>
-            </a:pPr>
-            <a:r>
-              <a:t>• Procent efektywnie zmapowanego magazynu w pierwszych minutach pracy bez udziału człowieka.</a:t>
+              <a:t>Pojazd z Neuro-Curiosity pokonuje złożony labirynt magazynu bez naruszenia strefy bezpieczeństwa przeszkód.</a:t>
             </a:r>
           </a:p>
         </p:txBody>
@@ -12075,18 +11677,18 @@
         </p:nvSpPr>
         <p:spPr>
           <a:xfrm>
-            <a:off x="6720840" y="1691640"/>
-            <a:ext cx="5852160" cy="4389120"/>
+            <a:off x="594360" y="3154680"/>
+            <a:ext cx="5120640" cy="1325880"/>
           </a:xfrm>
           <a:prstGeom prst="roundRect">
             <a:avLst/>
           </a:prstGeom>
           <a:solidFill>
-            <a:srgbClr val="F0F8F3"/>
+            <a:srgbClr val="F8FAFC"/>
           </a:solidFill>
           <a:ln w="15240">
             <a:solidFill>
-              <a:srgbClr val="DCE0E6"/>
+              <a:srgbClr val="DAE0E9"/>
             </a:solidFill>
           </a:ln>
         </p:spPr>
@@ -12110,145 +11712,189 @@
           <a:p>
             <a:pPr algn="l">
               <a:spcAft>
-                <a:spcPts val="1000"/>
-              </a:spcAft>
-              <a:defRPr sz="1700" b="1">
-                <a:solidFill>
-                  <a:srgbClr val="006633"/>
+                <a:spcPts val="200"/>
+              </a:spcAft>
+              <a:defRPr sz="1500" b="1">
+                <a:solidFill>
+                  <a:srgbClr val="990000"/>
                 </a:solidFill>
                 <a:latin typeface="Calibri"/>
               </a:defRPr>
             </a:pPr>
             <a:r>
-              <a:t>Aparatura statystyczna (Testy Friedmana i Nemenyiego)</a:t>
+              <a:t>-62%  Wskaźnik szarpnięcia (Jerk)</a:t>
             </a:r>
           </a:p>
           <a:p>
             <a:pPr algn="l">
               <a:spcAft>
-                <a:spcPts val="500"/>
+                <a:spcPts val="0"/>
+              </a:spcAft>
+              <a:defRPr sz="1100" b="0">
+                <a:solidFill>
+                  <a:srgbClr val="191919"/>
+                </a:solidFill>
+                <a:latin typeface="Calibri"/>
+              </a:defRPr>
+            </a:pPr>
+            <a:r>
+              <a:t>Trzecia pochodna położenia (J = d³x/dt³). Płynniejsza jazda chroni przewożone ładunki i mechanikę kół.</a:t>
+            </a:r>
+          </a:p>
+        </p:txBody>
+      </p:sp>
+      <p:sp>
+        <p:nvSpPr>
+          <p:cNvPr id="5" name="Rounded Rectangle 4"/>
+          <p:cNvSpPr/>
+          <p:nvPr/>
+        </p:nvSpPr>
+        <p:spPr>
+          <a:xfrm>
+            <a:off x="594360" y="4617720"/>
+            <a:ext cx="5120640" cy="1554480"/>
+          </a:xfrm>
+          <a:prstGeom prst="roundRect">
+            <a:avLst/>
+          </a:prstGeom>
+          <a:solidFill>
+            <a:srgbClr val="F8FAFC"/>
+          </a:solidFill>
+          <a:ln w="15240">
+            <a:solidFill>
+              <a:srgbClr val="DAE0E9"/>
+            </a:solidFill>
+          </a:ln>
+        </p:spPr>
+        <p:style>
+          <a:lnRef idx="1">
+            <a:schemeClr val="accent1"/>
+          </a:lnRef>
+          <a:fillRef idx="3">
+            <a:schemeClr val="accent1"/>
+          </a:fillRef>
+          <a:effectRef idx="2">
+            <a:schemeClr val="accent1"/>
+          </a:effectRef>
+          <a:fontRef idx="minor">
+            <a:schemeClr val="lt1"/>
+          </a:fontRef>
+        </p:style>
+        <p:txBody>
+          <a:bodyPr rtlCol="0" anchor="t" wrap="square"/>
+          <a:lstStyle/>
+          <a:p>
+            <a:pPr algn="l">
+              <a:spcAft>
+                <a:spcPts val="200"/>
+              </a:spcAft>
+              <a:defRPr sz="1400" b="1">
+                <a:solidFill>
+                  <a:srgbClr val="191919"/>
+                </a:solidFill>
+                <a:latin typeface="Calibri"/>
+              </a:defRPr>
+            </a:pPr>
+            <a:r>
+              <a:t>Rygor statystyczny: Test Friedmana i Nemenyiego</a:t>
+            </a:r>
+          </a:p>
+          <a:p>
+            <a:pPr algn="l">
+              <a:spcAft>
+                <a:spcPts val="0"/>
+              </a:spcAft>
+              <a:defRPr sz="1100" b="0">
+                <a:solidFill>
+                  <a:srgbClr val="5A5F64"/>
+                </a:solidFill>
+                <a:latin typeface="Calibri"/>
+              </a:defRPr>
+            </a:pPr>
+            <a:r>
+              <a:t>• Nieparametryczna ocena na 50 trasach magazynowych.</a:t>
+            </a:r>
+            <a:br/>
+            <a:r>
+              <a:t>• Istotność statystyczna przewagi z poziomem p &lt; 0.05.</a:t>
+            </a:r>
+            <a:br/>
+            <a:r>
+              <a:t>• Spełnienie wymogów recenzenckich czasopism JCR Q1.</a:t>
+            </a:r>
+          </a:p>
+        </p:txBody>
+      </p:sp>
+      <p:sp>
+        <p:nvSpPr>
+          <p:cNvPr id="6" name="Rounded Rectangle 5"/>
+          <p:cNvSpPr/>
+          <p:nvPr/>
+        </p:nvSpPr>
+        <p:spPr>
+          <a:xfrm>
+            <a:off x="6035040" y="1691640"/>
+            <a:ext cx="6583680" cy="4480560"/>
+          </a:xfrm>
+          <a:prstGeom prst="roundRect">
+            <a:avLst/>
+          </a:prstGeom>
+          <a:solidFill>
+            <a:srgbClr val="EEF4FA"/>
+          </a:solidFill>
+          <a:ln w="19050">
+            <a:solidFill>
+              <a:srgbClr val="8CAFD2"/>
+            </a:solidFill>
+          </a:ln>
+        </p:spPr>
+        <p:style>
+          <a:lnRef idx="1">
+            <a:schemeClr val="accent1"/>
+          </a:lnRef>
+          <a:fillRef idx="3">
+            <a:schemeClr val="accent1"/>
+          </a:fillRef>
+          <a:effectRef idx="2">
+            <a:schemeClr val="accent1"/>
+          </a:effectRef>
+          <a:fontRef idx="minor">
+            <a:schemeClr val="lt1"/>
+          </a:fontRef>
+        </p:style>
+        <p:txBody>
+          <a:bodyPr rtlCol="0" anchor="ctr" wrap="square"/>
+          <a:lstStyle/>
+          <a:p>
+            <a:pPr algn="ctr">
+              <a:spcAft>
+                <a:spcPts val="300"/>
               </a:spcAft>
               <a:defRPr sz="1300" b="1">
                 <a:solidFill>
-                  <a:srgbClr val="191919"/>
+                  <a:srgbClr val="0D47A1"/>
                 </a:solidFill>
                 <a:latin typeface="Calibri"/>
               </a:defRPr>
             </a:pPr>
             <a:r>
-              <a:t>Eliminacja przypadkowości wyników:</a:t>
-            </a:r>
-          </a:p>
-          <a:p>
-            <a:pPr algn="l">
-              <a:spcAft>
-                <a:spcPts val="500"/>
-              </a:spcAft>
-              <a:defRPr sz="1300" b="0">
-                <a:solidFill>
-                  <a:srgbClr val="505050"/>
+              <a:t>🖼 WYKRES / BOXPLOT: Porównanie Neuro-Curiosity vs Epsilon-Greedy</a:t>
+            </a:r>
+          </a:p>
+          <a:p>
+            <a:pPr algn="ctr">
+              <a:spcAft>
+                <a:spcPts val="0"/>
+              </a:spcAft>
+              <a:defRPr sz="1000" b="0">
+                <a:solidFill>
+                  <a:srgbClr val="5A5F64"/>
                 </a:solidFill>
                 <a:latin typeface="Calibri"/>
               </a:defRPr>
             </a:pPr>
             <a:r>
-              <a:t>• Proste porównanie średnich jest niewystarczające w środowiskach stochastycznych.</a:t>
-            </a:r>
-          </a:p>
-          <a:p>
-            <a:pPr algn="l">
-              <a:spcAft>
-                <a:spcPts val="500"/>
-              </a:spcAft>
-              <a:defRPr sz="1300" b="1">
-                <a:solidFill>
-                  <a:srgbClr val="191919"/>
-                </a:solidFill>
-                <a:latin typeface="Calibri"/>
-              </a:defRPr>
-            </a:pPr>
-            <a:r>
-              <a:t>Nieparametryczny Test Friedmana:</a:t>
-            </a:r>
-          </a:p>
-          <a:p>
-            <a:pPr algn="l">
-              <a:spcAft>
-                <a:spcPts val="500"/>
-              </a:spcAft>
-              <a:defRPr sz="1300" b="0">
-                <a:solidFill>
-                  <a:srgbClr val="505050"/>
-                </a:solidFill>
-                <a:latin typeface="Calibri"/>
-              </a:defRPr>
-            </a:pPr>
-            <a:r>
-              <a:t>• Ocenia rangi efektywności porównywanych algorytmów (Neuro-Curiosity vs Epsilon-Greedy vs PPO Baseline) na wielu trasach testowych.</a:t>
-            </a:r>
-          </a:p>
-          <a:p>
-            <a:pPr algn="l">
-              <a:spcAft>
-                <a:spcPts val="500"/>
-              </a:spcAft>
-              <a:defRPr sz="1300" b="1">
-                <a:solidFill>
-                  <a:srgbClr val="191919"/>
-                </a:solidFill>
-                <a:latin typeface="Calibri"/>
-              </a:defRPr>
-            </a:pPr>
-            <a:r>
-              <a:t>Test Post-Hoc Nemenyiego:</a:t>
-            </a:r>
-          </a:p>
-          <a:p>
-            <a:pPr algn="l">
-              <a:spcAft>
-                <a:spcPts val="500"/>
-              </a:spcAft>
-              <a:defRPr sz="1300" b="0">
-                <a:solidFill>
-                  <a:srgbClr val="505050"/>
-                </a:solidFill>
-                <a:latin typeface="Calibri"/>
-              </a:defRPr>
-            </a:pPr>
-            <a:r>
-              <a:t>• Precyzyjne wyznaczenie krytycznej różnicy (Critical Difference CD) i wskazanie, które algorytmy różnią się w sposób statystycznie istotny (p &lt; 0.05).</a:t>
-            </a:r>
-          </a:p>
-          <a:p>
-            <a:pPr algn="l">
-              <a:spcAft>
-                <a:spcPts val="500"/>
-              </a:spcAft>
-              <a:defRPr sz="1300" b="1">
-                <a:solidFill>
-                  <a:srgbClr val="191919"/>
-                </a:solidFill>
-                <a:latin typeface="Calibri"/>
-              </a:defRPr>
-            </a:pPr>
-            <a:r>
-              <a:t>Naukowa rzetelność publikacji:</a:t>
-            </a:r>
-          </a:p>
-          <a:p>
-            <a:pPr algn="l">
-              <a:spcAft>
-                <a:spcPts val="500"/>
-              </a:spcAft>
-              <a:defRPr sz="1300" b="0">
-                <a:solidFill>
-                  <a:srgbClr val="505050"/>
-                </a:solidFill>
-                <a:latin typeface="Calibri"/>
-              </a:defRPr>
-            </a:pPr>
-            <a:r>
-              <a:t>• Zastosowanie rygoru statystycznego spełnia najwyższe standardy recenzenckie prestiżowych czasopism z listy filadelfijskiej (JCR Q1).</a:t>
+              <a:t>Wklej wykres zbieżności uczenia (krzywa nagrody) lub diagram różnic krytycznych (Critical Difference CD Diagram) z testu Nemenyiego</a:t>
             </a:r>
           </a:p>
         </p:txBody>
@@ -12311,7 +11957,7 @@
               <a:spcAft>
                 <a:spcPts val="0"/>
               </a:spcAft>
-              <a:defRPr sz="2300" b="1">
+              <a:defRPr sz="2200" b="1">
                 <a:solidFill>
                   <a:srgbClr val="191919"/>
                 </a:solidFill>
@@ -12333,17 +11979,17 @@
         <p:spPr>
           <a:xfrm>
             <a:off x="594360" y="1691640"/>
-            <a:ext cx="5852160" cy="2148840"/>
+            <a:ext cx="5486400" cy="1051560"/>
           </a:xfrm>
           <a:prstGeom prst="roundRect">
             <a:avLst/>
           </a:prstGeom>
           <a:solidFill>
-            <a:srgbClr val="F8F9FA"/>
+            <a:srgbClr val="F8FAFC"/>
           </a:solidFill>
           <a:ln w="15240">
             <a:solidFill>
-              <a:srgbClr val="DCE0E6"/>
+              <a:srgbClr val="DAE0E9"/>
             </a:solidFill>
           </a:ln>
         </p:spPr>
@@ -12367,9 +12013,9 @@
           <a:p>
             <a:pPr algn="l">
               <a:spcAft>
-                <a:spcPts val="600"/>
-              </a:spcAft>
-              <a:defRPr sz="1500" b="1">
+                <a:spcPts val="200"/>
+              </a:spcAft>
+              <a:defRPr sz="1300" b="1">
                 <a:solidFill>
                   <a:srgbClr val="990000"/>
                 </a:solidFill>
@@ -12377,15 +12023,15 @@
               </a:defRPr>
             </a:pPr>
             <a:r>
-              <a:t>Kwartał I: Modelowanie i Symulacja Isaac Sim</a:t>
-            </a:r>
-          </a:p>
-          <a:p>
-            <a:pPr>
-              <a:spcAft>
-                <a:spcPts val="300"/>
-              </a:spcAft>
-              <a:defRPr sz="1200">
+              <a:t>Kwartał I: Symulacja Isaac Sim</a:t>
+            </a:r>
+          </a:p>
+          <a:p>
+            <a:pPr algn="l">
+              <a:spcAft>
+                <a:spcPts val="0"/>
+              </a:spcAft>
+              <a:defRPr sz="1100" b="0">
                 <a:solidFill>
                   <a:srgbClr val="191919"/>
                 </a:solidFill>
@@ -12393,39 +12039,7 @@
               </a:defRPr>
             </a:pPr>
             <a:r>
-              <a:t>• Kamień milowy 1: Implementacja modułu ICM i forward dynamics w PyTorch.</a:t>
-            </a:r>
-          </a:p>
-          <a:p>
-            <a:pPr>
-              <a:spcAft>
-                <a:spcPts val="300"/>
-              </a:spcAft>
-              <a:defRPr sz="1200">
-                <a:solidFill>
-                  <a:srgbClr val="191919"/>
-                </a:solidFill>
-                <a:latin typeface="Calibri"/>
-              </a:defRPr>
-            </a:pPr>
-            <a:r>
-              <a:t>• Zadanie: Stworzenie wirtualnej geometrii magazynu 3D oraz kinematyki AGV w NVIDIA Isaac Sim.</a:t>
-            </a:r>
-          </a:p>
-          <a:p>
-            <a:pPr>
-              <a:spcAft>
-                <a:spcPts val="300"/>
-              </a:spcAft>
-              <a:defRPr sz="1200">
-                <a:solidFill>
-                  <a:srgbClr val="191919"/>
-                </a:solidFill>
-                <a:latin typeface="Calibri"/>
-              </a:defRPr>
-            </a:pPr>
-            <a:r>
-              <a:t>• Rezultat: Wstępne wagi modelu wytrenowane w środowisku czysto symulacyjnym.</a:t>
+              <a:t>Model geometrii magazynu, kinematyka AGV, moduł ICM w PyTorch.</a:t>
             </a:r>
           </a:p>
         </p:txBody>
@@ -12438,18 +12052,18 @@
         </p:nvSpPr>
         <p:spPr>
           <a:xfrm>
-            <a:off x="6766560" y="1691640"/>
-            <a:ext cx="5852160" cy="2148840"/>
+            <a:off x="594360" y="2852928"/>
+            <a:ext cx="5486400" cy="1051560"/>
           </a:xfrm>
           <a:prstGeom prst="roundRect">
             <a:avLst/>
           </a:prstGeom>
           <a:solidFill>
-            <a:srgbClr val="F8F9FA"/>
+            <a:srgbClr val="F8FAFC"/>
           </a:solidFill>
           <a:ln w="15240">
             <a:solidFill>
-              <a:srgbClr val="DCE0E6"/>
+              <a:srgbClr val="DAE0E9"/>
             </a:solidFill>
           </a:ln>
         </p:spPr>
@@ -12473,25 +12087,25 @@
           <a:p>
             <a:pPr algn="l">
               <a:spcAft>
-                <a:spcPts val="600"/>
-              </a:spcAft>
-              <a:defRPr sz="1500" b="1">
-                <a:solidFill>
-                  <a:srgbClr val="990000"/>
+                <a:spcPts val="200"/>
+              </a:spcAft>
+              <a:defRPr sz="1300" b="1">
+                <a:solidFill>
+                  <a:srgbClr val="191919"/>
                 </a:solidFill>
                 <a:latin typeface="Calibri"/>
               </a:defRPr>
             </a:pPr>
             <a:r>
-              <a:t>Kwartał II: Integracja Edge AI &amp; Cyfrowy Bliźniak</a:t>
-            </a:r>
-          </a:p>
-          <a:p>
-            <a:pPr>
-              <a:spcAft>
-                <a:spcPts val="300"/>
-              </a:spcAft>
-              <a:defRPr sz="1200">
+              <a:t>Kwartał II: Edge AI &amp; Cyfrowy Bliźniak</a:t>
+            </a:r>
+          </a:p>
+          <a:p>
+            <a:pPr algn="l">
+              <a:spcAft>
+                <a:spcPts val="0"/>
+              </a:spcAft>
+              <a:defRPr sz="1100" b="0">
                 <a:solidFill>
                   <a:srgbClr val="191919"/>
                 </a:solidFill>
@@ -12499,39 +12113,7 @@
               </a:defRPr>
             </a:pPr>
             <a:r>
-              <a:t>• Kamień milowy 2: Uruchomienie wnioskowania TensorRT na NVIDIA Jetson Orin NX.</a:t>
-            </a:r>
-          </a:p>
-          <a:p>
-            <a:pPr>
-              <a:spcAft>
-                <a:spcPts val="300"/>
-              </a:spcAft>
-              <a:defRPr sz="1200">
-                <a:solidFill>
-                  <a:srgbClr val="191919"/>
-                </a:solidFill>
-                <a:latin typeface="Calibri"/>
-              </a:defRPr>
-            </a:pPr>
-            <a:r>
-              <a:t>• Zadanie: Integracja pipeline'u telemetrii: broker Kafka, TimescaleDB oraz wizualizacja Three.js.</a:t>
-            </a:r>
-          </a:p>
-          <a:p>
-            <a:pPr>
-              <a:spcAft>
-                <a:spcPts val="300"/>
-              </a:spcAft>
-              <a:defRPr sz="1200">
-                <a:solidFill>
-                  <a:srgbClr val="191919"/>
-                </a:solidFill>
-                <a:latin typeface="Calibri"/>
-              </a:defRPr>
-            </a:pPr>
-            <a:r>
-              <a:t>• Rezultat: Działający Digital Twin w czasie rzeczywistym z opóźnieniem &lt;15 ms.</a:t>
+              <a:t>Wdrożenie TensorRT na Jetson Orin NX, integracja szyny Kafka i 3D.</a:t>
             </a:r>
           </a:p>
         </p:txBody>
@@ -12544,18 +12126,18 @@
         </p:nvSpPr>
         <p:spPr>
           <a:xfrm>
-            <a:off x="594360" y="4069080"/>
-            <a:ext cx="5852160" cy="2148840"/>
+            <a:off x="594360" y="4014216"/>
+            <a:ext cx="5486400" cy="1051560"/>
           </a:xfrm>
           <a:prstGeom prst="roundRect">
             <a:avLst/>
           </a:prstGeom>
           <a:solidFill>
-            <a:srgbClr val="F8F9FA"/>
+            <a:srgbClr val="F8FAFC"/>
           </a:solidFill>
           <a:ln w="15240">
             <a:solidFill>
-              <a:srgbClr val="DCE0E6"/>
+              <a:srgbClr val="DAE0E9"/>
             </a:solidFill>
           </a:ln>
         </p:spPr>
@@ -12579,25 +12161,25 @@
           <a:p>
             <a:pPr algn="l">
               <a:spcAft>
-                <a:spcPts val="600"/>
-              </a:spcAft>
-              <a:defRPr sz="1500" b="1">
-                <a:solidFill>
-                  <a:srgbClr val="990000"/>
+                <a:spcPts val="200"/>
+              </a:spcAft>
+              <a:defRPr sz="1300" b="1">
+                <a:solidFill>
+                  <a:srgbClr val="191919"/>
                 </a:solidFill>
                 <a:latin typeface="Calibri"/>
               </a:defRPr>
             </a:pPr>
             <a:r>
-              <a:t>Kwartał III: Domain Randomization i Sim-to-Real</a:t>
-            </a:r>
-          </a:p>
-          <a:p>
-            <a:pPr>
-              <a:spcAft>
-                <a:spcPts val="300"/>
-              </a:spcAft>
-              <a:defRPr sz="1200">
+              <a:t>Kwartał III: Domain Randomization &amp; Sim-to-Real</a:t>
+            </a:r>
+          </a:p>
+          <a:p>
+            <a:pPr algn="l">
+              <a:spcAft>
+                <a:spcPts val="0"/>
+              </a:spcAft>
+              <a:defRPr sz="1100" b="0">
                 <a:solidFill>
                   <a:srgbClr val="191919"/>
                 </a:solidFill>
@@ -12605,39 +12187,7 @@
               </a:defRPr>
             </a:pPr>
             <a:r>
-              <a:t>• Kamień milowy 3: Testy zero-shot transfer na fizycznej platformie jezdnej.</a:t>
-            </a:r>
-          </a:p>
-          <a:p>
-            <a:pPr>
-              <a:spcAft>
-                <a:spcPts val="300"/>
-              </a:spcAft>
-              <a:defRPr sz="1200">
-                <a:solidFill>
-                  <a:srgbClr val="191919"/>
-                </a:solidFill>
-                <a:latin typeface="Calibri"/>
-              </a:defRPr>
-            </a:pPr>
-            <a:r>
-              <a:t>• Zadanie: Wprowadzenie losowości tarcia, oświetlenia i opóźnień w symulatorze.</a:t>
-            </a:r>
-          </a:p>
-          <a:p>
-            <a:pPr>
-              <a:spcAft>
-                <a:spcPts val="300"/>
-              </a:spcAft>
-              <a:defRPr sz="1200">
-                <a:solidFill>
-                  <a:srgbClr val="191919"/>
-                </a:solidFill>
-                <a:latin typeface="Calibri"/>
-              </a:defRPr>
-            </a:pPr>
-            <a:r>
-              <a:t>• Rezultat: Potwierdzenie odporności algorytmu na warunki rzeczywiste bez kolizji.</a:t>
+              <a:t>Testy odporności, randomizacja tarcia posadzki, próby jezdne AGV.</a:t>
             </a:r>
           </a:p>
         </p:txBody>
@@ -12650,18 +12200,18 @@
         </p:nvSpPr>
         <p:spPr>
           <a:xfrm>
-            <a:off x="6766560" y="4069080"/>
-            <a:ext cx="5852160" cy="2148840"/>
+            <a:off x="594360" y="5175504"/>
+            <a:ext cx="5486400" cy="1051560"/>
           </a:xfrm>
           <a:prstGeom prst="roundRect">
             <a:avLst/>
           </a:prstGeom>
           <a:solidFill>
-            <a:srgbClr val="F8F9FA"/>
+            <a:srgbClr val="F8FAFC"/>
           </a:solidFill>
           <a:ln w="15240">
             <a:solidFill>
-              <a:srgbClr val="DCE0E6"/>
+              <a:srgbClr val="DAE0E9"/>
             </a:solidFill>
           </a:ln>
         </p:spPr>
@@ -12685,65 +12235,107 @@
           <a:p>
             <a:pPr algn="l">
               <a:spcAft>
-                <a:spcPts val="600"/>
-              </a:spcAft>
-              <a:defRPr sz="1500" b="1">
-                <a:solidFill>
-                  <a:srgbClr val="990000"/>
+                <a:spcPts val="200"/>
+              </a:spcAft>
+              <a:defRPr sz="1300" b="1">
+                <a:solidFill>
+                  <a:srgbClr val="006633"/>
                 </a:solidFill>
                 <a:latin typeface="Calibri"/>
               </a:defRPr>
             </a:pPr>
             <a:r>
-              <a:t>Kwartał IV: Ewaluacja Statystyczna i Upowszechnienie</a:t>
-            </a:r>
-          </a:p>
-          <a:p>
-            <a:pPr>
+              <a:t>Kwartał IV: Ewaluacja i Upowszechnienie</a:t>
+            </a:r>
+          </a:p>
+          <a:p>
+            <a:pPr algn="l">
+              <a:spcAft>
+                <a:spcPts val="0"/>
+              </a:spcAft>
+              <a:defRPr sz="1100" b="0">
+                <a:solidFill>
+                  <a:srgbClr val="191919"/>
+                </a:solidFill>
+                <a:latin typeface="Calibri"/>
+              </a:defRPr>
+            </a:pPr>
+            <a:r>
+              <a:t>Seria 50 testów statystycznych, artykuł Q1, konferencja ICCC 2026.</a:t>
+            </a:r>
+          </a:p>
+        </p:txBody>
+      </p:sp>
+      <p:sp>
+        <p:nvSpPr>
+          <p:cNvPr id="7" name="Rounded Rectangle 6"/>
+          <p:cNvSpPr/>
+          <p:nvPr/>
+        </p:nvSpPr>
+        <p:spPr>
+          <a:xfrm>
+            <a:off x="6400800" y="1691640"/>
+            <a:ext cx="6217920" cy="4480560"/>
+          </a:xfrm>
+          <a:prstGeom prst="roundRect">
+            <a:avLst/>
+          </a:prstGeom>
+          <a:solidFill>
+            <a:srgbClr val="EEF4FA"/>
+          </a:solidFill>
+          <a:ln w="19050">
+            <a:solidFill>
+              <a:srgbClr val="8CAFD2"/>
+            </a:solidFill>
+          </a:ln>
+        </p:spPr>
+        <p:style>
+          <a:lnRef idx="1">
+            <a:schemeClr val="accent1"/>
+          </a:lnRef>
+          <a:fillRef idx="3">
+            <a:schemeClr val="accent1"/>
+          </a:fillRef>
+          <a:effectRef idx="2">
+            <a:schemeClr val="accent1"/>
+          </a:effectRef>
+          <a:fontRef idx="minor">
+            <a:schemeClr val="lt1"/>
+          </a:fontRef>
+        </p:style>
+        <p:txBody>
+          <a:bodyPr rtlCol="0" anchor="ctr" wrap="square"/>
+          <a:lstStyle/>
+          <a:p>
+            <a:pPr algn="ctr">
               <a:spcAft>
                 <a:spcPts val="300"/>
               </a:spcAft>
-              <a:defRPr sz="1200">
-                <a:solidFill>
-                  <a:srgbClr val="191919"/>
+              <a:defRPr sz="1300" b="1">
+                <a:solidFill>
+                  <a:srgbClr val="0D47A1"/>
                 </a:solidFill>
                 <a:latin typeface="Calibri"/>
               </a:defRPr>
             </a:pPr>
             <a:r>
-              <a:t>• Kamień milowy 4: Raport badawczy, artykuł Q1 i wystąpienie konferencyjne.</a:t>
-            </a:r>
-          </a:p>
-          <a:p>
-            <a:pPr>
-              <a:spcAft>
-                <a:spcPts val="300"/>
-              </a:spcAft>
-              <a:defRPr sz="1200">
-                <a:solidFill>
-                  <a:srgbClr val="191919"/>
+              <a:t>🖼 ZDJĘCIE: Stanowisko laboratoryjne / Zespół SKN Sensor</a:t>
+            </a:r>
+          </a:p>
+          <a:p>
+            <a:pPr algn="ctr">
+              <a:spcAft>
+                <a:spcPts val="0"/>
+              </a:spcAft>
+              <a:defRPr sz="1000" b="0">
+                <a:solidFill>
+                  <a:srgbClr val="5A5F64"/>
                 </a:solidFill>
                 <a:latin typeface="Calibri"/>
               </a:defRPr>
             </a:pPr>
             <a:r>
-              <a:t>• Zadanie: Wykonanie testów Friedmana/Nemenyiego na 50 scenariuszach fabrycznych.</a:t>
-            </a:r>
-          </a:p>
-          <a:p>
-            <a:pPr>
-              <a:spcAft>
-                <a:spcPts val="300"/>
-              </a:spcAft>
-              <a:defRPr sz="1200">
-                <a:solidFill>
-                  <a:srgbClr val="191919"/>
-                </a:solidFill>
-                <a:latin typeface="Calibri"/>
-              </a:defRPr>
-            </a:pPr>
-            <a:r>
-              <a:t>• Rezultat: Prezentacja na ICCC 2026 i KKR oraz publikacja repozytorium GitHub Open Source.</a:t>
+              <a:t>Wklej zdjęcie laboratorium robotyki, platformy jezdnej lub zespołu realizującego projekt na AGH</a:t>
             </a:r>
           </a:p>
         </p:txBody>
@@ -12806,7 +12398,7 @@
               <a:spcAft>
                 <a:spcPts val="0"/>
               </a:spcAft>
-              <a:defRPr sz="2300" b="1">
+              <a:defRPr sz="2200" b="1">
                 <a:solidFill>
                   <a:srgbClr val="191919"/>
                 </a:solidFill>
@@ -12814,7 +12406,7 @@
               </a:defRPr>
             </a:pPr>
             <a:r>
-              <a:t>Budżet projektu oraz plan upowszechniania wyników</a:t>
+              <a:t>Budżet projektu oraz plan upowszechniania</a:t>
             </a:r>
           </a:p>
         </p:txBody>
@@ -12828,17 +12420,17 @@
         <p:spPr>
           <a:xfrm>
             <a:off x="594360" y="1691640"/>
-            <a:ext cx="5852160" cy="4389120"/>
+            <a:ext cx="5303520" cy="1371600"/>
           </a:xfrm>
           <a:prstGeom prst="roundRect">
             <a:avLst/>
           </a:prstGeom>
           <a:solidFill>
-            <a:srgbClr val="F8F9FA"/>
+            <a:srgbClr val="F0F9F4"/>
           </a:solidFill>
           <a:ln w="15240">
             <a:solidFill>
-              <a:srgbClr val="DCE0E6"/>
+              <a:srgbClr val="DAE0E9"/>
             </a:solidFill>
           </a:ln>
         </p:spPr>
@@ -12862,9 +12454,9 @@
           <a:p>
             <a:pPr algn="l">
               <a:spcAft>
-                <a:spcPts val="1000"/>
-              </a:spcAft>
-              <a:defRPr sz="1700" b="1">
+                <a:spcPts val="300"/>
+              </a:spcAft>
+              <a:defRPr sz="1600" b="1">
                 <a:solidFill>
                   <a:srgbClr val="990000"/>
                 </a:solidFill>
@@ -12872,15 +12464,15 @@
               </a:defRPr>
             </a:pPr>
             <a:r>
-              <a:t>Kosztorys grantu IDUB (Łącznie: 44 900 PLN)</a:t>
+              <a:t>Całkowity budżet grantu: 44 900 PLN</a:t>
             </a:r>
           </a:p>
           <a:p>
             <a:pPr algn="l">
               <a:spcAft>
-                <a:spcPts val="100"/>
-              </a:spcAft>
-              <a:defRPr sz="1300" b="1">
+                <a:spcPts val="0"/>
+              </a:spcAft>
+              <a:defRPr sz="1100" b="0">
                 <a:solidFill>
                   <a:srgbClr val="191919"/>
                 </a:solidFill>
@@ -12888,183 +12480,11 @@
               </a:defRPr>
             </a:pPr>
             <a:r>
-              <a:t>• 1. Jednostka procesująca Edge AI:  8 000,00 PLN</a:t>
-            </a:r>
-          </a:p>
-          <a:p>
-            <a:pPr algn="l">
-              <a:spcAft>
-                <a:spcPts val="500"/>
-              </a:spcAft>
-              <a:defRPr sz="1100" b="0">
-                <a:solidFill>
-                  <a:srgbClr val="505050"/>
-                </a:solidFill>
-                <a:latin typeface="Calibri"/>
-              </a:defRPr>
-            </a:pPr>
-            <a:r>
-              <a:t>   Moduł NVIDIA Jetson Orin NX + carrier board + zasilanie przemysłowe</a:t>
-            </a:r>
-          </a:p>
-          <a:p>
-            <a:pPr algn="l">
-              <a:spcAft>
-                <a:spcPts val="100"/>
-              </a:spcAft>
-              <a:defRPr sz="1300" b="1">
-                <a:solidFill>
-                  <a:srgbClr val="191919"/>
-                </a:solidFill>
-                <a:latin typeface="Calibri"/>
-              </a:defRPr>
-            </a:pPr>
-            <a:r>
-              <a:t>• 2. Konferencje naukowe i delegacje:  35 000,00 PLN</a:t>
-            </a:r>
-          </a:p>
-          <a:p>
-            <a:pPr algn="l">
-              <a:spcAft>
-                <a:spcPts val="500"/>
-              </a:spcAft>
-              <a:defRPr sz="1100" b="0">
-                <a:solidFill>
-                  <a:srgbClr val="505050"/>
-                </a:solidFill>
-                <a:latin typeface="Calibri"/>
-              </a:defRPr>
-            </a:pPr>
-            <a:r>
-              <a:t>   Udział zespołu w ICCC 2026 (IEEE) oraz 18. KKR (Krajowa Konf. Robotyki)</a:t>
-            </a:r>
-          </a:p>
-          <a:p>
-            <a:pPr algn="l">
-              <a:spcAft>
-                <a:spcPts val="100"/>
-              </a:spcAft>
-              <a:defRPr sz="1300" b="1">
-                <a:solidFill>
-                  <a:srgbClr val="191919"/>
-                </a:solidFill>
-                <a:latin typeface="Calibri"/>
-              </a:defRPr>
-            </a:pPr>
-            <a:r>
-              <a:t>• 3. Materiały konstrukcyjne:  500,00 PLN</a:t>
-            </a:r>
-          </a:p>
-          <a:p>
-            <a:pPr algn="l">
-              <a:spcAft>
-                <a:spcPts val="500"/>
-              </a:spcAft>
-              <a:defRPr sz="1100" b="0">
-                <a:solidFill>
-                  <a:srgbClr val="505050"/>
-                </a:solidFill>
-                <a:latin typeface="Calibri"/>
-              </a:defRPr>
-            </a:pPr>
-            <a:r>
-              <a:t>   Mocowania sensorów, elementy montażowe podwozia AGV</a:t>
-            </a:r>
-          </a:p>
-          <a:p>
-            <a:pPr algn="l">
-              <a:spcAft>
-                <a:spcPts val="100"/>
-              </a:spcAft>
-              <a:defRPr sz="1300" b="1">
-                <a:solidFill>
-                  <a:srgbClr val="191919"/>
-                </a:solidFill>
-                <a:latin typeface="Calibri"/>
-              </a:defRPr>
-            </a:pPr>
-            <a:r>
-              <a:t>• 4. Oprzyrządowanie elektroniczne:  500,00 PLN</a:t>
-            </a:r>
-          </a:p>
-          <a:p>
-            <a:pPr algn="l">
-              <a:spcAft>
-                <a:spcPts val="500"/>
-              </a:spcAft>
-              <a:defRPr sz="1100" b="0">
-                <a:solidFill>
-                  <a:srgbClr val="505050"/>
-                </a:solidFill>
-                <a:latin typeface="Calibri"/>
-              </a:defRPr>
-            </a:pPr>
-            <a:r>
-              <a:t>   Okablowanie CAN/Ethernet, zabezpieczenia przeciwprzepięciowe</a:t>
-            </a:r>
-          </a:p>
-          <a:p>
-            <a:pPr algn="l">
-              <a:spcAft>
-                <a:spcPts val="100"/>
-              </a:spcAft>
-              <a:defRPr sz="1300" b="1">
-                <a:solidFill>
-                  <a:srgbClr val="191919"/>
-                </a:solidFill>
-                <a:latin typeface="Calibri"/>
-              </a:defRPr>
-            </a:pPr>
-            <a:r>
-              <a:t>• 5. Usługi (publikacje i Open Access):  900,00 PLN</a:t>
-            </a:r>
-          </a:p>
-          <a:p>
-            <a:pPr algn="l">
-              <a:spcAft>
-                <a:spcPts val="500"/>
-              </a:spcAft>
-              <a:defRPr sz="1100" b="0">
-                <a:solidFill>
-                  <a:srgbClr val="505050"/>
-                </a:solidFill>
-                <a:latin typeface="Calibri"/>
-              </a:defRPr>
-            </a:pPr>
-            <a:r>
-              <a:t>   Proofreading językowy, przygotowanie posterów naukowych</a:t>
-            </a:r>
-          </a:p>
-          <a:p>
-            <a:pPr algn="l">
-              <a:spcAft>
-                <a:spcPts val="100"/>
-              </a:spcAft>
-              <a:defRPr sz="1300" b="1">
-                <a:solidFill>
-                  <a:srgbClr val="191919"/>
-                </a:solidFill>
-                <a:latin typeface="Calibri"/>
-              </a:defRPr>
-            </a:pPr>
-            <a:r>
-              <a:t>• Stypendia motywacyjne dla studentów:  8 980,00 PLN</a:t>
-            </a:r>
-          </a:p>
-          <a:p>
-            <a:pPr algn="l">
-              <a:spcAft>
-                <a:spcPts val="500"/>
-              </a:spcAft>
-              <a:defRPr sz="1100" b="0">
-                <a:solidFill>
-                  <a:srgbClr val="505050"/>
-                </a:solidFill>
-                <a:latin typeface="Calibri"/>
-              </a:defRPr>
-            </a:pPr>
-            <a:r>
-              <a:t>   Finansowane w ramach subwencji dydaktycznej jednostki</a:t>
+              <a:t>• Efektywna alokacja środków na sprzęt brzegowy i konferencje.</a:t>
+            </a:r>
+            <a:br/>
+            <a:r>
+              <a:t>• Stypendia motywacyjne dla studentów: 8 980 PLN (subwencja).</a:t>
             </a:r>
           </a:p>
         </p:txBody>
@@ -13077,18 +12497,18 @@
         </p:nvSpPr>
         <p:spPr>
           <a:xfrm>
-            <a:off x="6720840" y="1691640"/>
-            <a:ext cx="5852160" cy="4389120"/>
+            <a:off x="594360" y="3246120"/>
+            <a:ext cx="5303520" cy="1371600"/>
           </a:xfrm>
           <a:prstGeom prst="roundRect">
             <a:avLst/>
           </a:prstGeom>
           <a:solidFill>
-            <a:srgbClr val="F0F8F3"/>
+            <a:srgbClr val="F8FAFC"/>
           </a:solidFill>
           <a:ln w="15240">
             <a:solidFill>
-              <a:srgbClr val="DCE0E6"/>
+              <a:srgbClr val="DAE0E9"/>
             </a:solidFill>
           </a:ln>
         </p:spPr>
@@ -13112,9 +12532,91 @@
           <a:p>
             <a:pPr algn="l">
               <a:spcAft>
-                <a:spcPts val="1000"/>
-              </a:spcAft>
-              <a:defRPr sz="1700" b="1">
+                <a:spcPts val="300"/>
+              </a:spcAft>
+              <a:defRPr sz="1400" b="1">
+                <a:solidFill>
+                  <a:srgbClr val="191919"/>
+                </a:solidFill>
+                <a:latin typeface="Calibri"/>
+              </a:defRPr>
+            </a:pPr>
+            <a:r>
+              <a:t>Główne pozycje kosztorysu</a:t>
+            </a:r>
+          </a:p>
+          <a:p>
+            <a:pPr algn="l">
+              <a:spcAft>
+                <a:spcPts val="0"/>
+              </a:spcAft>
+              <a:defRPr sz="1100" b="0">
+                <a:solidFill>
+                  <a:srgbClr val="191919"/>
+                </a:solidFill>
+                <a:latin typeface="Calibri"/>
+              </a:defRPr>
+            </a:pPr>
+            <a:r>
+              <a:t>• Jednostka Edge AI (NVIDIA Jetson Orin NX + zasilanie): 8 000 PLN</a:t>
+            </a:r>
+            <a:br/>
+            <a:r>
+              <a:t>• Wyjazdy i konferencje naukowe (ICCC 2026, KKR): 35 000 PLN</a:t>
+            </a:r>
+            <a:br/>
+            <a:r>
+              <a:t>• Aparatura, sensory i usługi publikacyjne: 1 900 PLN</a:t>
+            </a:r>
+          </a:p>
+        </p:txBody>
+      </p:sp>
+      <p:sp>
+        <p:nvSpPr>
+          <p:cNvPr id="5" name="Rounded Rectangle 4"/>
+          <p:cNvSpPr/>
+          <p:nvPr/>
+        </p:nvSpPr>
+        <p:spPr>
+          <a:xfrm>
+            <a:off x="594360" y="4800600"/>
+            <a:ext cx="5303520" cy="1371600"/>
+          </a:xfrm>
+          <a:prstGeom prst="roundRect">
+            <a:avLst/>
+          </a:prstGeom>
+          <a:solidFill>
+            <a:srgbClr val="F8FAFC"/>
+          </a:solidFill>
+          <a:ln w="15240">
+            <a:solidFill>
+              <a:srgbClr val="DAE0E9"/>
+            </a:solidFill>
+          </a:ln>
+        </p:spPr>
+        <p:style>
+          <a:lnRef idx="1">
+            <a:schemeClr val="accent1"/>
+          </a:lnRef>
+          <a:fillRef idx="3">
+            <a:schemeClr val="accent1"/>
+          </a:fillRef>
+          <a:effectRef idx="2">
+            <a:schemeClr val="accent1"/>
+          </a:effectRef>
+          <a:fontRef idx="minor">
+            <a:schemeClr val="lt1"/>
+          </a:fontRef>
+        </p:style>
+        <p:txBody>
+          <a:bodyPr rtlCol="0" anchor="t" wrap="square"/>
+          <a:lstStyle/>
+          <a:p>
+            <a:pPr algn="l">
+              <a:spcAft>
+                <a:spcPts val="300"/>
+              </a:spcAft>
+              <a:defRPr sz="1400" b="1">
                 <a:solidFill>
                   <a:srgbClr val="006633"/>
                 </a:solidFill>
@@ -13122,135 +12624,109 @@
               </a:defRPr>
             </a:pPr>
             <a:r>
-              <a:t>Plan upowszechniania i wpływ na otoczenie</a:t>
+              <a:t>Kanały upowszechniania wyników</a:t>
             </a:r>
           </a:p>
           <a:p>
             <a:pPr algn="l">
               <a:spcAft>
-                <a:spcPts val="500"/>
+                <a:spcPts val="0"/>
+              </a:spcAft>
+              <a:defRPr sz="1100" b="0">
+                <a:solidFill>
+                  <a:srgbClr val="191919"/>
+                </a:solidFill>
+                <a:latin typeface="Calibri"/>
+              </a:defRPr>
+            </a:pPr>
+            <a:r>
+              <a:t>• Publikacja w prestiżowym czasopiśmie JCR Q1 (Open Access).</a:t>
+            </a:r>
+            <a:br/>
+            <a:r>
+              <a:t>• Repozytorium Open Source na GitHubie (kod i wagi modeli).</a:t>
+            </a:r>
+            <a:br/>
+            <a:r>
+              <a:t>• Pokazy na żywo na Dniach Otwartych i Targach Kół AGH.</a:t>
+            </a:r>
+          </a:p>
+        </p:txBody>
+      </p:sp>
+      <p:sp>
+        <p:nvSpPr>
+          <p:cNvPr id="6" name="Rounded Rectangle 5"/>
+          <p:cNvSpPr/>
+          <p:nvPr/>
+        </p:nvSpPr>
+        <p:spPr>
+          <a:xfrm>
+            <a:off x="6217920" y="1691640"/>
+            <a:ext cx="6400800" cy="4480560"/>
+          </a:xfrm>
+          <a:prstGeom prst="roundRect">
+            <a:avLst/>
+          </a:prstGeom>
+          <a:solidFill>
+            <a:srgbClr val="EEF4FA"/>
+          </a:solidFill>
+          <a:ln w="19050">
+            <a:solidFill>
+              <a:srgbClr val="8CAFD2"/>
+            </a:solidFill>
+          </a:ln>
+        </p:spPr>
+        <p:style>
+          <a:lnRef idx="1">
+            <a:schemeClr val="accent1"/>
+          </a:lnRef>
+          <a:fillRef idx="3">
+            <a:schemeClr val="accent1"/>
+          </a:fillRef>
+          <a:effectRef idx="2">
+            <a:schemeClr val="accent1"/>
+          </a:effectRef>
+          <a:fontRef idx="minor">
+            <a:schemeClr val="lt1"/>
+          </a:fontRef>
+        </p:style>
+        <p:txBody>
+          <a:bodyPr rtlCol="0" anchor="ctr" wrap="square"/>
+          <a:lstStyle/>
+          <a:p>
+            <a:pPr algn="ctr">
+              <a:spcAft>
+                <a:spcPts val="300"/>
               </a:spcAft>
               <a:defRPr sz="1300" b="1">
                 <a:solidFill>
-                  <a:srgbClr val="191919"/>
+                  <a:srgbClr val="0D47A1"/>
                 </a:solidFill>
                 <a:latin typeface="Calibri"/>
               </a:defRPr>
             </a:pPr>
             <a:r>
-              <a:t>Publikacje w czasopismach JCR Q1 / Core A:</a:t>
-            </a:r>
-          </a:p>
-          <a:p>
-            <a:pPr algn="l">
-              <a:spcAft>
-                <a:spcPts val="500"/>
-              </a:spcAft>
-              <a:defRPr sz="1300" b="0">
-                <a:solidFill>
-                  <a:srgbClr val="505050"/>
+              <a:t>🖼 LOGOTYPY: Konferencje, Bazy Indeksacyjne, GitHub</a:t>
+            </a:r>
+          </a:p>
+          <a:p>
+            <a:pPr algn="ctr">
+              <a:spcAft>
+                <a:spcPts val="0"/>
+              </a:spcAft>
+              <a:defRPr sz="1000" b="0">
+                <a:solidFill>
+                  <a:srgbClr val="5A5F64"/>
                 </a:solidFill>
                 <a:latin typeface="Calibri"/>
               </a:defRPr>
             </a:pPr>
             <a:r>
-              <a:t>• Artykuł podsumowujący transfer Sim-to-Real w systemach intralogistycznych w modelu Open Access.</a:t>
-            </a:r>
-          </a:p>
-          <a:p>
-            <a:pPr algn="l">
-              <a:spcAft>
-                <a:spcPts val="500"/>
-              </a:spcAft>
-              <a:defRPr sz="1300" b="1">
-                <a:solidFill>
-                  <a:srgbClr val="191919"/>
-                </a:solidFill>
-                <a:latin typeface="Calibri"/>
-              </a:defRPr>
-            </a:pPr>
-            <a:r>
-              <a:t>Widoczność w bazach Scopus i IEEE Xplore:</a:t>
-            </a:r>
-          </a:p>
-          <a:p>
-            <a:pPr algn="l">
-              <a:spcAft>
-                <a:spcPts val="500"/>
-              </a:spcAft>
-              <a:defRPr sz="1300" b="0">
-                <a:solidFill>
-                  <a:srgbClr val="505050"/>
-                </a:solidFill>
-                <a:latin typeface="Calibri"/>
-              </a:defRPr>
-            </a:pPr>
-            <a:r>
-              <a:t>• Publikacja wyników w materiałach 27th International Carpathian Control Conference ICCC 2026.</a:t>
-            </a:r>
-          </a:p>
-          <a:p>
-            <a:pPr algn="l">
-              <a:spcAft>
-                <a:spcPts val="500"/>
-              </a:spcAft>
-              <a:defRPr sz="1300" b="1">
-                <a:solidFill>
-                  <a:srgbClr val="191919"/>
-                </a:solidFill>
-                <a:latin typeface="Calibri"/>
-              </a:defRPr>
-            </a:pPr>
-            <a:r>
-              <a:t>Repozytorium Open Source na GitHubie:</a:t>
-            </a:r>
-          </a:p>
-          <a:p>
-            <a:pPr algn="l">
-              <a:spcAft>
-                <a:spcPts val="500"/>
-              </a:spcAft>
-              <a:defRPr sz="1300" b="0">
-                <a:solidFill>
-                  <a:srgbClr val="505050"/>
-                </a:solidFill>
-                <a:latin typeface="Calibri"/>
-              </a:defRPr>
-            </a:pPr>
-            <a:r>
-              <a:t>• Udostępnienie kodów źródłowych modułu ICM, wag modeli oraz komponentów Cyfrowego Bliźniaka dla społeczności akademickiej.</a:t>
-            </a:r>
-          </a:p>
-          <a:p>
-            <a:pPr algn="l">
-              <a:spcAft>
-                <a:spcPts val="500"/>
-              </a:spcAft>
-              <a:defRPr sz="1300" b="1">
-                <a:solidFill>
-                  <a:srgbClr val="191919"/>
-                </a:solidFill>
-                <a:latin typeface="Calibri"/>
-              </a:defRPr>
-            </a:pPr>
-            <a:r>
-              <a:t>Promocja AGH i Dni Otwarte:</a:t>
-            </a:r>
-          </a:p>
-          <a:p>
-            <a:pPr algn="l">
-              <a:spcAft>
-                <a:spcPts val="500"/>
-              </a:spcAft>
-              <a:defRPr sz="1300" b="0">
-                <a:solidFill>
-                  <a:srgbClr val="505050"/>
-                </a:solidFill>
-                <a:latin typeface="Calibri"/>
-              </a:defRPr>
-            </a:pPr>
-            <a:r>
-              <a:t>• Demonstracja autonomicznych pojazdów AGV na żywo podczas Dni Otwartych AGH oraz Targów Organizacji Studenckich dla kandydatów na studia.</a:t>
+              <a:t>Wklej logotypy: IEEE Xplore, ICCC 2026, KKR 2026, GitHub Open Source</a:t>
+            </a:r>
+            <a:br/>
+            <a:r>
+              <a:t>oraz zrzut repozytorium projektu</a:t>
             </a:r>
           </a:p>
         </p:txBody>
@@ -13313,7 +12789,7 @@
               <a:spcAft>
                 <a:spcPts val="0"/>
               </a:spcAft>
-              <a:defRPr sz="2300" b="1">
+              <a:defRPr sz="2200" b="1">
                 <a:solidFill>
                   <a:srgbClr val="191919"/>
                 </a:solidFill>
@@ -13335,17 +12811,17 @@
         <p:spPr>
           <a:xfrm>
             <a:off x="594360" y="1691640"/>
-            <a:ext cx="3840480" cy="4389120"/>
+            <a:ext cx="5669280" cy="1371600"/>
           </a:xfrm>
           <a:prstGeom prst="roundRect">
             <a:avLst/>
           </a:prstGeom>
           <a:solidFill>
-            <a:srgbClr val="F8F9FA"/>
+            <a:srgbClr val="F0F9F4"/>
           </a:solidFill>
           <a:ln w="15240">
             <a:solidFill>
-              <a:srgbClr val="DCE0E6"/>
+              <a:srgbClr val="DAE0E9"/>
             </a:solidFill>
           </a:ln>
         </p:spPr>
@@ -13369,25 +12845,25 @@
           <a:p>
             <a:pPr algn="l">
               <a:spcAft>
-                <a:spcPts val="1200"/>
-              </a:spcAft>
-              <a:defRPr sz="1700" b="1">
-                <a:solidFill>
-                  <a:srgbClr val="990000"/>
+                <a:spcPts val="200"/>
+              </a:spcAft>
+              <a:defRPr sz="1400" b="1">
+                <a:solidFill>
+                  <a:srgbClr val="006633"/>
                 </a:solidFill>
                 <a:latin typeface="Calibri"/>
               </a:defRPr>
             </a:pPr>
             <a:r>
-              <a:t>Innowacja Naukowa</a:t>
+              <a:t>1. Innowacja naukowa</a:t>
             </a:r>
           </a:p>
           <a:p>
             <a:pPr algn="l">
               <a:spcAft>
-                <a:spcPts val="600"/>
-              </a:spcAft>
-              <a:defRPr sz="1300" b="1">
+                <a:spcPts val="0"/>
+              </a:spcAft>
+              <a:defRPr sz="1100" b="0">
                 <a:solidFill>
                   <a:srgbClr val="191919"/>
                 </a:solidFill>
@@ -13395,87 +12871,7 @@
               </a:defRPr>
             </a:pPr>
             <a:r>
-              <a:t>Przełamanie barier RL:</a:t>
-            </a:r>
-          </a:p>
-          <a:p>
-            <a:pPr algn="l">
-              <a:spcAft>
-                <a:spcPts val="600"/>
-              </a:spcAft>
-              <a:defRPr sz="1300" b="0">
-                <a:solidFill>
-                  <a:srgbClr val="505050"/>
-                </a:solidFill>
-                <a:latin typeface="Calibri"/>
-              </a:defRPr>
-            </a:pPr>
-            <a:r>
-              <a:t>• Skuteczna nawigacja w środowiskach o rzadkich nagrodach bez konieczności kosztownego reward engineeringu.</a:t>
-            </a:r>
-          </a:p>
-          <a:p>
-            <a:pPr algn="l">
-              <a:spcAft>
-                <a:spcPts val="600"/>
-              </a:spcAft>
-              <a:defRPr sz="1300" b="1">
-                <a:solidFill>
-                  <a:srgbClr val="191919"/>
-                </a:solidFill>
-                <a:latin typeface="Calibri"/>
-              </a:defRPr>
-            </a:pPr>
-            <a:r>
-              <a:t>Odporność na szum sensoryczny:</a:t>
-            </a:r>
-          </a:p>
-          <a:p>
-            <a:pPr algn="l">
-              <a:spcAft>
-                <a:spcPts val="600"/>
-              </a:spcAft>
-              <a:defRPr sz="1300" b="0">
-                <a:solidFill>
-                  <a:srgbClr val="505050"/>
-                </a:solidFill>
-                <a:latin typeface="Calibri"/>
-              </a:defRPr>
-            </a:pPr>
-            <a:r>
-              <a:t>• Moduł ICM filtruje nieistotne fluktuacje otoczenia magazynowego.</a:t>
-            </a:r>
-          </a:p>
-          <a:p>
-            <a:pPr algn="l">
-              <a:spcAft>
-                <a:spcPts val="600"/>
-              </a:spcAft>
-              <a:defRPr sz="1300" b="1">
-                <a:solidFill>
-                  <a:srgbClr val="191919"/>
-                </a:solidFill>
-                <a:latin typeface="Calibri"/>
-              </a:defRPr>
-            </a:pPr>
-            <a:r>
-              <a:t>Wysoki potencjał publikacyjny:</a:t>
-            </a:r>
-          </a:p>
-          <a:p>
-            <a:pPr algn="l">
-              <a:spcAft>
-                <a:spcPts val="600"/>
-              </a:spcAft>
-              <a:defRPr sz="1300" b="0">
-                <a:solidFill>
-                  <a:srgbClr val="505050"/>
-                </a:solidFill>
-                <a:latin typeface="Calibri"/>
-              </a:defRPr>
-            </a:pPr>
-            <a:r>
-              <a:t>• Tematyka Deep RL i ciekawości maszynowej to jeden z najszybciej rosnących trendów wg bazy SciVal.</a:t>
+              <a:t>Przełamanie bariery rzadkich nagród w robotyce mobilnej dzięki modułowi Neuro-Curiosity i filtracji szumu sensorycznego.</a:t>
             </a:r>
           </a:p>
         </p:txBody>
@@ -13488,18 +12884,18 @@
         </p:nvSpPr>
         <p:spPr>
           <a:xfrm>
-            <a:off x="4754880" y="1691640"/>
-            <a:ext cx="3840480" cy="4389120"/>
+            <a:off x="594360" y="3246120"/>
+            <a:ext cx="5669280" cy="1371600"/>
           </a:xfrm>
           <a:prstGeom prst="roundRect">
             <a:avLst/>
           </a:prstGeom>
           <a:solidFill>
-            <a:srgbClr val="F8F9FA"/>
+            <a:srgbClr val="F8FAFC"/>
           </a:solidFill>
           <a:ln w="15240">
             <a:solidFill>
-              <a:srgbClr val="DCE0E6"/>
+              <a:srgbClr val="DAE0E9"/>
             </a:solidFill>
           </a:ln>
         </p:spPr>
@@ -13523,25 +12919,25 @@
           <a:p>
             <a:pPr algn="l">
               <a:spcAft>
-                <a:spcPts val="1200"/>
-              </a:spcAft>
-              <a:defRPr sz="1700" b="1">
-                <a:solidFill>
-                  <a:srgbClr val="006633"/>
+                <a:spcPts val="200"/>
+              </a:spcAft>
+              <a:defRPr sz="1400" b="1">
+                <a:solidFill>
+                  <a:srgbClr val="990000"/>
                 </a:solidFill>
                 <a:latin typeface="Calibri"/>
               </a:defRPr>
             </a:pPr>
             <a:r>
-              <a:t>Wartość Przemysłowa</a:t>
+              <a:t>2. Bezpieczeństwo i ekonomia Sim-to-Real</a:t>
             </a:r>
           </a:p>
           <a:p>
             <a:pPr algn="l">
               <a:spcAft>
-                <a:spcPts val="600"/>
-              </a:spcAft>
-              <a:defRPr sz="1300" b="1">
+                <a:spcPts val="0"/>
+              </a:spcAft>
+              <a:defRPr sz="1100" b="0">
                 <a:solidFill>
                   <a:srgbClr val="191919"/>
                 </a:solidFill>
@@ -13549,87 +12945,7 @@
               </a:defRPr>
             </a:pPr>
             <a:r>
-              <a:t>Ekonomia wdrożenia Sim-to-Real:</a:t>
-            </a:r>
-          </a:p>
-          <a:p>
-            <a:pPr algn="l">
-              <a:spcAft>
-                <a:spcPts val="600"/>
-              </a:spcAft>
-              <a:defRPr sz="1300" b="0">
-                <a:solidFill>
-                  <a:srgbClr val="505050"/>
-                </a:solidFill>
-                <a:latin typeface="Calibri"/>
-              </a:defRPr>
-            </a:pPr>
-            <a:r>
-              <a:t>• Drastyczne obniżenie kosztów integracji autonomicznych wózków dla sektora MŚP i Przemysłu 4.0.</a:t>
-            </a:r>
-          </a:p>
-          <a:p>
-            <a:pPr algn="l">
-              <a:spcAft>
-                <a:spcPts val="600"/>
-              </a:spcAft>
-              <a:defRPr sz="1300" b="1">
-                <a:solidFill>
-                  <a:srgbClr val="191919"/>
-                </a:solidFill>
-                <a:latin typeface="Calibri"/>
-              </a:defRPr>
-            </a:pPr>
-            <a:r>
-              <a:t>Bezpieczeństwo infrastruktury:</a:t>
-            </a:r>
-          </a:p>
-          <a:p>
-            <a:pPr algn="l">
-              <a:spcAft>
-                <a:spcPts val="600"/>
-              </a:spcAft>
-              <a:defRPr sz="1300" b="0">
-                <a:solidFill>
-                  <a:srgbClr val="505050"/>
-                </a:solidFill>
-                <a:latin typeface="Calibri"/>
-              </a:defRPr>
-            </a:pPr>
-            <a:r>
-              <a:t>• Minimalizacja wskaźnika Jerk i eliminacja losowych zderzeń chroni pojazdy i linie produkcyjne.</a:t>
-            </a:r>
-          </a:p>
-          <a:p>
-            <a:pPr algn="l">
-              <a:spcAft>
-                <a:spcPts val="600"/>
-              </a:spcAft>
-              <a:defRPr sz="1300" b="1">
-                <a:solidFill>
-                  <a:srgbClr val="191919"/>
-                </a:solidFill>
-                <a:latin typeface="Calibri"/>
-              </a:defRPr>
-            </a:pPr>
-            <a:r>
-              <a:t>Kompaktowy Edge Computing:</a:t>
-            </a:r>
-          </a:p>
-          <a:p>
-            <a:pPr algn="l">
-              <a:spcAft>
-                <a:spcPts val="600"/>
-              </a:spcAft>
-              <a:defRPr sz="1300" b="0">
-                <a:solidFill>
-                  <a:srgbClr val="505050"/>
-                </a:solidFill>
-                <a:latin typeface="Calibri"/>
-              </a:defRPr>
-            </a:pPr>
-            <a:r>
-              <a:t>• Pełna autonomia na pokładzie AGV bez konieczności stałego łącza z chmurą.</a:t>
+              <a:t>Redukcja testów poligonowych o 75%, eliminacja kolizji oraz płynna jazda bez przeciążeń mechaniki napędów (niski Jerk).</a:t>
             </a:r>
           </a:p>
         </p:txBody>
@@ -13642,18 +12958,18 @@
         </p:nvSpPr>
         <p:spPr>
           <a:xfrm>
-            <a:off x="8915400" y="1691640"/>
-            <a:ext cx="3840480" cy="4389120"/>
+            <a:off x="594360" y="4800600"/>
+            <a:ext cx="5669280" cy="1371600"/>
           </a:xfrm>
           <a:prstGeom prst="roundRect">
             <a:avLst/>
           </a:prstGeom>
           <a:solidFill>
-            <a:srgbClr val="F0F8F3"/>
+            <a:srgbClr val="F8FAFC"/>
           </a:solidFill>
           <a:ln w="15240">
             <a:solidFill>
-              <a:srgbClr val="DCE0E6"/>
+              <a:srgbClr val="DAE0E9"/>
             </a:solidFill>
           </a:ln>
         </p:spPr>
@@ -13677,9 +12993,9 @@
           <a:p>
             <a:pPr algn="l">
               <a:spcAft>
-                <a:spcPts val="1200"/>
-              </a:spcAft>
-              <a:defRPr sz="1700" b="1">
+                <a:spcPts val="200"/>
+              </a:spcAft>
+              <a:defRPr sz="1400" b="1">
                 <a:solidFill>
                   <a:srgbClr val="0D47A1"/>
                 </a:solidFill>
@@ -13687,103 +13003,171 @@
               </a:defRPr>
             </a:pPr>
             <a:r>
-              <a:t>Integracja i Rozwój AGH</a:t>
+              <a:t>3. Synergia AGH i rozwój kadr</a:t>
             </a:r>
           </a:p>
           <a:p>
             <a:pPr algn="l">
               <a:spcAft>
-                <a:spcPts val="600"/>
+                <a:spcPts val="0"/>
+              </a:spcAft>
+              <a:defRPr sz="1100" b="0">
+                <a:solidFill>
+                  <a:srgbClr val="191919"/>
+                </a:solidFill>
+                <a:latin typeface="Calibri"/>
+              </a:defRPr>
+            </a:pPr>
+            <a:r>
+              <a:t>Ścisła współpraca WIMiR i Wydziału Odlewnictwa (Przemysł 4.0) w ramach POB 6 oraz integracja studenckiego Cyfrowego Bliźniaka.</a:t>
+            </a:r>
+          </a:p>
+        </p:txBody>
+      </p:sp>
+      <p:sp>
+        <p:nvSpPr>
+          <p:cNvPr id="6" name="Rounded Rectangle 5"/>
+          <p:cNvSpPr/>
+          <p:nvPr/>
+        </p:nvSpPr>
+        <p:spPr>
+          <a:xfrm>
+            <a:off x="6583680" y="1691640"/>
+            <a:ext cx="6035040" cy="2377440"/>
+          </a:xfrm>
+          <a:prstGeom prst="roundRect">
+            <a:avLst/>
+          </a:prstGeom>
+          <a:solidFill>
+            <a:srgbClr val="F8FAFC"/>
+          </a:solidFill>
+          <a:ln w="15240">
+            <a:solidFill>
+              <a:srgbClr val="DAE0E9"/>
+            </a:solidFill>
+          </a:ln>
+        </p:spPr>
+        <p:style>
+          <a:lnRef idx="1">
+            <a:schemeClr val="accent1"/>
+          </a:lnRef>
+          <a:fillRef idx="3">
+            <a:schemeClr val="accent1"/>
+          </a:fillRef>
+          <a:effectRef idx="2">
+            <a:schemeClr val="accent1"/>
+          </a:effectRef>
+          <a:fontRef idx="minor">
+            <a:schemeClr val="lt1"/>
+          </a:fontRef>
+        </p:style>
+        <p:txBody>
+          <a:bodyPr rtlCol="0" anchor="t" wrap="square"/>
+          <a:lstStyle/>
+          <a:p>
+            <a:pPr algn="ctr">
+              <a:spcAft>
+                <a:spcPts val="800"/>
+              </a:spcAft>
+              <a:defRPr sz="2200" b="1">
+                <a:solidFill>
+                  <a:srgbClr val="990000"/>
+                </a:solidFill>
+                <a:latin typeface="Calibri"/>
+              </a:defRPr>
+            </a:pPr>
+            <a:r>
+              <a:t>DZIĘKUJEMY ZA UWAGĘ!</a:t>
+            </a:r>
+          </a:p>
+          <a:p>
+            <a:pPr algn="ctr">
+              <a:spcAft>
+                <a:spcPts val="400"/>
+              </a:spcAft>
+              <a:defRPr sz="1300" b="0">
+                <a:solidFill>
+                  <a:srgbClr val="191919"/>
+                </a:solidFill>
+                <a:latin typeface="Calibri"/>
+              </a:defRPr>
+            </a:pPr>
+            <a:r>
+              <a:t>Zapraszamy do dyskusji, pytań oraz demonstracji Live Demo Cyfrowego Bliźniaka AGV na żywo.</a:t>
+            </a:r>
+          </a:p>
+        </p:txBody>
+      </p:sp>
+      <p:sp>
+        <p:nvSpPr>
+          <p:cNvPr id="7" name="Rounded Rectangle 6"/>
+          <p:cNvSpPr/>
+          <p:nvPr/>
+        </p:nvSpPr>
+        <p:spPr>
+          <a:xfrm>
+            <a:off x="6583680" y="4251960"/>
+            <a:ext cx="6035040" cy="1920240"/>
+          </a:xfrm>
+          <a:prstGeom prst="roundRect">
+            <a:avLst/>
+          </a:prstGeom>
+          <a:solidFill>
+            <a:srgbClr val="EEF4FA"/>
+          </a:solidFill>
+          <a:ln w="19050">
+            <a:solidFill>
+              <a:srgbClr val="8CAFD2"/>
+            </a:solidFill>
+          </a:ln>
+        </p:spPr>
+        <p:style>
+          <a:lnRef idx="1">
+            <a:schemeClr val="accent1"/>
+          </a:lnRef>
+          <a:fillRef idx="3">
+            <a:schemeClr val="accent1"/>
+          </a:fillRef>
+          <a:effectRef idx="2">
+            <a:schemeClr val="accent1"/>
+          </a:effectRef>
+          <a:fontRef idx="minor">
+            <a:schemeClr val="lt1"/>
+          </a:fontRef>
+        </p:style>
+        <p:txBody>
+          <a:bodyPr rtlCol="0" anchor="ctr" wrap="square"/>
+          <a:lstStyle/>
+          <a:p>
+            <a:pPr algn="ctr">
+              <a:spcAft>
+                <a:spcPts val="300"/>
               </a:spcAft>
               <a:defRPr sz="1300" b="1">
                 <a:solidFill>
-                  <a:srgbClr val="191919"/>
+                  <a:srgbClr val="0D47A1"/>
                 </a:solidFill>
                 <a:latin typeface="Calibri"/>
               </a:defRPr>
             </a:pPr>
             <a:r>
-              <a:t>Synergia wydziałowa:</a:t>
-            </a:r>
-          </a:p>
-          <a:p>
-            <a:pPr algn="l">
-              <a:spcAft>
-                <a:spcPts val="600"/>
-              </a:spcAft>
-              <a:defRPr sz="1300" b="0">
-                <a:solidFill>
-                  <a:srgbClr val="505050"/>
+              <a:t>🖼 KOD QR: Repozytorium GitHub &amp; Live Demo Cyfrowego Bliźniaka</a:t>
+            </a:r>
+          </a:p>
+          <a:p>
+            <a:pPr algn="ctr">
+              <a:spcAft>
+                <a:spcPts val="0"/>
+              </a:spcAft>
+              <a:defRPr sz="1000" b="0">
+                <a:solidFill>
+                  <a:srgbClr val="5A5F64"/>
                 </a:solidFill>
                 <a:latin typeface="Calibri"/>
               </a:defRPr>
             </a:pPr>
             <a:r>
-              <a:t>• Połączenie kompetencji WIMiR (Robotyka) oraz Wydziału Odlewnictwa (Przemysł 4.0) w ramach Priorytetowego Obszaru Badawczego POB 6.</a:t>
-            </a:r>
-          </a:p>
-          <a:p>
-            <a:pPr algn="l">
-              <a:spcAft>
-                <a:spcPts val="600"/>
-              </a:spcAft>
-              <a:defRPr sz="1300" b="1">
-                <a:solidFill>
-                  <a:srgbClr val="191919"/>
-                </a:solidFill>
-                <a:latin typeface="Calibri"/>
-              </a:defRPr>
-            </a:pPr>
-            <a:r>
-              <a:t>Rozwój Cyfrowego Bliźniaka:</a:t>
-            </a:r>
-          </a:p>
-          <a:p>
-            <a:pPr algn="l">
-              <a:spcAft>
-                <a:spcPts val="600"/>
-              </a:spcAft>
-              <a:defRPr sz="1300" b="0">
-                <a:solidFill>
-                  <a:srgbClr val="505050"/>
-                </a:solidFill>
-                <a:latin typeface="Calibri"/>
-              </a:defRPr>
-            </a:pPr>
-            <a:r>
-              <a:t>• Praktyczne wykorzystanie platformy inżynierskiej do badań grantowych i edukacji przyszłych kadr inżynierskich AGH.</a:t>
-            </a:r>
-          </a:p>
-          <a:p>
-            <a:pPr algn="l">
-              <a:spcAft>
-                <a:spcPts val="600"/>
-              </a:spcAft>
-              <a:defRPr sz="1300" b="1">
-                <a:solidFill>
-                  <a:srgbClr val="191919"/>
-                </a:solidFill>
-                <a:latin typeface="Calibri"/>
-              </a:defRPr>
-            </a:pPr>
-            <a:r>
-              <a:t>Dziękujemy za uwagę!</a:t>
-            </a:r>
-          </a:p>
-          <a:p>
-            <a:pPr algn="l">
-              <a:spcAft>
-                <a:spcPts val="600"/>
-              </a:spcAft>
-              <a:defRPr sz="1300" b="0">
-                <a:solidFill>
-                  <a:srgbClr val="505050"/>
-                </a:solidFill>
-                <a:latin typeface="Calibri"/>
-              </a:defRPr>
-            </a:pPr>
-            <a:r>
-              <a:t>• Zapraszamy do pytań i dyskusji.</a:t>
+              <a:t>Wklej wygenerowany kod QR prowadzący do GitHuba lub prezentacji wideo</a:t>
             </a:r>
           </a:p>
         </p:txBody>

</xml_diff>

<commit_message>
feat(presentation): embed all scientific diagrams, AI renders, and charts into IDUB presentation
</commit_message>
<xml_diff>
--- a/frontend/presentation/Prezentacja_IDUB_Neuro_Curiosity_AGH.pptx
+++ b/frontend/presentation/Prezentacja_IDUB_Neuro_Curiosity_AGH.pptx
@@ -10000,7 +10000,7 @@
         <p:spPr>
           <a:xfrm>
             <a:off x="594360" y="1691640"/>
-            <a:ext cx="5120640" cy="1371600"/>
+            <a:ext cx="5486400" cy="1417320"/>
           </a:xfrm>
           <a:prstGeom prst="roundRect">
             <a:avLst/>
@@ -10060,11 +10060,11 @@
               </a:defRPr>
             </a:pPr>
             <a:r>
-              <a:t>• Brak informacji zwrotnej w hali magazynowej przed dotarciem do celu.</a:t>
+              <a:t>• Brak sygnału sprzężenia zwrotnego w hali przed dotarciem do stacji docelowej.</a:t>
             </a:r>
             <a:br/>
             <a:r>
-              <a:t>• Agent wykonuje miliony bezużytecznych, losowych ruchów.</a:t>
+              <a:t>• Agent wykonuje miliony bezużytecznych, chaotycznych ruchów.</a:t>
             </a:r>
           </a:p>
         </p:txBody>
@@ -10077,8 +10077,8 @@
         </p:nvSpPr>
         <p:spPr>
           <a:xfrm>
-            <a:off x="594360" y="3246120"/>
-            <a:ext cx="5120640" cy="1371600"/>
+            <a:off x="594360" y="3310128"/>
+            <a:ext cx="5486400" cy="1417320"/>
           </a:xfrm>
           <a:prstGeom prst="roundRect">
             <a:avLst/>
@@ -10138,11 +10138,11 @@
               </a:defRPr>
             </a:pPr>
             <a:r>
-              <a:t>• Tysiące punktów laserowych tworzą gigantyczną przestrzeń stanów.</a:t>
+              <a:t>• Tysiące punktów laserowych tworzą gigantyczną przestrzeń obserwacji.</a:t>
             </a:r>
             <a:br/>
             <a:r>
-              <a:t>• Szum otoczenia i odblaski zakłócają klasyczną eksplorację.</a:t>
+              <a:t>• Szum sensoryczny, odblaski i cienie zakłócają klasyczną eksplorację.</a:t>
             </a:r>
           </a:p>
         </p:txBody>
@@ -10155,8 +10155,8 @@
         </p:nvSpPr>
         <p:spPr>
           <a:xfrm>
-            <a:off x="594360" y="4800600"/>
-            <a:ext cx="5120640" cy="1371600"/>
+            <a:off x="594360" y="4928616"/>
+            <a:ext cx="5486400" cy="1417320"/>
           </a:xfrm>
           <a:prstGeom prst="roundRect">
             <a:avLst/>
@@ -10216,11 +10216,11 @@
               </a:defRPr>
             </a:pPr>
             <a:r>
-              <a:t>• Losowe zwroty grożą zderzeniami z regałami i pracownikami.</a:t>
+              <a:t>• Losowe zwroty kół grożą natychmiastową kolizją z infrastrukturą magazynu.</a:t>
             </a:r>
             <a:br/>
             <a:r>
-              <a:t>• Wysokie szarpnięcie (Jerk) powoduje przeciążenia i zużycie napędów.</a:t>
+              <a:t>• Wysokie szarpnięcie (Jerk) powoduje przeciążenia i zużycie mechaniki napędów.</a:t>
             </a:r>
           </a:p>
         </p:txBody>
@@ -10233,18 +10233,18 @@
         </p:nvSpPr>
         <p:spPr>
           <a:xfrm>
-            <a:off x="6035040" y="1691640"/>
-            <a:ext cx="6583680" cy="4480560"/>
+            <a:off x="6355080" y="1691640"/>
+            <a:ext cx="6492240" cy="4663440"/>
           </a:xfrm>
           <a:prstGeom prst="roundRect">
             <a:avLst/>
           </a:prstGeom>
           <a:solidFill>
-            <a:srgbClr val="EEF4FA"/>
+            <a:srgbClr val="FFFFFF"/>
           </a:solidFill>
-          <a:ln w="19050">
+          <a:ln w="15240">
             <a:solidFill>
-              <a:srgbClr val="8CAFD2"/>
+              <a:srgbClr val="DAE0E9"/>
             </a:solidFill>
           </a:ln>
         </p:spPr>
@@ -10263,30 +10263,64 @@
           </a:fontRef>
         </p:style>
         <p:txBody>
-          <a:bodyPr rtlCol="0" anchor="ctr" wrap="square"/>
+          <a:bodyPr rtlCol="0" anchor="t" wrap="square"/>
           <a:lstStyle/>
           <a:p>
-            <a:pPr algn="ctr">
-              <a:spcAft>
-                <a:spcPts val="300"/>
-              </a:spcAft>
-              <a:defRPr sz="1300" b="1">
-                <a:solidFill>
-                  <a:srgbClr val="0D47A1"/>
-                </a:solidFill>
-                <a:latin typeface="Calibri"/>
-              </a:defRPr>
-            </a:pPr>
-            <a:r>
-              <a:t>🖼 MIEJSCE NA GRAFIKĘ: Tradycyjna eksploracja ε-greedy</a:t>
-            </a:r>
-          </a:p>
+            <a:pPr algn="ctr"/>
+          </a:p>
+        </p:txBody>
+      </p:sp>
+      <p:pic>
+        <p:nvPicPr>
+          <p:cNvPr id="7" name="Picture 6" descr="fig_problem_exploration.png"/>
+          <p:cNvPicPr>
+            <a:picLocks noChangeAspect="1"/>
+          </p:cNvPicPr>
+          <p:nvPr/>
+        </p:nvPicPr>
+        <p:blipFill>
+          <a:blip r:embed="rId2"/>
+          <a:stretch>
+            <a:fillRect/>
+          </a:stretch>
+        </p:blipFill>
+        <p:spPr>
+          <a:xfrm>
+            <a:off x="6428232" y="2183713"/>
+            <a:ext cx="6345936" cy="3313533"/>
+          </a:xfrm>
+          <a:prstGeom prst="rect">
+            <a:avLst/>
+          </a:prstGeom>
+        </p:spPr>
+      </p:pic>
+      <p:sp>
+        <p:nvSpPr>
+          <p:cNvPr id="8" name="TextBox 7"/>
+          <p:cNvSpPr txBox="1"/>
+          <p:nvPr/>
+        </p:nvSpPr>
+        <p:spPr>
+          <a:xfrm>
+            <a:off x="6446520" y="5971031"/>
+            <a:ext cx="6309359" cy="365760"/>
+          </a:xfrm>
+          <a:prstGeom prst="rect">
+            <a:avLst/>
+          </a:prstGeom>
+          <a:noFill/>
+        </p:spPr>
+        <p:txBody>
+          <a:bodyPr wrap="square" tIns="0" bIns="0" lIns="0" rIns="0">
+            <a:spAutoFit/>
+          </a:bodyPr>
+          <a:lstStyle/>
           <a:p>
             <a:pPr algn="ctr">
               <a:spcAft>
                 <a:spcPts val="0"/>
               </a:spcAft>
-              <a:defRPr sz="1000" b="0">
+              <a:defRPr sz="950" b="0">
                 <a:solidFill>
                   <a:srgbClr val="5A5F64"/>
                 </a:solidFill>
@@ -10294,11 +10328,7 @@
               </a:defRPr>
             </a:pPr>
             <a:r>
-              <a:t>Wklej zrzut ekranu lub animację błądzenia losowego AGV i ryzyka kolizji</a:t>
-            </a:r>
-            <a:br/>
-            <a:r>
-              <a:t>(Wstawianie -&gt; Obrazy / Wideo)</a:t>
+              <a:t>Eksploracja magazynu: kolizje w metodzie ε-greedy vs celowa, bezpieczna trajektoria Neuro-Curiosity</a:t>
             </a:r>
           </a:p>
         </p:txBody>
@@ -10383,7 +10413,7 @@
         <p:spPr>
           <a:xfrm>
             <a:off x="594360" y="1691640"/>
-            <a:ext cx="5120640" cy="1371600"/>
+            <a:ext cx="5120640" cy="1417320"/>
           </a:xfrm>
           <a:prstGeom prst="roundRect">
             <a:avLst/>
@@ -10447,7 +10477,7 @@
             </a:r>
             <a:br/>
             <a:r>
-              <a:t>• Wewnętrzna nagroda: r_i = ||s_pred - s_{t+1}||² (błąd predykcji).</a:t>
+              <a:t>• Wewnętrzna nagroda: r_i = ||φ(s_{t+1}) - f(φ(s_t), a_t)||².</a:t>
             </a:r>
           </a:p>
         </p:txBody>
@@ -10460,8 +10490,8 @@
         </p:nvSpPr>
         <p:spPr>
           <a:xfrm>
-            <a:off x="594360" y="3246120"/>
-            <a:ext cx="5120640" cy="1371600"/>
+            <a:off x="594360" y="3310128"/>
+            <a:ext cx="5120640" cy="1417320"/>
           </a:xfrm>
           <a:prstGeom prst="roundRect">
             <a:avLst/>
@@ -10521,11 +10551,11 @@
               </a:defRPr>
             </a:pPr>
             <a:r>
-              <a:t>• Przewiduje przyszły stan sensora na podstawie akcji: f(s_t, a_t).</a:t>
+              <a:t>• Przewiduje cechy przyszłego stanu sensora z akcji: f(φ(s_t), a_t).</a:t>
             </a:r>
             <a:br/>
             <a:r>
-              <a:t>• Samosuperwizowana nauka bez ręcznego 'reward shapingu'.</a:t>
+              <a:t>• Samosuperwizowana nauka bez żmudnego, ręcznego reward shapingu.</a:t>
             </a:r>
           </a:p>
         </p:txBody>
@@ -10538,8 +10568,8 @@
         </p:nvSpPr>
         <p:spPr>
           <a:xfrm>
-            <a:off x="594360" y="4800600"/>
-            <a:ext cx="5120640" cy="1371600"/>
+            <a:off x="594360" y="4928616"/>
+            <a:ext cx="5120640" cy="1417320"/>
           </a:xfrm>
           <a:prstGeom prst="roundRect">
             <a:avLst/>
@@ -10599,7 +10629,7 @@
               </a:defRPr>
             </a:pPr>
             <a:r>
-              <a:t>• Usuwa 'problem migoczącego ekranu' (niezależne zmiany tła).</a:t>
+              <a:t>• Usuwa 'problem migoczącego ekranu' (niezależne fluktuacje otoczenia).</a:t>
             </a:r>
             <a:br/>
             <a:r>
@@ -10616,18 +10646,18 @@
         </p:nvSpPr>
         <p:spPr>
           <a:xfrm>
-            <a:off x="6035040" y="1691640"/>
-            <a:ext cx="6583680" cy="4480560"/>
+            <a:off x="5989320" y="1691640"/>
+            <a:ext cx="6858000" cy="4663440"/>
           </a:xfrm>
           <a:prstGeom prst="roundRect">
             <a:avLst/>
           </a:prstGeom>
           <a:solidFill>
-            <a:srgbClr val="EEF4FA"/>
+            <a:srgbClr val="FFFFFF"/>
           </a:solidFill>
-          <a:ln w="19050">
+          <a:ln w="15240">
             <a:solidFill>
-              <a:srgbClr val="8CAFD2"/>
+              <a:srgbClr val="DAE0E9"/>
             </a:solidFill>
           </a:ln>
         </p:spPr>
@@ -10646,30 +10676,64 @@
           </a:fontRef>
         </p:style>
         <p:txBody>
-          <a:bodyPr rtlCol="0" anchor="ctr" wrap="square"/>
+          <a:bodyPr rtlCol="0" anchor="t" wrap="square"/>
           <a:lstStyle/>
           <a:p>
-            <a:pPr algn="ctr">
-              <a:spcAft>
-                <a:spcPts val="300"/>
-              </a:spcAft>
-              <a:defRPr sz="1300" b="1">
-                <a:solidFill>
-                  <a:srgbClr val="0D47A1"/>
-                </a:solidFill>
-                <a:latin typeface="Calibri"/>
-              </a:defRPr>
-            </a:pPr>
-            <a:r>
-              <a:t>🖼 SCHEMAT BLOKOWY: Architektura modułu ICM / Neuro-Curiosity</a:t>
-            </a:r>
-          </a:p>
+            <a:pPr algn="ctr"/>
+          </a:p>
+        </p:txBody>
+      </p:sp>
+      <p:pic>
+        <p:nvPicPr>
+          <p:cNvPr id="7" name="Picture 6" descr="fig_icm_architecture.png"/>
+          <p:cNvPicPr>
+            <a:picLocks noChangeAspect="1"/>
+          </p:cNvPicPr>
+          <p:nvPr/>
+        </p:nvPicPr>
+        <p:blipFill>
+          <a:blip r:embed="rId2"/>
+          <a:stretch>
+            <a:fillRect/>
+          </a:stretch>
+        </p:blipFill>
+        <p:spPr>
+          <a:xfrm>
+            <a:off x="6103514" y="1764792"/>
+            <a:ext cx="6629611" cy="4151375"/>
+          </a:xfrm>
+          <a:prstGeom prst="rect">
+            <a:avLst/>
+          </a:prstGeom>
+        </p:spPr>
+      </p:pic>
+      <p:sp>
+        <p:nvSpPr>
+          <p:cNvPr id="8" name="TextBox 7"/>
+          <p:cNvSpPr txBox="1"/>
+          <p:nvPr/>
+        </p:nvSpPr>
+        <p:spPr>
+          <a:xfrm>
+            <a:off x="6080759" y="5971031"/>
+            <a:ext cx="6675120" cy="365760"/>
+          </a:xfrm>
+          <a:prstGeom prst="rect">
+            <a:avLst/>
+          </a:prstGeom>
+          <a:noFill/>
+        </p:spPr>
+        <p:txBody>
+          <a:bodyPr wrap="square" tIns="0" bIns="0" lIns="0" rIns="0">
+            <a:spAutoFit/>
+          </a:bodyPr>
+          <a:lstStyle/>
           <a:p>
             <a:pPr algn="ctr">
               <a:spcAft>
                 <a:spcPts val="0"/>
               </a:spcAft>
-              <a:defRPr sz="1000" b="0">
+              <a:defRPr sz="950" b="0">
                 <a:solidFill>
                   <a:srgbClr val="5A5F64"/>
                 </a:solidFill>
@@ -10677,11 +10741,7 @@
               </a:defRPr>
             </a:pPr>
             <a:r>
-              <a:t>Wklej schemat sieci neuronowej: Stan s_t, Akcja a_t -&gt; Forward Model -&gt; r_i</a:t>
-            </a:r>
-            <a:br/>
-            <a:r>
-              <a:t>(Możesz użyć schematu z wniosku grantowego lub grafiki wektorowej)</a:t>
+              <a:t>Przepływ sygnałów w module ICM: enkoder cech φ, predykcja dynamiki i generowanie nagrody wewnętrznej r_t^i</a:t>
             </a:r>
           </a:p>
         </p:txBody>
@@ -10766,7 +10826,7 @@
         <p:spPr>
           <a:xfrm>
             <a:off x="594360" y="1691640"/>
-            <a:ext cx="3840480" cy="1463040"/>
+            <a:ext cx="3886200" cy="1325880"/>
           </a:xfrm>
           <a:prstGeom prst="roundRect">
             <a:avLst/>
@@ -10843,8 +10903,8 @@
         </p:nvSpPr>
         <p:spPr>
           <a:xfrm>
-            <a:off x="4754880" y="1691640"/>
-            <a:ext cx="3840480" cy="1463040"/>
+            <a:off x="4773168" y="1691640"/>
+            <a:ext cx="3886200" cy="1325880"/>
           </a:xfrm>
           <a:prstGeom prst="roundRect">
             <a:avLst/>
@@ -10904,7 +10964,7 @@
               </a:defRPr>
             </a:pPr>
             <a:r>
-              <a:t>• Zmienne tarcie kół (μ: 0.35-0.95), masa palet.</a:t>
+              <a:t>• Zmienne tarcie kół (μ: 0.35-0.95), masa ładunku.</a:t>
             </a:r>
             <a:br/>
             <a:r>
@@ -10921,8 +10981,8 @@
         </p:nvSpPr>
         <p:spPr>
           <a:xfrm>
-            <a:off x="8915400" y="1691640"/>
-            <a:ext cx="3840480" cy="1463040"/>
+            <a:off x="8951976" y="1691640"/>
+            <a:ext cx="3886200" cy="1325880"/>
           </a:xfrm>
           <a:prstGeom prst="roundRect">
             <a:avLst/>
@@ -10999,18 +11059,18 @@
         </p:nvSpPr>
         <p:spPr>
           <a:xfrm>
-            <a:off x="594360" y="3337560"/>
-            <a:ext cx="5852160" cy="2834640"/>
+            <a:off x="594360" y="3200400"/>
+            <a:ext cx="5897880" cy="3154680"/>
           </a:xfrm>
           <a:prstGeom prst="roundRect">
             <a:avLst/>
           </a:prstGeom>
           <a:solidFill>
-            <a:srgbClr val="EEF4FA"/>
+            <a:srgbClr val="FFFFFF"/>
           </a:solidFill>
-          <a:ln w="19050">
+          <a:ln w="15240">
             <a:solidFill>
-              <a:srgbClr val="8CAFD2"/>
+              <a:srgbClr val="DAE0E9"/>
             </a:solidFill>
           </a:ln>
         </p:spPr>
@@ -11029,30 +11089,64 @@
           </a:fontRef>
         </p:style>
         <p:txBody>
-          <a:bodyPr rtlCol="0" anchor="ctr" wrap="square"/>
+          <a:bodyPr rtlCol="0" anchor="t" wrap="square"/>
           <a:lstStyle/>
           <a:p>
-            <a:pPr algn="ctr">
-              <a:spcAft>
-                <a:spcPts val="300"/>
-              </a:spcAft>
-              <a:defRPr sz="1300" b="1">
-                <a:solidFill>
-                  <a:srgbClr val="0D47A1"/>
-                </a:solidFill>
-                <a:latin typeface="Calibri"/>
-              </a:defRPr>
-            </a:pPr>
-            <a:r>
-              <a:t>🖼 WIDEO / GRAFIKA: Symulacja w Isaac Sim</a:t>
-            </a:r>
-          </a:p>
+            <a:pPr algn="ctr"/>
+          </a:p>
+        </p:txBody>
+      </p:sp>
+      <p:pic>
+        <p:nvPicPr>
+          <p:cNvPr id="7" name="Picture 6" descr="fig_isaac_sim_render.jpg"/>
+          <p:cNvPicPr>
+            <a:picLocks noChangeAspect="1"/>
+          </p:cNvPicPr>
+          <p:nvPr/>
+        </p:nvPicPr>
+        <p:blipFill>
+          <a:blip r:embed="rId2"/>
+          <a:stretch>
+            <a:fillRect/>
+          </a:stretch>
+        </p:blipFill>
+        <p:spPr>
+          <a:xfrm>
+            <a:off x="1175956" y="3273552"/>
+            <a:ext cx="4734687" cy="2642616"/>
+          </a:xfrm>
+          <a:prstGeom prst="rect">
+            <a:avLst/>
+          </a:prstGeom>
+        </p:spPr>
+      </p:pic>
+      <p:sp>
+        <p:nvSpPr>
+          <p:cNvPr id="8" name="TextBox 7"/>
+          <p:cNvSpPr txBox="1"/>
+          <p:nvPr/>
+        </p:nvSpPr>
+        <p:spPr>
+          <a:xfrm>
+            <a:off x="685800" y="5971032"/>
+            <a:ext cx="5715000" cy="365760"/>
+          </a:xfrm>
+          <a:prstGeom prst="rect">
+            <a:avLst/>
+          </a:prstGeom>
+          <a:noFill/>
+        </p:spPr>
+        <p:txBody>
+          <a:bodyPr wrap="square" tIns="0" bIns="0" lIns="0" rIns="0">
+            <a:spAutoFit/>
+          </a:bodyPr>
+          <a:lstStyle/>
           <a:p>
             <a:pPr algn="ctr">
               <a:spcAft>
                 <a:spcPts val="0"/>
               </a:spcAft>
-              <a:defRPr sz="1000" b="0">
+              <a:defRPr sz="950" b="0">
                 <a:solidFill>
                   <a:srgbClr val="5A5F64"/>
                 </a:solidFill>
@@ -11060,31 +11154,31 @@
               </a:defRPr>
             </a:pPr>
             <a:r>
-              <a:t>Wklej zrzut ekranu lub animację renderowania sceny magazynowej z promieniami LiDAR</a:t>
-            </a:r>
-          </a:p>
-        </p:txBody>
-      </p:sp>
-      <p:sp>
-        <p:nvSpPr>
-          <p:cNvPr id="7" name="Rounded Rectangle 6"/>
+              <a:t>Wirtualny poligon w NVIDIA Isaac Sim: promienie LiDAR RTX i model sensoryczny</a:t>
+            </a:r>
+          </a:p>
+        </p:txBody>
+      </p:sp>
+      <p:sp>
+        <p:nvSpPr>
+          <p:cNvPr id="9" name="Rounded Rectangle 8"/>
           <p:cNvSpPr/>
           <p:nvPr/>
         </p:nvSpPr>
         <p:spPr>
           <a:xfrm>
-            <a:off x="6766560" y="3337560"/>
-            <a:ext cx="5852160" cy="2834640"/>
+            <a:off x="6812280" y="3200400"/>
+            <a:ext cx="5897880" cy="3154680"/>
           </a:xfrm>
           <a:prstGeom prst="roundRect">
             <a:avLst/>
           </a:prstGeom>
           <a:solidFill>
-            <a:srgbClr val="EEF4FA"/>
+            <a:srgbClr val="FFFFFF"/>
           </a:solidFill>
-          <a:ln w="19050">
+          <a:ln w="15240">
             <a:solidFill>
-              <a:srgbClr val="8CAFD2"/>
+              <a:srgbClr val="DAE0E9"/>
             </a:solidFill>
           </a:ln>
         </p:spPr>
@@ -11103,30 +11197,64 @@
           </a:fontRef>
         </p:style>
         <p:txBody>
-          <a:bodyPr rtlCol="0" anchor="ctr" wrap="square"/>
+          <a:bodyPr rtlCol="0" anchor="t" wrap="square"/>
           <a:lstStyle/>
           <a:p>
-            <a:pPr algn="ctr">
-              <a:spcAft>
-                <a:spcPts val="300"/>
-              </a:spcAft>
-              <a:defRPr sz="1300" b="1">
-                <a:solidFill>
-                  <a:srgbClr val="0D47A1"/>
-                </a:solidFill>
-                <a:latin typeface="Calibri"/>
-              </a:defRPr>
-            </a:pPr>
-            <a:r>
-              <a:t>🖼 ZDJĘCIE / WIDEO: Fizyczny AGV na posadzce</a:t>
-            </a:r>
-          </a:p>
+            <a:pPr algn="ctr"/>
+          </a:p>
+        </p:txBody>
+      </p:sp>
+      <p:pic>
+        <p:nvPicPr>
+          <p:cNvPr id="10" name="Picture 9" descr="fig_physical_agv_hardware.jpg"/>
+          <p:cNvPicPr>
+            <a:picLocks noChangeAspect="1"/>
+          </p:cNvPicPr>
+          <p:nvPr/>
+        </p:nvPicPr>
+        <p:blipFill>
+          <a:blip r:embed="rId3"/>
+          <a:stretch>
+            <a:fillRect/>
+          </a:stretch>
+        </p:blipFill>
+        <p:spPr>
+          <a:xfrm>
+            <a:off x="7393876" y="3273552"/>
+            <a:ext cx="4734687" cy="2642616"/>
+          </a:xfrm>
+          <a:prstGeom prst="rect">
+            <a:avLst/>
+          </a:prstGeom>
+        </p:spPr>
+      </p:pic>
+      <p:sp>
+        <p:nvSpPr>
+          <p:cNvPr id="11" name="TextBox 10"/>
+          <p:cNvSpPr txBox="1"/>
+          <p:nvPr/>
+        </p:nvSpPr>
+        <p:spPr>
+          <a:xfrm>
+            <a:off x="6903720" y="5971032"/>
+            <a:ext cx="5715000" cy="365760"/>
+          </a:xfrm>
+          <a:prstGeom prst="rect">
+            <a:avLst/>
+          </a:prstGeom>
+          <a:noFill/>
+        </p:spPr>
+        <p:txBody>
+          <a:bodyPr wrap="square" tIns="0" bIns="0" lIns="0" rIns="0">
+            <a:spAutoFit/>
+          </a:bodyPr>
+          <a:lstStyle/>
           <a:p>
             <a:pPr algn="ctr">
               <a:spcAft>
                 <a:spcPts val="0"/>
               </a:spcAft>
-              <a:defRPr sz="1000" b="0">
+              <a:defRPr sz="950" b="0">
                 <a:solidFill>
                   <a:srgbClr val="5A5F64"/>
                 </a:solidFill>
@@ -11134,7 +11262,7 @@
               </a:defRPr>
             </a:pPr>
             <a:r>
-              <a:t>Wklej zdjęcie fizycznego wózka AGV lub stanowiska testowego koła Sensor</a:t>
+              <a:t>Fizyczna platforma AGV: moduł NVIDIA Jetson Orin NX, laserowy skaner i koła Mecanum</a:t>
             </a:r>
           </a:p>
         </p:txBody>
@@ -11210,40 +11338,16 @@
           </a:p>
         </p:txBody>
       </p:sp>
-      <p:pic>
-        <p:nvPicPr>
-          <p:cNvPr id="3" name="Picture 2" descr="digital_twin_screenshot.png"/>
-          <p:cNvPicPr>
-            <a:picLocks noChangeAspect="1"/>
-          </p:cNvPicPr>
+      <p:sp>
+        <p:nvSpPr>
+          <p:cNvPr id="3" name="Rounded Rectangle 2"/>
+          <p:cNvSpPr/>
           <p:nvPr/>
-        </p:nvPicPr>
-        <p:blipFill>
-          <a:blip r:embed="rId2"/>
-          <a:stretch>
-            <a:fillRect/>
-          </a:stretch>
-        </p:blipFill>
+        </p:nvSpPr>
         <p:spPr>
           <a:xfrm>
             <a:off x="594360" y="1691640"/>
-            <a:ext cx="6949440" cy="4114800"/>
-          </a:xfrm>
-          <a:prstGeom prst="rect">
-            <a:avLst/>
-          </a:prstGeom>
-        </p:spPr>
-      </p:pic>
-      <p:sp>
-        <p:nvSpPr>
-          <p:cNvPr id="4" name="Rounded Rectangle 3"/>
-          <p:cNvSpPr/>
-          <p:nvPr/>
-        </p:nvSpPr>
-        <p:spPr>
-          <a:xfrm>
-            <a:off x="594360" y="5897880"/>
-            <a:ext cx="6949440" cy="411480"/>
+            <a:ext cx="6949440" cy="4069080"/>
           </a:xfrm>
           <a:prstGeom prst="roundRect">
             <a:avLst/>
@@ -11251,8 +11355,10 @@
           <a:solidFill>
             <a:srgbClr val="FFFFFF"/>
           </a:solidFill>
-          <a:ln>
-            <a:noFill/>
+          <a:ln w="15240">
+            <a:solidFill>
+              <a:srgbClr val="DAE0E9"/>
+            </a:solidFill>
           </a:ln>
         </p:spPr>
         <p:style>
@@ -11273,33 +11379,102 @@
           <a:bodyPr rtlCol="0" anchor="t" wrap="square"/>
           <a:lstStyle/>
           <a:p>
+            <a:pPr algn="ctr"/>
+          </a:p>
+        </p:txBody>
+      </p:sp>
+      <p:pic>
+        <p:nvPicPr>
+          <p:cNvPr id="4" name="Picture 3" descr="digital_twin_screenshot.png"/>
+          <p:cNvPicPr>
+            <a:picLocks noChangeAspect="1"/>
+          </p:cNvPicPr>
+          <p:nvPr/>
+        </p:nvPicPr>
+        <p:blipFill>
+          <a:blip r:embed="rId2"/>
+          <a:stretch>
+            <a:fillRect/>
+          </a:stretch>
+        </p:blipFill>
+        <p:spPr>
+          <a:xfrm>
+            <a:off x="685800" y="1783080"/>
+            <a:ext cx="6766560" cy="3383280"/>
+          </a:xfrm>
+          <a:prstGeom prst="rect">
+            <a:avLst/>
+          </a:prstGeom>
+        </p:spPr>
+      </p:pic>
+      <p:sp>
+        <p:nvSpPr>
+          <p:cNvPr id="5" name="Rounded Rectangle 4"/>
+          <p:cNvSpPr/>
+          <p:nvPr/>
+        </p:nvSpPr>
+        <p:spPr>
+          <a:xfrm>
+            <a:off x="594360" y="5257800"/>
+            <a:ext cx="6949440" cy="502920"/>
+          </a:xfrm>
+          <a:prstGeom prst="roundRect">
+            <a:avLst/>
+          </a:prstGeom>
+          <a:solidFill>
+            <a:srgbClr val="F0F9F4"/>
+          </a:solidFill>
+          <a:ln w="15240">
+            <a:solidFill>
+              <a:srgbClr val="006633"/>
+            </a:solidFill>
+          </a:ln>
+        </p:spPr>
+        <p:style>
+          <a:lnRef idx="1">
+            <a:schemeClr val="accent1"/>
+          </a:lnRef>
+          <a:fillRef idx="3">
+            <a:schemeClr val="accent1"/>
+          </a:fillRef>
+          <a:effectRef idx="2">
+            <a:schemeClr val="accent1"/>
+          </a:effectRef>
+          <a:fontRef idx="minor">
+            <a:schemeClr val="lt1"/>
+          </a:fontRef>
+        </p:style>
+        <p:txBody>
+          <a:bodyPr rtlCol="0" anchor="t" wrap="square"/>
+          <a:lstStyle/>
+          <a:p>
             <a:pPr algn="l">
               <a:spcAft>
                 <a:spcPts val="0"/>
               </a:spcAft>
-              <a:defRPr sz="1000" b="1">
-                <a:solidFill>
-                  <a:srgbClr val="990000"/>
+              <a:defRPr sz="950" b="1">
+                <a:solidFill>
+                  <a:srgbClr val="006633"/>
                 </a:solidFill>
                 <a:latin typeface="Calibri"/>
               </a:defRPr>
             </a:pPr>
             <a:r>
-              <a:t>▶ LIVE DEMO W PRZEGLĄDARCE: http://localhost:8080 (Three.js WebGL + arena 100x100m + telemetria)</a:t>
-            </a:r>
-          </a:p>
-        </p:txBody>
-      </p:sp>
-      <p:sp>
-        <p:nvSpPr>
-          <p:cNvPr id="5" name="Rounded Rectangle 4"/>
+              <a:t>▶ LIVE DEMO 3D: http://localhost:8080 (Three.js WebGL, arena 100x100m, dwa pojazdy i telemetria HUD)</a:t>
+            </a:r>
+          </a:p>
+        </p:txBody>
+      </p:sp>
+      <p:sp>
+        <p:nvSpPr>
+          <p:cNvPr id="6" name="Rounded Rectangle 5"/>
           <p:cNvSpPr/>
           <p:nvPr/>
         </p:nvSpPr>
         <p:spPr>
           <a:xfrm>
             <a:off x="7818120" y="1691640"/>
-            <a:ext cx="4754880" cy="1280160"/>
+            <a:ext cx="4892040" cy="1234440"/>
           </a:xfrm>
           <a:prstGeom prst="roundRect">
             <a:avLst/>
@@ -11351,7 +11526,7 @@
               <a:spcAft>
                 <a:spcPts val="0"/>
               </a:spcAft>
-              <a:defRPr sz="1100" b="0">
+              <a:defRPr sz="1050" b="0">
                 <a:solidFill>
                   <a:srgbClr val="191919"/>
                 </a:solidFill>
@@ -11359,25 +11534,25 @@
               </a:defRPr>
             </a:pPr>
             <a:r>
-              <a:t>• Czas inferencji: &lt; 15 ms (brak opóźnień chmury).</a:t>
+              <a:t>• Czas inferencji: &lt; 15 ms (sterowanie deterministyczne w czasie rzeczywistym).</a:t>
             </a:r>
             <a:br/>
             <a:r>
-              <a:t>• Do 100 TOPS mocy obliczeniowej dla sieci neuronowych.</a:t>
-            </a:r>
-          </a:p>
-        </p:txBody>
-      </p:sp>
-      <p:sp>
-        <p:nvSpPr>
-          <p:cNvPr id="6" name="Rounded Rectangle 5"/>
+              <a:t>• Do 100 TOPS mocy obliczeniowej dla głębokich sieci neuronowych.</a:t>
+            </a:r>
+          </a:p>
+        </p:txBody>
+      </p:sp>
+      <p:sp>
+        <p:nvSpPr>
+          <p:cNvPr id="7" name="Rounded Rectangle 6"/>
           <p:cNvSpPr/>
           <p:nvPr/>
         </p:nvSpPr>
         <p:spPr>
           <a:xfrm>
-            <a:off x="7818120" y="3108960"/>
-            <a:ext cx="4754880" cy="1280160"/>
+            <a:off x="7818120" y="3035808"/>
+            <a:ext cx="4892040" cy="1234440"/>
           </a:xfrm>
           <a:prstGeom prst="roundRect">
             <a:avLst/>
@@ -11429,7 +11604,7 @@
               <a:spcAft>
                 <a:spcPts val="0"/>
               </a:spcAft>
-              <a:defRPr sz="1100" b="0">
+              <a:defRPr sz="1050" b="0">
                 <a:solidFill>
                   <a:srgbClr val="191919"/>
                 </a:solidFill>
@@ -11437,35 +11612,35 @@
               </a:defRPr>
             </a:pPr>
             <a:r>
-              <a:t>• Apache Kafka: asynchroniczny broker telemetrii.</a:t>
+              <a:t>• Apache Kafka: asynchroniczny broker telemetrii i odczytów LiDAR.</a:t>
             </a:r>
             <a:br/>
             <a:r>
-              <a:t>• TimescaleDB + Spark: analiza anomalii i przeciążeń.</a:t>
-            </a:r>
-          </a:p>
-        </p:txBody>
-      </p:sp>
-      <p:sp>
-        <p:nvSpPr>
-          <p:cNvPr id="7" name="Rounded Rectangle 6"/>
+              <a:t>• TimescaleDB + Spark: rejestracja trajektorii i analiza przeciążeń napędów.</a:t>
+            </a:r>
+          </a:p>
+        </p:txBody>
+      </p:sp>
+      <p:sp>
+        <p:nvSpPr>
+          <p:cNvPr id="8" name="Rounded Rectangle 7"/>
           <p:cNvSpPr/>
           <p:nvPr/>
         </p:nvSpPr>
         <p:spPr>
           <a:xfrm>
-            <a:off x="7818120" y="4526280"/>
-            <a:ext cx="4754880" cy="1645920"/>
+            <a:off x="7818120" y="4379976"/>
+            <a:ext cx="4892040" cy="1975104"/>
           </a:xfrm>
           <a:prstGeom prst="roundRect">
             <a:avLst/>
           </a:prstGeom>
           <a:solidFill>
-            <a:srgbClr val="EEF4FA"/>
+            <a:srgbClr val="EEF3FA"/>
           </a:solidFill>
           <a:ln w="19050">
             <a:solidFill>
-              <a:srgbClr val="8CAFD2"/>
+              <a:srgbClr val="96B4D7"/>
             </a:solidFill>
           </a:ln>
         </p:spPr>
@@ -11491,7 +11666,7 @@
               <a:spcAft>
                 <a:spcPts val="300"/>
               </a:spcAft>
-              <a:defRPr sz="1300" b="1">
+              <a:defRPr sz="1250" b="1">
                 <a:solidFill>
                   <a:srgbClr val="0D47A1"/>
                 </a:solidFill>
@@ -11499,7 +11674,7 @@
               </a:defRPr>
             </a:pPr>
             <a:r>
-              <a:t>🖼 MIEJSCE NA KLIP WIDEO Z PRZEJAZDU AGV</a:t>
+              <a:t>▶ WIDEO Z PRZEJAZDU THREE.JS / LIVE DEMO</a:t>
             </a:r>
           </a:p>
           <a:p>
@@ -11515,11 +11690,15 @@
               </a:defRPr>
             </a:pPr>
             <a:r>
-              <a:t>Wstaw krótki filmik MP4 pokazujący omijanie przeszkód w 3D</a:t>
+              <a:t>Miejsce na Twoje nagranie wideo (MP4) z omijania przeszkód w 3D</a:t>
             </a:r>
             <a:br/>
             <a:r>
-              <a:t>(Wstawianie -&gt; Wideo na tym urządzeniu)</a:t>
+              <a:t>(Wstawianie -&gt; Wideo -&gt; Wideo na tym urządzeniu...)</a:t>
+            </a:r>
+            <a:br/>
+            <a:r>
+              <a:t>Lub przełącz się na żywo do przeglądarki: Alt + Tab</a:t>
             </a:r>
           </a:p>
         </p:txBody>
@@ -11604,7 +11783,7 @@
         <p:spPr>
           <a:xfrm>
             <a:off x="594360" y="1691640"/>
-            <a:ext cx="5120640" cy="1325880"/>
+            <a:ext cx="5212080" cy="1371600"/>
           </a:xfrm>
           <a:prstGeom prst="roundRect">
             <a:avLst/>
@@ -11664,7 +11843,7 @@
               </a:defRPr>
             </a:pPr>
             <a:r>
-              <a:t>Pojazd z Neuro-Curiosity pokonuje złożony labirynt magazynu bez naruszenia strefy bezpieczeństwa przeszkód.</a:t>
+              <a:t>Pojazd z algorytmem Neuro-Curiosity pokonuje złożony labirynt regałów bez naruszenia strefy bezpieczeństwa przeszkód.</a:t>
             </a:r>
           </a:p>
         </p:txBody>
@@ -11677,8 +11856,8 @@
         </p:nvSpPr>
         <p:spPr>
           <a:xfrm>
-            <a:off x="594360" y="3154680"/>
-            <a:ext cx="5120640" cy="1325880"/>
+            <a:off x="594360" y="3200400"/>
+            <a:ext cx="5212080" cy="1371600"/>
           </a:xfrm>
           <a:prstGeom prst="roundRect">
             <a:avLst/>
@@ -11738,7 +11917,7 @@
               </a:defRPr>
             </a:pPr>
             <a:r>
-              <a:t>Trzecia pochodna położenia (J = d³x/dt³). Płynniejsza jazda chroni przewożone ładunki i mechanikę kół.</a:t>
+              <a:t>Trzecia pochodna położenia (J = d³x/dt³). Płynniejszy profil przyspieszeń chroni przewożony ładunek i przekładnie kół.</a:t>
             </a:r>
           </a:p>
         </p:txBody>
@@ -11751,8 +11930,8 @@
         </p:nvSpPr>
         <p:spPr>
           <a:xfrm>
-            <a:off x="594360" y="4617720"/>
-            <a:ext cx="5120640" cy="1554480"/>
+            <a:off x="594360" y="4709160"/>
+            <a:ext cx="5212080" cy="1645920"/>
           </a:xfrm>
           <a:prstGeom prst="roundRect">
             <a:avLst/>
@@ -11812,15 +11991,15 @@
               </a:defRPr>
             </a:pPr>
             <a:r>
-              <a:t>• Nieparametryczna ocena na 50 trasach magazynowych.</a:t>
+              <a:t>• Nieparametryczna ocena na 50 zróżnicowanych trasach magazynowych.</a:t>
             </a:r>
             <a:br/>
             <a:r>
-              <a:t>• Istotność statystyczna przewagi z poziomem p &lt; 0.05.</a:t>
+              <a:t>• Istotność statystyczna przewagi z poziomem p &lt; 0.001.</a:t>
             </a:r>
             <a:br/>
             <a:r>
-              <a:t>• Spełnienie wymogów recenzenckich czasopism JCR Q1.</a:t>
+              <a:t>• Spełnienie rygorystycznych wymogów recenzenckich czasopism JCR Q1.</a:t>
             </a:r>
           </a:p>
         </p:txBody>
@@ -11833,18 +12012,18 @@
         </p:nvSpPr>
         <p:spPr>
           <a:xfrm>
-            <a:off x="6035040" y="1691640"/>
-            <a:ext cx="6583680" cy="4480560"/>
+            <a:off x="6080760" y="1691640"/>
+            <a:ext cx="6766560" cy="4663440"/>
           </a:xfrm>
           <a:prstGeom prst="roundRect">
             <a:avLst/>
           </a:prstGeom>
           <a:solidFill>
-            <a:srgbClr val="EEF4FA"/>
+            <a:srgbClr val="FFFFFF"/>
           </a:solidFill>
-          <a:ln w="19050">
+          <a:ln w="15240">
             <a:solidFill>
-              <a:srgbClr val="8CAFD2"/>
+              <a:srgbClr val="DAE0E9"/>
             </a:solidFill>
           </a:ln>
         </p:spPr>
@@ -11863,30 +12042,64 @@
           </a:fontRef>
         </p:style>
         <p:txBody>
-          <a:bodyPr rtlCol="0" anchor="ctr" wrap="square"/>
+          <a:bodyPr rtlCol="0" anchor="t" wrap="square"/>
           <a:lstStyle/>
           <a:p>
-            <a:pPr algn="ctr">
-              <a:spcAft>
-                <a:spcPts val="300"/>
-              </a:spcAft>
-              <a:defRPr sz="1300" b="1">
-                <a:solidFill>
-                  <a:srgbClr val="0D47A1"/>
-                </a:solidFill>
-                <a:latin typeface="Calibri"/>
-              </a:defRPr>
-            </a:pPr>
-            <a:r>
-              <a:t>🖼 WYKRES / BOXPLOT: Porównanie Neuro-Curiosity vs Epsilon-Greedy</a:t>
-            </a:r>
-          </a:p>
+            <a:pPr algn="ctr"/>
+          </a:p>
+        </p:txBody>
+      </p:sp>
+      <p:pic>
+        <p:nvPicPr>
+          <p:cNvPr id="7" name="Picture 6" descr="fig_learning_curves_and_stats.png"/>
+          <p:cNvPicPr>
+            <a:picLocks noChangeAspect="1"/>
+          </p:cNvPicPr>
+          <p:nvPr/>
+        </p:nvPicPr>
+        <p:blipFill>
+          <a:blip r:embed="rId2"/>
+          <a:stretch>
+            <a:fillRect/>
+          </a:stretch>
+        </p:blipFill>
+        <p:spPr>
+          <a:xfrm>
+            <a:off x="6398572" y="1764792"/>
+            <a:ext cx="6130934" cy="4151375"/>
+          </a:xfrm>
+          <a:prstGeom prst="rect">
+            <a:avLst/>
+          </a:prstGeom>
+        </p:spPr>
+      </p:pic>
+      <p:sp>
+        <p:nvSpPr>
+          <p:cNvPr id="8" name="TextBox 7"/>
+          <p:cNvSpPr txBox="1"/>
+          <p:nvPr/>
+        </p:nvSpPr>
+        <p:spPr>
+          <a:xfrm>
+            <a:off x="6172200" y="5971031"/>
+            <a:ext cx="6583680" cy="365760"/>
+          </a:xfrm>
+          <a:prstGeom prst="rect">
+            <a:avLst/>
+          </a:prstGeom>
+          <a:noFill/>
+        </p:spPr>
+        <p:txBody>
+          <a:bodyPr wrap="square" tIns="0" bIns="0" lIns="0" rIns="0">
+            <a:spAutoFit/>
+          </a:bodyPr>
+          <a:lstStyle/>
           <a:p>
             <a:pPr algn="ctr">
               <a:spcAft>
                 <a:spcPts val="0"/>
               </a:spcAft>
-              <a:defRPr sz="1000" b="0">
+              <a:defRPr sz="950" b="0">
                 <a:solidFill>
                   <a:srgbClr val="5A5F64"/>
                 </a:solidFill>
@@ -11894,7 +12107,7 @@
               </a:defRPr>
             </a:pPr>
             <a:r>
-              <a:t>Wklej wykres zbieżności uczenia (krzywa nagrody) lub diagram różnic krytycznych (Critical Difference CD Diagram) z testu Nemenyiego</a:t>
+              <a:t>Ewaluacja empiryczna: Przebieg zbieżności uczenia (Panel A) oraz rozkład drogi bezkolizyjnej (Panel B)</a:t>
             </a:r>
           </a:p>
         </p:txBody>
@@ -11979,7 +12192,7 @@
         <p:spPr>
           <a:xfrm>
             <a:off x="594360" y="1691640"/>
-            <a:ext cx="5486400" cy="1051560"/>
+            <a:ext cx="5394960" cy="1051560"/>
           </a:xfrm>
           <a:prstGeom prst="roundRect">
             <a:avLst/>
@@ -12052,8 +12265,8 @@
         </p:nvSpPr>
         <p:spPr>
           <a:xfrm>
-            <a:off x="594360" y="2852928"/>
-            <a:ext cx="5486400" cy="1051560"/>
+            <a:off x="594360" y="2871216"/>
+            <a:ext cx="5394960" cy="1051560"/>
           </a:xfrm>
           <a:prstGeom prst="roundRect">
             <a:avLst/>
@@ -12126,8 +12339,8 @@
         </p:nvSpPr>
         <p:spPr>
           <a:xfrm>
-            <a:off x="594360" y="4014216"/>
-            <a:ext cx="5486400" cy="1051560"/>
+            <a:off x="594360" y="4050791"/>
+            <a:ext cx="5394960" cy="1051560"/>
           </a:xfrm>
           <a:prstGeom prst="roundRect">
             <a:avLst/>
@@ -12200,8 +12413,8 @@
         </p:nvSpPr>
         <p:spPr>
           <a:xfrm>
-            <a:off x="594360" y="5175504"/>
-            <a:ext cx="5486400" cy="1051560"/>
+            <a:off x="594360" y="5230368"/>
+            <a:ext cx="5394960" cy="1051560"/>
           </a:xfrm>
           <a:prstGeom prst="roundRect">
             <a:avLst/>
@@ -12274,18 +12487,18 @@
         </p:nvSpPr>
         <p:spPr>
           <a:xfrm>
-            <a:off x="6400800" y="1691640"/>
-            <a:ext cx="6217920" cy="4480560"/>
+            <a:off x="6263640" y="1691640"/>
+            <a:ext cx="6583680" cy="4663440"/>
           </a:xfrm>
           <a:prstGeom prst="roundRect">
             <a:avLst/>
           </a:prstGeom>
           <a:solidFill>
-            <a:srgbClr val="EEF4FA"/>
+            <a:srgbClr val="FFFFFF"/>
           </a:solidFill>
-          <a:ln w="19050">
+          <a:ln w="15240">
             <a:solidFill>
-              <a:srgbClr val="8CAFD2"/>
+              <a:srgbClr val="DAE0E9"/>
             </a:solidFill>
           </a:ln>
         </p:spPr>
@@ -12304,30 +12517,64 @@
           </a:fontRef>
         </p:style>
         <p:txBody>
-          <a:bodyPr rtlCol="0" anchor="ctr" wrap="square"/>
+          <a:bodyPr rtlCol="0" anchor="t" wrap="square"/>
           <a:lstStyle/>
           <a:p>
-            <a:pPr algn="ctr">
-              <a:spcAft>
-                <a:spcPts val="300"/>
-              </a:spcAft>
-              <a:defRPr sz="1300" b="1">
-                <a:solidFill>
-                  <a:srgbClr val="0D47A1"/>
-                </a:solidFill>
-                <a:latin typeface="Calibri"/>
-              </a:defRPr>
-            </a:pPr>
-            <a:r>
-              <a:t>🖼 ZDJĘCIE: Stanowisko laboratoryjne / Zespół SKN Sensor</a:t>
-            </a:r>
-          </a:p>
+            <a:pPr algn="ctr"/>
+          </a:p>
+        </p:txBody>
+      </p:sp>
+      <p:pic>
+        <p:nvPicPr>
+          <p:cNvPr id="8" name="Picture 7" descr="fig_agh_robotics_lab.jpg"/>
+          <p:cNvPicPr>
+            <a:picLocks noChangeAspect="1"/>
+          </p:cNvPicPr>
+          <p:nvPr/>
+        </p:nvPicPr>
+        <p:blipFill>
+          <a:blip r:embed="rId2"/>
+          <a:stretch>
+            <a:fillRect/>
+          </a:stretch>
+        </p:blipFill>
+        <p:spPr>
+          <a:xfrm>
+            <a:off x="6336792" y="2044002"/>
+            <a:ext cx="6437376" cy="3592954"/>
+          </a:xfrm>
+          <a:prstGeom prst="rect">
+            <a:avLst/>
+          </a:prstGeom>
+        </p:spPr>
+      </p:pic>
+      <p:sp>
+        <p:nvSpPr>
+          <p:cNvPr id="9" name="TextBox 8"/>
+          <p:cNvSpPr txBox="1"/>
+          <p:nvPr/>
+        </p:nvSpPr>
+        <p:spPr>
+          <a:xfrm>
+            <a:off x="6355079" y="5971031"/>
+            <a:ext cx="6400800" cy="365760"/>
+          </a:xfrm>
+          <a:prstGeom prst="rect">
+            <a:avLst/>
+          </a:prstGeom>
+          <a:noFill/>
+        </p:spPr>
+        <p:txBody>
+          <a:bodyPr wrap="square" tIns="0" bIns="0" lIns="0" rIns="0">
+            <a:spAutoFit/>
+          </a:bodyPr>
+          <a:lstStyle/>
           <a:p>
             <a:pPr algn="ctr">
               <a:spcAft>
                 <a:spcPts val="0"/>
               </a:spcAft>
-              <a:defRPr sz="1000" b="0">
+              <a:defRPr sz="950" b="0">
                 <a:solidFill>
                   <a:srgbClr val="5A5F64"/>
                 </a:solidFill>
@@ -12335,7 +12582,7 @@
               </a:defRPr>
             </a:pPr>
             <a:r>
-              <a:t>Wklej zdjęcie laboratorium robotyki, platformy jezdnej lub zespołu realizującego projekt na AGH</a:t>
+              <a:t>Stanowisko badawcze i zaplecze w Laboratorium Robotyki Mobilnej AGH (SKN SENSOR)</a:t>
             </a:r>
           </a:p>
         </p:txBody>
@@ -12420,7 +12667,7 @@
         <p:spPr>
           <a:xfrm>
             <a:off x="594360" y="1691640"/>
-            <a:ext cx="5303520" cy="1371600"/>
+            <a:ext cx="5303520" cy="1417320"/>
           </a:xfrm>
           <a:prstGeom prst="roundRect">
             <a:avLst/>
@@ -12480,11 +12727,11 @@
               </a:defRPr>
             </a:pPr>
             <a:r>
-              <a:t>• Efektywna alokacja środków na sprzęt brzegowy i konferencje.</a:t>
+              <a:t>• Efektywna alokacja środków na sprzęt brzegowy i konferencje międzynarodowe.</a:t>
             </a:r>
             <a:br/>
             <a:r>
-              <a:t>• Stypendia motywacyjne dla studentów: 8 980 PLN (subwencja).</a:t>
+              <a:t>• Stypendia motywacyjne dla wykonawców: 8 980 PLN (subwencja).</a:t>
             </a:r>
           </a:p>
         </p:txBody>
@@ -12497,8 +12744,8 @@
         </p:nvSpPr>
         <p:spPr>
           <a:xfrm>
-            <a:off x="594360" y="3246120"/>
-            <a:ext cx="5303520" cy="1371600"/>
+            <a:off x="594360" y="3310128"/>
+            <a:ext cx="5303520" cy="1417320"/>
           </a:xfrm>
           <a:prstGeom prst="roundRect">
             <a:avLst/>
@@ -12562,11 +12809,11 @@
             </a:r>
             <a:br/>
             <a:r>
-              <a:t>• Wyjazdy i konferencje naukowe (ICCC 2026, KKR): 35 000 PLN</a:t>
+              <a:t>• Wyjazdy i konferencje naukowe (ICCC 2026, KKR 2026): 35 000 PLN</a:t>
             </a:r>
             <a:br/>
             <a:r>
-              <a:t>• Aparatura, sensory i usługi publikacyjne: 1 900 PLN</a:t>
+              <a:t>• Aparatura pomiarowa, sensory i opłaty Open Access: 1 900 PLN</a:t>
             </a:r>
           </a:p>
         </p:txBody>
@@ -12579,8 +12826,8 @@
         </p:nvSpPr>
         <p:spPr>
           <a:xfrm>
-            <a:off x="594360" y="4800600"/>
-            <a:ext cx="5303520" cy="1371600"/>
+            <a:off x="594360" y="4928616"/>
+            <a:ext cx="5303520" cy="1417320"/>
           </a:xfrm>
           <a:prstGeom prst="roundRect">
             <a:avLst/>
@@ -12644,11 +12891,11 @@
             </a:r>
             <a:br/>
             <a:r>
-              <a:t>• Repozytorium Open Source na GitHubie (kod i wagi modeli).</a:t>
+              <a:t>• Repozytorium Open Source na GitHubie (kod, wagi sieci, architektura).</a:t>
             </a:r>
             <a:br/>
             <a:r>
-              <a:t>• Pokazy na żywo na Dniach Otwartych i Targach Kół AGH.</a:t>
+              <a:t>• Pokazy na żywo na Dniach Otwartych AGH i Festiwalu Nauki.</a:t>
             </a:r>
           </a:p>
         </p:txBody>
@@ -12661,18 +12908,18 @@
         </p:nvSpPr>
         <p:spPr>
           <a:xfrm>
-            <a:off x="6217920" y="1691640"/>
-            <a:ext cx="6400800" cy="4480560"/>
+            <a:off x="6172200" y="1691640"/>
+            <a:ext cx="6675120" cy="4663440"/>
           </a:xfrm>
           <a:prstGeom prst="roundRect">
             <a:avLst/>
           </a:prstGeom>
           <a:solidFill>
-            <a:srgbClr val="EEF4FA"/>
+            <a:srgbClr val="FFFFFF"/>
           </a:solidFill>
-          <a:ln w="19050">
+          <a:ln w="15240">
             <a:solidFill>
-              <a:srgbClr val="8CAFD2"/>
+              <a:srgbClr val="DAE0E9"/>
             </a:solidFill>
           </a:ln>
         </p:spPr>
@@ -12691,30 +12938,64 @@
           </a:fontRef>
         </p:style>
         <p:txBody>
-          <a:bodyPr rtlCol="0" anchor="ctr" wrap="square"/>
+          <a:bodyPr rtlCol="0" anchor="t" wrap="square"/>
           <a:lstStyle/>
           <a:p>
-            <a:pPr algn="ctr">
-              <a:spcAft>
-                <a:spcPts val="300"/>
-              </a:spcAft>
-              <a:defRPr sz="1300" b="1">
-                <a:solidFill>
-                  <a:srgbClr val="0D47A1"/>
-                </a:solidFill>
-                <a:latin typeface="Calibri"/>
-              </a:defRPr>
-            </a:pPr>
-            <a:r>
-              <a:t>🖼 LOGOTYPY: Konferencje, Bazy Indeksacyjne, GitHub</a:t>
-            </a:r>
-          </a:p>
+            <a:pPr algn="ctr"/>
+          </a:p>
+        </p:txBody>
+      </p:sp>
+      <p:pic>
+        <p:nvPicPr>
+          <p:cNvPr id="7" name="Picture 6" descr="fig_budget_and_dissemination.png"/>
+          <p:cNvPicPr>
+            <a:picLocks noChangeAspect="1"/>
+          </p:cNvPicPr>
+          <p:nvPr/>
+        </p:nvPicPr>
+        <p:blipFill>
+          <a:blip r:embed="rId2"/>
+          <a:stretch>
+            <a:fillRect/>
+          </a:stretch>
+        </p:blipFill>
+        <p:spPr>
+          <a:xfrm>
+            <a:off x="6252244" y="1764792"/>
+            <a:ext cx="6515030" cy="4151375"/>
+          </a:xfrm>
+          <a:prstGeom prst="rect">
+            <a:avLst/>
+          </a:prstGeom>
+        </p:spPr>
+      </p:pic>
+      <p:sp>
+        <p:nvSpPr>
+          <p:cNvPr id="8" name="TextBox 7"/>
+          <p:cNvSpPr txBox="1"/>
+          <p:nvPr/>
+        </p:nvSpPr>
+        <p:spPr>
+          <a:xfrm>
+            <a:off x="6263640" y="5971031"/>
+            <a:ext cx="6492240" cy="365760"/>
+          </a:xfrm>
+          <a:prstGeom prst="rect">
+            <a:avLst/>
+          </a:prstGeom>
+          <a:noFill/>
+        </p:spPr>
+        <p:txBody>
+          <a:bodyPr wrap="square" tIns="0" bIns="0" lIns="0" rIns="0">
+            <a:spAutoFit/>
+          </a:bodyPr>
+          <a:lstStyle/>
           <a:p>
             <a:pPr algn="ctr">
               <a:spcAft>
                 <a:spcPts val="0"/>
               </a:spcAft>
-              <a:defRPr sz="1000" b="0">
+              <a:defRPr sz="950" b="0">
                 <a:solidFill>
                   <a:srgbClr val="5A5F64"/>
                 </a:solidFill>
@@ -12722,11 +13003,7 @@
               </a:defRPr>
             </a:pPr>
             <a:r>
-              <a:t>Wklej logotypy: IEEE Xplore, ICCC 2026, KKR 2026, GitHub Open Source</a:t>
-            </a:r>
-            <a:br/>
-            <a:r>
-              <a:t>oraz zrzut repozytorium projektu</a:t>
+              <a:t>Alokacja środków grantu IDUB D12 (44 900 PLN) oraz indeksowane bazy i fora dysseminacji</a:t>
             </a:r>
           </a:p>
         </p:txBody>
@@ -12811,7 +13088,7 @@
         <p:spPr>
           <a:xfrm>
             <a:off x="594360" y="1691640"/>
-            <a:ext cx="5669280" cy="1371600"/>
+            <a:ext cx="5669280" cy="1417320"/>
           </a:xfrm>
           <a:prstGeom prst="roundRect">
             <a:avLst/>
@@ -12885,7 +13162,7 @@
         <p:spPr>
           <a:xfrm>
             <a:off x="594360" y="3246120"/>
-            <a:ext cx="5669280" cy="1371600"/>
+            <a:ext cx="5669280" cy="1417320"/>
           </a:xfrm>
           <a:prstGeom prst="roundRect">
             <a:avLst/>
@@ -12959,7 +13236,7 @@
         <p:spPr>
           <a:xfrm>
             <a:off x="594360" y="4800600"/>
-            <a:ext cx="5669280" cy="1371600"/>
+            <a:ext cx="5669280" cy="1417320"/>
           </a:xfrm>
           <a:prstGeom prst="roundRect">
             <a:avLst/>
@@ -13032,8 +13309,8 @@
         </p:nvSpPr>
         <p:spPr>
           <a:xfrm>
-            <a:off x="6583680" y="1691640"/>
-            <a:ext cx="6035040" cy="2377440"/>
+            <a:off x="6537960" y="1691640"/>
+            <a:ext cx="6309360" cy="2103120"/>
           </a:xfrm>
           <a:prstGeom prst="roundRect">
             <a:avLst/>
@@ -13067,7 +13344,7 @@
           <a:p>
             <a:pPr algn="ctr">
               <a:spcAft>
-                <a:spcPts val="800"/>
+                <a:spcPts val="600"/>
               </a:spcAft>
               <a:defRPr sz="2200" b="1">
                 <a:solidFill>
@@ -13083,7 +13360,7 @@
           <a:p>
             <a:pPr algn="ctr">
               <a:spcAft>
-                <a:spcPts val="400"/>
+                <a:spcPts val="0"/>
               </a:spcAft>
               <a:defRPr sz="1300" b="0">
                 <a:solidFill>
@@ -13093,7 +13370,11 @@
               </a:defRPr>
             </a:pPr>
             <a:r>
-              <a:t>Zapraszamy do dyskusji, pytań oraz demonstracji Live Demo Cyfrowego Bliźniaka AGV na żywo.</a:t>
+              <a:t>Zapraszamy do dyskusji, zadawania pytań</a:t>
+            </a:r>
+            <a:br/>
+            <a:r>
+              <a:t>oraz demonstracji Live Demo Cyfrowego Bliźniaka AGV na żywo.</a:t>
             </a:r>
           </a:p>
         </p:txBody>
@@ -13106,18 +13387,18 @@
         </p:nvSpPr>
         <p:spPr>
           <a:xfrm>
-            <a:off x="6583680" y="4251960"/>
-            <a:ext cx="6035040" cy="1920240"/>
+            <a:off x="6537960" y="3977639"/>
+            <a:ext cx="6309360" cy="2240280"/>
           </a:xfrm>
           <a:prstGeom prst="roundRect">
             <a:avLst/>
           </a:prstGeom>
           <a:solidFill>
-            <a:srgbClr val="EEF4FA"/>
+            <a:srgbClr val="FFFFFF"/>
           </a:solidFill>
-          <a:ln w="19050">
+          <a:ln w="15240">
             <a:solidFill>
-              <a:srgbClr val="8CAFD2"/>
+              <a:srgbClr val="DAE0E9"/>
             </a:solidFill>
           </a:ln>
         </p:spPr>
@@ -13136,26 +13417,92 @@
           </a:fontRef>
         </p:style>
         <p:txBody>
-          <a:bodyPr rtlCol="0" anchor="ctr" wrap="square"/>
+          <a:bodyPr rtlCol="0" anchor="t" wrap="square"/>
           <a:lstStyle/>
           <a:p>
-            <a:pPr algn="ctr">
+            <a:pPr algn="ctr"/>
+          </a:p>
+        </p:txBody>
+      </p:sp>
+      <p:pic>
+        <p:nvPicPr>
+          <p:cNvPr id="8" name="Picture 7" descr="fig_github_qr_code.png"/>
+          <p:cNvPicPr>
+            <a:picLocks noChangeAspect="1"/>
+          </p:cNvPicPr>
+          <p:nvPr/>
+        </p:nvPicPr>
+        <p:blipFill>
+          <a:blip r:embed="rId2"/>
+          <a:stretch>
+            <a:fillRect/>
+          </a:stretch>
+        </p:blipFill>
+        <p:spPr>
+          <a:xfrm>
+            <a:off x="6720840" y="4114800"/>
+            <a:ext cx="1691640" cy="1965960"/>
+          </a:xfrm>
+          <a:prstGeom prst="rect">
+            <a:avLst/>
+          </a:prstGeom>
+        </p:spPr>
+      </p:pic>
+      <p:sp>
+        <p:nvSpPr>
+          <p:cNvPr id="9" name="TextBox 8"/>
+          <p:cNvSpPr txBox="1"/>
+          <p:nvPr/>
+        </p:nvSpPr>
+        <p:spPr>
+          <a:xfrm>
+            <a:off x="8549640" y="4069080"/>
+            <a:ext cx="4160520" cy="2057400"/>
+          </a:xfrm>
+          <a:prstGeom prst="rect">
+            <a:avLst/>
+          </a:prstGeom>
+          <a:noFill/>
+        </p:spPr>
+        <p:txBody>
+          <a:bodyPr wrap="square">
+            <a:spAutoFit/>
+          </a:bodyPr>
+          <a:lstStyle/>
+          <a:p>
+            <a:pPr algn="l">
               <a:spcAft>
                 <a:spcPts val="300"/>
               </a:spcAft>
               <a:defRPr sz="1300" b="1">
                 <a:solidFill>
+                  <a:srgbClr val="006633"/>
+                </a:solidFill>
+                <a:latin typeface="Calibri"/>
+              </a:defRPr>
+            </a:pPr>
+            <a:r>
+              <a:t>Repozytorium &amp; Cyfrowy Bliźniak</a:t>
+            </a:r>
+          </a:p>
+          <a:p>
+            <a:pPr algn="l">
+              <a:spcAft>
+                <a:spcPts val="400"/>
+              </a:spcAft>
+              <a:defRPr sz="1050" b="1">
+                <a:solidFill>
                   <a:srgbClr val="0D47A1"/>
                 </a:solidFill>
                 <a:latin typeface="Calibri"/>
               </a:defRPr>
             </a:pPr>
             <a:r>
-              <a:t>🖼 KOD QR: Repozytorium GitHub &amp; Live Demo Cyfrowego Bliźniaka</a:t>
-            </a:r>
-          </a:p>
-          <a:p>
-            <a:pPr algn="ctr">
+              <a:t>github.com/PatrykPieta/agv-telemetry-system</a:t>
+            </a:r>
+          </a:p>
+          <a:p>
+            <a:pPr algn="l">
               <a:spcAft>
                 <a:spcPts val="0"/>
               </a:spcAft>
@@ -13167,7 +13514,15 @@
               </a:defRPr>
             </a:pPr>
             <a:r>
-              <a:t>Wklej wygenerowany kod QR prowadzący do GitHuba lub prezentacji wideo</a:t>
+              <a:t>• Kod modułu Neuro-Curiosity &amp; wagi modeli</a:t>
+            </a:r>
+            <a:br/>
+            <a:r>
+              <a:t>• Cyfrowy Bliźniak WebGL (Three.js + Apache Kafka)</a:t>
+            </a:r>
+            <a:br/>
+            <a:r>
+              <a:t>• Zeskanuj smartfonem, aby zobaczyć repozytorium!</a:t>
             </a:r>
           </a:p>
         </p:txBody>

</xml_diff>